<commit_message>
Fix Jobcenter UTF-8 generation without internal npm calls
</commit_message>
<xml_diff>
--- a/uaos-ai-factory/jobcenter-send-ready/UAOS_JOBCENTER_PRESENTATION_2026-07-01_DE.pptx
+++ b/uaos-ai-factory/jobcenter-send-ready/UAOS_JOBCENTER_PRESENTATION_2026-07-01_DE.pptx
@@ -1,14 +1,14 @@
 
 <file path=docProps\app.xml><?xml version="1.0" encoding="utf-8"?>
 <Properties xmlns="http://schemas.openxmlformats.org/officeDocument/2006/extended-properties">
-  <Application>UAOS Local PPT Generator</Application>
+  <Application>UAOS Jobcenter UTF-8 Generator</Application>
   <Slides>4</Slides>
 </Properties>
 </file>
 
 <file path=docProps\core.xml><?xml version="1.0" encoding="utf-8"?>
 <cp:coreProperties xmlns:cp="http://schemas.openxmlformats.org/package/2006/metadata/core-properties" xmlns:dc="http://purl.org/dc/elements/1.1/">
-  <dc:title>UAOS Jobcenter Evidence Pack DE</dc:title>
+  <dc:title>UAOS Jobcenter Präsentation</dc:title>
   <dc:creator>UAOS Local</dc:creator>
 </cp:coreProperties>
 </file>
@@ -63,8 +63,8 @@
           <a:lstStyle/>
           <a:p>
             <a:r>
-              <a:rPr lang="en-US" sz="3400" b="1"/>
-              <a:t>UAOS Jobcenter Evidence Pack DE</a:t>
+              <a:rPr lang="de-DE" sz="3300" b="1"/>
+              <a:t>UAOS Jobcenter Businessplan</a:t>
             </a:r>
           </a:p>
         </p:txBody>
@@ -88,39 +88,39 @@
           <a:bodyPr wrap="square"/>
           <a:lstStyle/>
           <a:p>
-            <a:pPr marL="0" indent="0">
-              <a:buChar char="•"/>
-            </a:pPr>
-            <a:r>
-              <a:rPr lang="en-US" sz="2200"/>
-              <a:t>LOCAL ONLY</a:t>
-            </a:r>
-          </a:p>
-          <a:p>
-            <a:pPr marL="342900" indent="0">
-              <a:buChar char="•"/>
-            </a:pPr>
-            <a:r>
-              <a:rPr lang="en-US" sz="2200"/>
-              <a:t>READ ONLY</a:t>
-            </a:r>
-          </a:p>
-          <a:p>
-            <a:pPr marL="342900" indent="0">
-              <a:buChar char="•"/>
-            </a:pPr>
-            <a:r>
-              <a:rPr lang="en-US" sz="2200"/>
-              <a:t>NOT PUBLIC RELEASE</a:t>
-            </a:r>
-          </a:p>
-          <a:p>
-            <a:pPr marL="342900" indent="0">
-              <a:buChar char="•"/>
-            </a:pPr>
-            <a:r>
-              <a:rPr lang="en-US" sz="2200"/>
-              <a:t>NOT KEYBOARD OUTPUT</a:t>
+            <a:pPr marL="342900" indent="0">
+              <a:buChar char="•"/>
+            </a:pPr>
+            <a:r>
+              <a:rPr lang="de-DE" sz="2200"/>
+              <a:t>Datum: 01.07.2026</a:t>
+            </a:r>
+          </a:p>
+          <a:p>
+            <a:pPr marL="342900" indent="0">
+              <a:buChar char="•"/>
+            </a:pPr>
+            <a:r>
+              <a:rPr lang="de-DE" sz="2200"/>
+              <a:t>Jobcenter-only</a:t>
+            </a:r>
+          </a:p>
+          <a:p>
+            <a:pPr marL="342900" indent="0">
+              <a:buChar char="•"/>
+            </a:pPr>
+            <a:r>
+              <a:rPr lang="de-DE" sz="2200"/>
+              <a:t>Lokaler privater Prototyp</a:t>
+            </a:r>
+          </a:p>
+          <a:p>
+            <a:pPr marL="342900" indent="0">
+              <a:buChar char="•"/>
+            </a:pPr>
+            <a:r>
+              <a:rPr lang="de-DE" sz="2200"/>
+              <a:t>Nicht öffentlich live</a:t>
             </a:r>
           </a:p>
         </p:txBody>
@@ -145,8 +145,8 @@
           <a:lstStyle/>
           <a:p>
             <a:r>
-              <a:rPr lang="en-US" sz="1200"/>
-              <a:t>LOCAL ONLY - NOT KEYBOARD OUTPUT - NO PUSH / NO DEPLOY / NO VERCEL</a:t>
+              <a:rPr lang="de-DE" sz="1200"/>
+              <a:t>LOCAL ONLY - JOBCENTER ONLY - NOT KEYBOARD OUTPUT</a:t>
             </a:r>
           </a:p>
         </p:txBody>
@@ -196,8 +196,8 @@
           <a:lstStyle/>
           <a:p>
             <a:r>
-              <a:rPr lang="en-US" sz="3400" b="1"/>
-              <a:t>Safety Boundaries</a:t>
+              <a:rPr lang="de-DE" sz="3300" b="1"/>
+              <a:t>Aktueller Projektstand</a:t>
             </a:r>
           </a:p>
         </p:txBody>
@@ -221,66 +221,57 @@
           <a:bodyPr wrap="square"/>
           <a:lstStyle/>
           <a:p>
-            <a:pPr marL="0" indent="0">
-              <a:buChar char="•"/>
-            </a:pPr>
-            <a:r>
-              <a:rPr lang="en-US" sz="2200"/>
-              <a:t>no public release</a:t>
-            </a:r>
-          </a:p>
-          <a:p>
-            <a:pPr marL="342900" indent="0">
-              <a:buChar char="•"/>
-            </a:pPr>
-            <a:r>
-              <a:rPr lang="en-US" sz="2200"/>
-              <a:t>no payment</a:t>
-            </a:r>
-          </a:p>
-          <a:p>
-            <a:pPr marL="342900" indent="0">
-              <a:buChar char="•"/>
-            </a:pPr>
-            <a:r>
-              <a:rPr lang="en-US" sz="2200"/>
-              <a:t>no keyboard-native output</a:t>
-            </a:r>
-          </a:p>
-          <a:p>
-            <a:pPr marL="342900" indent="0">
-              <a:buChar char="•"/>
-            </a:pPr>
-            <a:r>
-              <a:rPr lang="en-US" sz="2200"/>
-              <a:t>no keyboard transfer</a:t>
-            </a:r>
-          </a:p>
-          <a:p>
-            <a:pPr marL="342900" indent="0">
-              <a:buChar char="•"/>
-            </a:pPr>
-            <a:r>
-              <a:rPr lang="en-US" sz="2200"/>
-              <a:t>no deploy</a:t>
-            </a:r>
-          </a:p>
-          <a:p>
-            <a:pPr marL="342900" indent="0">
-              <a:buChar char="•"/>
-            </a:pPr>
-            <a:r>
-              <a:rPr lang="en-US" sz="2200"/>
-              <a:t>no Vercel</a:t>
-            </a:r>
-          </a:p>
-          <a:p>
-            <a:pPr marL="342900" indent="0">
-              <a:buChar char="•"/>
-            </a:pPr>
-            <a:r>
-              <a:rPr lang="en-US" sz="2200"/>
-              <a:t>no proprietary content</a:t>
+            <a:pPr marL="342900" indent="0">
+              <a:buChar char="•"/>
+            </a:pPr>
+            <a:r>
+              <a:rPr lang="de-DE" sz="2200"/>
+              <a:t>Lokaler Prototyp: vorhanden.</a:t>
+            </a:r>
+          </a:p>
+          <a:p>
+            <a:pPr marL="342900" indent="0">
+              <a:buChar char="•"/>
+            </a:pPr>
+            <a:r>
+              <a:rPr lang="de-DE" sz="2200"/>
+              <a:t>Aktueller lokaler Projektstand: vorhanden.</a:t>
+            </a:r>
+          </a:p>
+          <a:p>
+            <a:pPr marL="342900" indent="0">
+              <a:buChar char="•"/>
+            </a:pPr>
+            <a:r>
+              <a:rPr lang="de-DE" sz="2200"/>
+              <a:t>Evidence-Pack: vorbereitet und lokal pruefbar.</a:t>
+            </a:r>
+          </a:p>
+          <a:p>
+            <a:pPr marL="342900" indent="0">
+              <a:buChar char="•"/>
+            </a:pPr>
+            <a:r>
+              <a:rPr lang="de-DE" sz="2200"/>
+              <a:t>Ausgewaehltes Review-Paket: owner-neutral-003.</a:t>
+            </a:r>
+          </a:p>
+          <a:p>
+            <a:pPr marL="342900" indent="0">
+              <a:buChar char="•"/>
+            </a:pPr>
+            <a:r>
+              <a:rPr lang="de-DE" sz="2200"/>
+              <a:t>Keyboard Writer: blockiert.</a:t>
+            </a:r>
+          </a:p>
+          <a:p>
+            <a:pPr marL="342900" indent="0">
+              <a:buChar char="•"/>
+            </a:pPr>
+            <a:r>
+              <a:rPr lang="de-DE" sz="2200"/>
+              <a:t>Kein finales Keyboard-Nativformat.</a:t>
             </a:r>
           </a:p>
         </p:txBody>
@@ -305,8 +296,8 @@
           <a:lstStyle/>
           <a:p>
             <a:r>
-              <a:rPr lang="en-US" sz="1200"/>
-              <a:t>LOCAL ONLY - NOT KEYBOARD OUTPUT - NO PUSH / NO DEPLOY / NO VERCEL</a:t>
+              <a:rPr lang="de-DE" sz="1200"/>
+              <a:t>LOCAL ONLY - JOBCENTER ONLY - NOT KEYBOARD OUTPUT</a:t>
             </a:r>
           </a:p>
         </p:txBody>
@@ -356,8 +347,8 @@
           <a:lstStyle/>
           <a:p>
             <a:r>
-              <a:rPr lang="en-US" sz="3400" b="1"/>
-              <a:t>Review Evidence</a:t>
+              <a:rPr lang="de-DE" sz="3300" b="1"/>
+              <a:t>Projekt-Monitor</a:t>
             </a:r>
           </a:p>
         </p:txBody>
@@ -381,66 +372,30 @@
           <a:bodyPr wrap="square"/>
           <a:lstStyle/>
           <a:p>
-            <a:pPr marL="0" indent="0">
-              <a:buChar char="•"/>
-            </a:pPr>
-            <a:r>
-              <a:rPr lang="en-US" sz="2200"/>
-              <a:t>Lokaler Prototyp: vorhanden.</a:t>
-            </a:r>
-          </a:p>
-          <a:p>
-            <a:pPr marL="342900" indent="0">
-              <a:buChar char="•"/>
-            </a:pPr>
-            <a:r>
-              <a:rPr lang="en-US" sz="2200"/>
-              <a:t>Aktueller lokaler Projektstand: vorhanden.</a:t>
-            </a:r>
-          </a:p>
-          <a:p>
-            <a:pPr marL="342900" indent="0">
-              <a:buChar char="•"/>
-            </a:pPr>
-            <a:r>
-              <a:rPr lang="en-US" sz="2200"/>
-              <a:t>Evidence-Pack: vorbereitet und lokal pruefbar.</a:t>
-            </a:r>
-          </a:p>
-          <a:p>
-            <a:pPr marL="342900" indent="0">
-              <a:buChar char="•"/>
-            </a:pPr>
-            <a:r>
-              <a:rPr lang="en-US" sz="2200"/>
-              <a:t>Ausgewaehltes Review-Paket: owner-neutral-003.</a:t>
-            </a:r>
-          </a:p>
-          <a:p>
-            <a:pPr marL="342900" indent="0">
-              <a:buChar char="•"/>
-            </a:pPr>
-            <a:r>
-              <a:rPr lang="en-US" sz="2200"/>
-              <a:t>Keyboard Writer: blockiert.</a:t>
-            </a:r>
-          </a:p>
-          <a:p>
-            <a:pPr marL="342900" indent="0">
-              <a:buChar char="•"/>
-            </a:pPr>
-            <a:r>
-              <a:rPr lang="en-US" sz="2200"/>
-              <a:t>Kein finales Keyboard-Nativformat.</a:t>
-            </a:r>
-          </a:p>
-          <a:p>
-            <a:pPr marL="342900" indent="0">
-              <a:buChar char="•"/>
-            </a:pPr>
-            <a:r>
-              <a:rPr lang="en-US" sz="2200"/>
-              <a:t>Keyboard-native Ausgabe: blockiert.</a:t>
+            <a:pPr marL="342900" indent="0">
+              <a:buChar char="•"/>
+            </a:pPr>
+            <a:r>
+              <a:rPr lang="de-DE" sz="2200"/>
+              <a:t>wird nach Freigabe des Uploads aktiviert</a:t>
+            </a:r>
+          </a:p>
+          <a:p>
+            <a:pPr marL="342900" indent="0">
+              <a:buChar char="•"/>
+            </a:pPr>
+            <a:r>
+              <a:rPr lang="de-DE" sz="2200"/>
+              <a:t>Der Link ist derzeit noch nicht öffentlich live</a:t>
+            </a:r>
+          </a:p>
+          <a:p>
+            <a:pPr marL="342900" indent="0">
+              <a:buChar char="•"/>
+            </a:pPr>
+            <a:r>
+              <a:rPr lang="de-DE" sz="2200"/>
+              <a:t>Kein Upload, kein Push und kein Deploy freigegeben</a:t>
             </a:r>
           </a:p>
         </p:txBody>
@@ -465,8 +420,8 @@
           <a:lstStyle/>
           <a:p>
             <a:r>
-              <a:rPr lang="en-US" sz="1200"/>
-              <a:t>LOCAL ONLY - NOT KEYBOARD OUTPUT - NO PUSH / NO DEPLOY / NO VERCEL</a:t>
+              <a:rPr lang="de-DE" sz="1200"/>
+              <a:t>LOCAL ONLY - JOBCENTER ONLY - NOT KEYBOARD OUTPUT</a:t>
             </a:r>
           </a:p>
         </p:txBody>
@@ -516,8 +471,8 @@
           <a:lstStyle/>
           <a:p>
             <a:r>
-              <a:rPr lang="en-US" sz="3400" b="1"/>
-              <a:t>Manual Review State</a:t>
+              <a:rPr lang="de-DE" sz="3300" b="1"/>
+              <a:t>Sicherheitsgrenzen</a:t>
             </a:r>
           </a:p>
         </p:txBody>
@@ -541,48 +496,48 @@
           <a:bodyPr wrap="square"/>
           <a:lstStyle/>
           <a:p>
-            <a:pPr marL="0" indent="0">
-              <a:buChar char="•"/>
-            </a:pPr>
-            <a:r>
-              <a:rPr lang="en-US" sz="2200"/>
-              <a:t>PowerPoint created locally only</a:t>
-            </a:r>
-          </a:p>
-          <a:p>
-            <a:pPr marL="342900" indent="0">
-              <a:buChar char="•"/>
-            </a:pPr>
-            <a:r>
-              <a:rPr lang="en-US" sz="2200"/>
-              <a:t>No push, deploy, Vercel, or payment</a:t>
-            </a:r>
-          </a:p>
-          <a:p>
-            <a:pPr marL="342900" indent="0">
-              <a:buChar char="•"/>
-            </a:pPr>
-            <a:r>
-              <a:rPr lang="en-US" sz="2200"/>
-              <a:t>No proprietary content copied</a:t>
-            </a:r>
-          </a:p>
-          <a:p>
-            <a:pPr marL="342900" indent="0">
-              <a:buChar char="•"/>
-            </a:pPr>
-            <a:r>
-              <a:rPr lang="en-US" sz="2200"/>
-              <a:t>Keyboard transfer remains NO</a:t>
-            </a:r>
-          </a:p>
-          <a:p>
-            <a:pPr marL="342900" indent="0">
-              <a:buChar char="•"/>
-            </a:pPr>
-            <a:r>
-              <a:rPr lang="en-US" sz="2200"/>
-              <a:t>Ready for manual PPT review</a:t>
+            <a:pPr marL="342900" indent="0">
+              <a:buChar char="•"/>
+            </a:pPr>
+            <a:r>
+              <a:rPr lang="de-DE" sz="2200"/>
+              <a:t>Kein Payment</a:t>
+            </a:r>
+          </a:p>
+          <a:p>
+            <a:pPr marL="342900" indent="0">
+              <a:buChar char="•"/>
+            </a:pPr>
+            <a:r>
+              <a:rPr lang="de-DE" sz="2200"/>
+              <a:t>Kein Deploy</a:t>
+            </a:r>
+          </a:p>
+          <a:p>
+            <a:pPr marL="342900" indent="0">
+              <a:buChar char="•"/>
+            </a:pPr>
+            <a:r>
+              <a:rPr lang="de-DE" sz="2200"/>
+              <a:t>Kein Vercel</a:t>
+            </a:r>
+          </a:p>
+          <a:p>
+            <a:pPr marL="342900" indent="0">
+              <a:buChar char="•"/>
+            </a:pPr>
+            <a:r>
+              <a:rPr lang="de-DE" sz="2200"/>
+              <a:t>Keine Keyboard-native Ausgabe</a:t>
+            </a:r>
+          </a:p>
+          <a:p>
+            <a:pPr marL="342900" indent="0">
+              <a:buChar char="•"/>
+            </a:pPr>
+            <a:r>
+              <a:rPr lang="de-DE" sz="2200"/>
+              <a:t>Kein Keyboard Transfer</a:t>
             </a:r>
           </a:p>
         </p:txBody>
@@ -607,8 +562,8 @@
           <a:lstStyle/>
           <a:p>
             <a:r>
-              <a:rPr lang="en-US" sz="1200"/>
-              <a:t>LOCAL ONLY - NOT KEYBOARD OUTPUT - NO PUSH / NO DEPLOY / NO VERCEL</a:t>
+              <a:rPr lang="de-DE" sz="1200"/>
+              <a:t>LOCAL ONLY - JOBCENTER ONLY - NOT KEYBOARD OUTPUT</a:t>
             </a:r>
           </a:p>
         </p:txBody>
@@ -622,7 +577,7 @@
 </file>
 
 <file path=ppt\theme\theme1.xml><?xml version="1.0" encoding="utf-8"?>
-<a:theme xmlns:a="http://schemas.openxmlformats.org/drawingml/2006/main" name="UAOS Local">
+<a:theme xmlns:a="http://schemas.openxmlformats.org/drawingml/2006/main" name="UAOS Jobcenter">
   <a:themeElements>
     <a:clrScheme name="UAOS">
       <a:dk1>

</xml_diff>

<commit_message>
Add planned non-live Jobcenter monitor link to final pack
</commit_message>
<xml_diff>
--- a/uaos-ai-factory/jobcenter-send-ready/UAOS_JOBCENTER_PRESENTATION_2026-07-01_DE.pptx
+++ b/uaos-ai-factory/jobcenter-send-ready/UAOS_JOBCENTER_PRESENTATION_2026-07-01_DE.pptx
@@ -138,7 +138,7 @@
           <p:cNvPr id="2" name="Titel 1">
             <a:extLst>
               <a:ext uri="{FF2B5EF4-FFF2-40B4-BE49-F238E27FC236}">
-                <a16:creationId xmlns:a16="http://schemas.microsoft.com/office/drawing/2014/main" id="{AA13A773-61E3-BA81-8165-3A14C5C62C81}"/>
+                <a16:creationId xmlns:a16="http://schemas.microsoft.com/office/drawing/2014/main" id="{B5ACD904-75DC-1D59-61E9-27E5E89814D1}"/>
               </a:ext>
             </a:extLst>
           </p:cNvPr>
@@ -175,7 +175,7 @@
           <p:cNvPr id="3" name="Untertitel 2">
             <a:extLst>
               <a:ext uri="{FF2B5EF4-FFF2-40B4-BE49-F238E27FC236}">
-                <a16:creationId xmlns:a16="http://schemas.microsoft.com/office/drawing/2014/main" id="{28551774-043B-43A5-1112-B08CB76AC1A6}"/>
+                <a16:creationId xmlns:a16="http://schemas.microsoft.com/office/drawing/2014/main" id="{7120E6AD-E2E0-E038-930E-11B9EFD547CF}"/>
               </a:ext>
             </a:extLst>
           </p:cNvPr>
@@ -245,7 +245,7 @@
           <p:cNvPr id="4" name="Datumsplatzhalter 3">
             <a:extLst>
               <a:ext uri="{FF2B5EF4-FFF2-40B4-BE49-F238E27FC236}">
-                <a16:creationId xmlns:a16="http://schemas.microsoft.com/office/drawing/2014/main" id="{CC2A891B-1788-E268-8F3D-F3C3AFB06F29}"/>
+                <a16:creationId xmlns:a16="http://schemas.microsoft.com/office/drawing/2014/main" id="{E81306D2-482A-F278-E08B-09EC3765ED04}"/>
               </a:ext>
             </a:extLst>
           </p:cNvPr>
@@ -261,7 +261,7 @@
           <a:bodyPr/>
           <a:lstStyle/>
           <a:p>
-            <a:fld id="{170F6B8D-F804-4D13-B0B9-090A522C82BA}" type="datetimeFigureOut">
+            <a:fld id="{363C6B2F-0EB9-4825-8B3F-3C3C5B83126B}" type="datetimeFigureOut">
               <a:rPr lang="de-DE" smtClean="0"/>
               <a:t>01.07.2026</a:t>
             </a:fld>
@@ -274,7 +274,7 @@
           <p:cNvPr id="5" name="Fußzeilenplatzhalter 4">
             <a:extLst>
               <a:ext uri="{FF2B5EF4-FFF2-40B4-BE49-F238E27FC236}">
-                <a16:creationId xmlns:a16="http://schemas.microsoft.com/office/drawing/2014/main" id="{12C4C366-4C26-D792-966E-7D8185E8AE60}"/>
+                <a16:creationId xmlns:a16="http://schemas.microsoft.com/office/drawing/2014/main" id="{2E2F9342-E160-3AA8-18E3-A0B4307FCBAA}"/>
               </a:ext>
             </a:extLst>
           </p:cNvPr>
@@ -299,7 +299,7 @@
           <p:cNvPr id="6" name="Foliennummernplatzhalter 5">
             <a:extLst>
               <a:ext uri="{FF2B5EF4-FFF2-40B4-BE49-F238E27FC236}">
-                <a16:creationId xmlns:a16="http://schemas.microsoft.com/office/drawing/2014/main" id="{DC38D40D-A2A7-7FCF-EC9B-502D7426CB35}"/>
+                <a16:creationId xmlns:a16="http://schemas.microsoft.com/office/drawing/2014/main" id="{59FB6AED-DF50-987B-F1DD-A56148D3EC5D}"/>
               </a:ext>
             </a:extLst>
           </p:cNvPr>
@@ -315,7 +315,7 @@
           <a:bodyPr/>
           <a:lstStyle/>
           <a:p>
-            <a:fld id="{886836F0-5FA1-462F-9EA7-66848FCD4852}" type="slidenum">
+            <a:fld id="{D36C3734-E1F4-419B-9C5E-DD98F76C0988}" type="slidenum">
               <a:rPr lang="de-DE" smtClean="0"/>
               <a:t>‹Nr.›</a:t>
             </a:fld>
@@ -326,7 +326,7 @@
     </p:spTree>
     <p:extLst>
       <p:ext uri="{BB962C8B-B14F-4D97-AF65-F5344CB8AC3E}">
-        <p14:creationId xmlns:p14="http://schemas.microsoft.com/office/powerpoint/2010/main" val="1967064566"/>
+        <p14:creationId xmlns:p14="http://schemas.microsoft.com/office/powerpoint/2010/main" val="3417246299"/>
       </p:ext>
     </p:extLst>
   </p:cSld>
@@ -358,7 +358,7 @@
           <p:cNvPr id="2" name="Titel 1">
             <a:extLst>
               <a:ext uri="{FF2B5EF4-FFF2-40B4-BE49-F238E27FC236}">
-                <a16:creationId xmlns:a16="http://schemas.microsoft.com/office/drawing/2014/main" id="{5787B50D-5576-B97C-1719-2C92A69A4D2D}"/>
+                <a16:creationId xmlns:a16="http://schemas.microsoft.com/office/drawing/2014/main" id="{82B0448B-14B6-84B8-BE2E-6151C80442F4}"/>
               </a:ext>
             </a:extLst>
           </p:cNvPr>
@@ -386,7 +386,7 @@
           <p:cNvPr id="3" name="Vertikaler Textplatzhalter 2">
             <a:extLst>
               <a:ext uri="{FF2B5EF4-FFF2-40B4-BE49-F238E27FC236}">
-                <a16:creationId xmlns:a16="http://schemas.microsoft.com/office/drawing/2014/main" id="{DD08AEDD-857E-6824-F568-6C3072BC7198}"/>
+                <a16:creationId xmlns:a16="http://schemas.microsoft.com/office/drawing/2014/main" id="{FD7DBB8B-5DCA-249D-0413-9EC2E8C4582A}"/>
               </a:ext>
             </a:extLst>
           </p:cNvPr>
@@ -443,7 +443,7 @@
           <p:cNvPr id="4" name="Datumsplatzhalter 3">
             <a:extLst>
               <a:ext uri="{FF2B5EF4-FFF2-40B4-BE49-F238E27FC236}">
-                <a16:creationId xmlns:a16="http://schemas.microsoft.com/office/drawing/2014/main" id="{84424E71-4C72-F7CD-2F80-ECCB924B12C4}"/>
+                <a16:creationId xmlns:a16="http://schemas.microsoft.com/office/drawing/2014/main" id="{6E263608-89CB-B222-9749-002575BDE998}"/>
               </a:ext>
             </a:extLst>
           </p:cNvPr>
@@ -459,7 +459,7 @@
           <a:bodyPr/>
           <a:lstStyle/>
           <a:p>
-            <a:fld id="{170F6B8D-F804-4D13-B0B9-090A522C82BA}" type="datetimeFigureOut">
+            <a:fld id="{363C6B2F-0EB9-4825-8B3F-3C3C5B83126B}" type="datetimeFigureOut">
               <a:rPr lang="de-DE" smtClean="0"/>
               <a:t>01.07.2026</a:t>
             </a:fld>
@@ -472,7 +472,7 @@
           <p:cNvPr id="5" name="Fußzeilenplatzhalter 4">
             <a:extLst>
               <a:ext uri="{FF2B5EF4-FFF2-40B4-BE49-F238E27FC236}">
-                <a16:creationId xmlns:a16="http://schemas.microsoft.com/office/drawing/2014/main" id="{AD74DF21-05A1-16C0-C645-559CBC605A8B}"/>
+                <a16:creationId xmlns:a16="http://schemas.microsoft.com/office/drawing/2014/main" id="{462AD8A4-BB25-D935-FE60-F7B13A65D0DA}"/>
               </a:ext>
             </a:extLst>
           </p:cNvPr>
@@ -497,7 +497,7 @@
           <p:cNvPr id="6" name="Foliennummernplatzhalter 5">
             <a:extLst>
               <a:ext uri="{FF2B5EF4-FFF2-40B4-BE49-F238E27FC236}">
-                <a16:creationId xmlns:a16="http://schemas.microsoft.com/office/drawing/2014/main" id="{E25C54FF-5A8A-F2D0-BAFC-82F56D0536EC}"/>
+                <a16:creationId xmlns:a16="http://schemas.microsoft.com/office/drawing/2014/main" id="{48176FDE-B514-6254-E66F-109AAB6D9D98}"/>
               </a:ext>
             </a:extLst>
           </p:cNvPr>
@@ -513,7 +513,7 @@
           <a:bodyPr/>
           <a:lstStyle/>
           <a:p>
-            <a:fld id="{886836F0-5FA1-462F-9EA7-66848FCD4852}" type="slidenum">
+            <a:fld id="{D36C3734-E1F4-419B-9C5E-DD98F76C0988}" type="slidenum">
               <a:rPr lang="de-DE" smtClean="0"/>
               <a:t>‹Nr.›</a:t>
             </a:fld>
@@ -524,7 +524,7 @@
     </p:spTree>
     <p:extLst>
       <p:ext uri="{BB962C8B-B14F-4D97-AF65-F5344CB8AC3E}">
-        <p14:creationId xmlns:p14="http://schemas.microsoft.com/office/powerpoint/2010/main" val="1778477917"/>
+        <p14:creationId xmlns:p14="http://schemas.microsoft.com/office/powerpoint/2010/main" val="1597861993"/>
       </p:ext>
     </p:extLst>
   </p:cSld>
@@ -556,7 +556,7 @@
           <p:cNvPr id="2" name="Vertikaler Titel 1">
             <a:extLst>
               <a:ext uri="{FF2B5EF4-FFF2-40B4-BE49-F238E27FC236}">
-                <a16:creationId xmlns:a16="http://schemas.microsoft.com/office/drawing/2014/main" id="{E9F1051B-7B58-C1D0-BA13-BA66D715573B}"/>
+                <a16:creationId xmlns:a16="http://schemas.microsoft.com/office/drawing/2014/main" id="{9933CD0C-7557-31F2-9FDA-78C6494DA211}"/>
               </a:ext>
             </a:extLst>
           </p:cNvPr>
@@ -589,7 +589,7 @@
           <p:cNvPr id="3" name="Vertikaler Textplatzhalter 2">
             <a:extLst>
               <a:ext uri="{FF2B5EF4-FFF2-40B4-BE49-F238E27FC236}">
-                <a16:creationId xmlns:a16="http://schemas.microsoft.com/office/drawing/2014/main" id="{514B07E6-6EEC-C083-2F1D-EF215A9D7EFC}"/>
+                <a16:creationId xmlns:a16="http://schemas.microsoft.com/office/drawing/2014/main" id="{53BEFD0D-51ED-656B-70D2-73510E2CE465}"/>
               </a:ext>
             </a:extLst>
           </p:cNvPr>
@@ -651,7 +651,7 @@
           <p:cNvPr id="4" name="Datumsplatzhalter 3">
             <a:extLst>
               <a:ext uri="{FF2B5EF4-FFF2-40B4-BE49-F238E27FC236}">
-                <a16:creationId xmlns:a16="http://schemas.microsoft.com/office/drawing/2014/main" id="{97067A01-4D1B-EACD-B893-8BA0DB19F0EB}"/>
+                <a16:creationId xmlns:a16="http://schemas.microsoft.com/office/drawing/2014/main" id="{41A937FB-1514-8329-CF50-7C7D27AAFDC0}"/>
               </a:ext>
             </a:extLst>
           </p:cNvPr>
@@ -667,7 +667,7 @@
           <a:bodyPr/>
           <a:lstStyle/>
           <a:p>
-            <a:fld id="{170F6B8D-F804-4D13-B0B9-090A522C82BA}" type="datetimeFigureOut">
+            <a:fld id="{363C6B2F-0EB9-4825-8B3F-3C3C5B83126B}" type="datetimeFigureOut">
               <a:rPr lang="de-DE" smtClean="0"/>
               <a:t>01.07.2026</a:t>
             </a:fld>
@@ -680,7 +680,7 @@
           <p:cNvPr id="5" name="Fußzeilenplatzhalter 4">
             <a:extLst>
               <a:ext uri="{FF2B5EF4-FFF2-40B4-BE49-F238E27FC236}">
-                <a16:creationId xmlns:a16="http://schemas.microsoft.com/office/drawing/2014/main" id="{20D3BA43-4724-A508-3AC1-3E895898ED23}"/>
+                <a16:creationId xmlns:a16="http://schemas.microsoft.com/office/drawing/2014/main" id="{1D3AADC8-D3E0-C29D-F621-C2A924664667}"/>
               </a:ext>
             </a:extLst>
           </p:cNvPr>
@@ -705,7 +705,7 @@
           <p:cNvPr id="6" name="Foliennummernplatzhalter 5">
             <a:extLst>
               <a:ext uri="{FF2B5EF4-FFF2-40B4-BE49-F238E27FC236}">
-                <a16:creationId xmlns:a16="http://schemas.microsoft.com/office/drawing/2014/main" id="{2F74FAD1-EFA3-5202-7F0B-B03664EAC237}"/>
+                <a16:creationId xmlns:a16="http://schemas.microsoft.com/office/drawing/2014/main" id="{A7048438-BCA5-C402-C48E-34D9143B4253}"/>
               </a:ext>
             </a:extLst>
           </p:cNvPr>
@@ -721,7 +721,7 @@
           <a:bodyPr/>
           <a:lstStyle/>
           <a:p>
-            <a:fld id="{886836F0-5FA1-462F-9EA7-66848FCD4852}" type="slidenum">
+            <a:fld id="{D36C3734-E1F4-419B-9C5E-DD98F76C0988}" type="slidenum">
               <a:rPr lang="de-DE" smtClean="0"/>
               <a:t>‹Nr.›</a:t>
             </a:fld>
@@ -732,7 +732,7 @@
     </p:spTree>
     <p:extLst>
       <p:ext uri="{BB962C8B-B14F-4D97-AF65-F5344CB8AC3E}">
-        <p14:creationId xmlns:p14="http://schemas.microsoft.com/office/powerpoint/2010/main" val="598266755"/>
+        <p14:creationId xmlns:p14="http://schemas.microsoft.com/office/powerpoint/2010/main" val="2670658476"/>
       </p:ext>
     </p:extLst>
   </p:cSld>
@@ -764,7 +764,7 @@
           <p:cNvPr id="2" name="Titel 1">
             <a:extLst>
               <a:ext uri="{FF2B5EF4-FFF2-40B4-BE49-F238E27FC236}">
-                <a16:creationId xmlns:a16="http://schemas.microsoft.com/office/drawing/2014/main" id="{1A45B364-5617-BB99-4471-79AE447D08BF}"/>
+                <a16:creationId xmlns:a16="http://schemas.microsoft.com/office/drawing/2014/main" id="{82FF80C1-1DCC-A8C2-AFF8-E554B02F1E2B}"/>
               </a:ext>
             </a:extLst>
           </p:cNvPr>
@@ -792,7 +792,7 @@
           <p:cNvPr id="3" name="Inhaltsplatzhalter 2">
             <a:extLst>
               <a:ext uri="{FF2B5EF4-FFF2-40B4-BE49-F238E27FC236}">
-                <a16:creationId xmlns:a16="http://schemas.microsoft.com/office/drawing/2014/main" id="{0A94FF1F-1A27-8EDC-0EA3-B02A41815B35}"/>
+                <a16:creationId xmlns:a16="http://schemas.microsoft.com/office/drawing/2014/main" id="{EA643ACC-27C1-0F30-39C8-75C7D1181D92}"/>
               </a:ext>
             </a:extLst>
           </p:cNvPr>
@@ -849,7 +849,7 @@
           <p:cNvPr id="4" name="Datumsplatzhalter 3">
             <a:extLst>
               <a:ext uri="{FF2B5EF4-FFF2-40B4-BE49-F238E27FC236}">
-                <a16:creationId xmlns:a16="http://schemas.microsoft.com/office/drawing/2014/main" id="{275B6A8D-A7BC-1C39-8B36-081C64657618}"/>
+                <a16:creationId xmlns:a16="http://schemas.microsoft.com/office/drawing/2014/main" id="{95793594-B919-2322-576C-AE21F2079A60}"/>
               </a:ext>
             </a:extLst>
           </p:cNvPr>
@@ -865,7 +865,7 @@
           <a:bodyPr/>
           <a:lstStyle/>
           <a:p>
-            <a:fld id="{170F6B8D-F804-4D13-B0B9-090A522C82BA}" type="datetimeFigureOut">
+            <a:fld id="{363C6B2F-0EB9-4825-8B3F-3C3C5B83126B}" type="datetimeFigureOut">
               <a:rPr lang="de-DE" smtClean="0"/>
               <a:t>01.07.2026</a:t>
             </a:fld>
@@ -878,7 +878,7 @@
           <p:cNvPr id="5" name="Fußzeilenplatzhalter 4">
             <a:extLst>
               <a:ext uri="{FF2B5EF4-FFF2-40B4-BE49-F238E27FC236}">
-                <a16:creationId xmlns:a16="http://schemas.microsoft.com/office/drawing/2014/main" id="{436904B1-70F5-3F6B-57A7-79D9DCE1A375}"/>
+                <a16:creationId xmlns:a16="http://schemas.microsoft.com/office/drawing/2014/main" id="{E6B94988-5AFF-1BDE-1945-9CE784F9C9C4}"/>
               </a:ext>
             </a:extLst>
           </p:cNvPr>
@@ -903,7 +903,7 @@
           <p:cNvPr id="6" name="Foliennummernplatzhalter 5">
             <a:extLst>
               <a:ext uri="{FF2B5EF4-FFF2-40B4-BE49-F238E27FC236}">
-                <a16:creationId xmlns:a16="http://schemas.microsoft.com/office/drawing/2014/main" id="{92D6A3C1-1DD4-FFB4-7665-3F36A031A67A}"/>
+                <a16:creationId xmlns:a16="http://schemas.microsoft.com/office/drawing/2014/main" id="{78199769-8E31-C740-01FF-5EC5B241E2A8}"/>
               </a:ext>
             </a:extLst>
           </p:cNvPr>
@@ -919,7 +919,7 @@
           <a:bodyPr/>
           <a:lstStyle/>
           <a:p>
-            <a:fld id="{886836F0-5FA1-462F-9EA7-66848FCD4852}" type="slidenum">
+            <a:fld id="{D36C3734-E1F4-419B-9C5E-DD98F76C0988}" type="slidenum">
               <a:rPr lang="de-DE" smtClean="0"/>
               <a:t>‹Nr.›</a:t>
             </a:fld>
@@ -930,7 +930,7 @@
     </p:spTree>
     <p:extLst>
       <p:ext uri="{BB962C8B-B14F-4D97-AF65-F5344CB8AC3E}">
-        <p14:creationId xmlns:p14="http://schemas.microsoft.com/office/powerpoint/2010/main" val="2788246608"/>
+        <p14:creationId xmlns:p14="http://schemas.microsoft.com/office/powerpoint/2010/main" val="1568535701"/>
       </p:ext>
     </p:extLst>
   </p:cSld>
@@ -962,7 +962,7 @@
           <p:cNvPr id="2" name="Titel 1">
             <a:extLst>
               <a:ext uri="{FF2B5EF4-FFF2-40B4-BE49-F238E27FC236}">
-                <a16:creationId xmlns:a16="http://schemas.microsoft.com/office/drawing/2014/main" id="{CFBD5869-37B3-9DB4-AC85-D3F1898E2A52}"/>
+                <a16:creationId xmlns:a16="http://schemas.microsoft.com/office/drawing/2014/main" id="{46FBCB9E-4161-8899-0698-773001446314}"/>
               </a:ext>
             </a:extLst>
           </p:cNvPr>
@@ -999,7 +999,7 @@
           <p:cNvPr id="3" name="Textplatzhalter 2">
             <a:extLst>
               <a:ext uri="{FF2B5EF4-FFF2-40B4-BE49-F238E27FC236}">
-                <a16:creationId xmlns:a16="http://schemas.microsoft.com/office/drawing/2014/main" id="{5BD407F9-BFDD-AFC6-C151-C5398D0933AE}"/>
+                <a16:creationId xmlns:a16="http://schemas.microsoft.com/office/drawing/2014/main" id="{D97C947B-4602-BC6F-9055-FD65C627AA0E}"/>
               </a:ext>
             </a:extLst>
           </p:cNvPr>
@@ -1124,7 +1124,7 @@
           <p:cNvPr id="4" name="Datumsplatzhalter 3">
             <a:extLst>
               <a:ext uri="{FF2B5EF4-FFF2-40B4-BE49-F238E27FC236}">
-                <a16:creationId xmlns:a16="http://schemas.microsoft.com/office/drawing/2014/main" id="{243183D8-25F5-7486-3D08-5DA775AF912C}"/>
+                <a16:creationId xmlns:a16="http://schemas.microsoft.com/office/drawing/2014/main" id="{DE59A43F-3126-E0F0-44D6-C8B4620ADB7F}"/>
               </a:ext>
             </a:extLst>
           </p:cNvPr>
@@ -1140,7 +1140,7 @@
           <a:bodyPr/>
           <a:lstStyle/>
           <a:p>
-            <a:fld id="{170F6B8D-F804-4D13-B0B9-090A522C82BA}" type="datetimeFigureOut">
+            <a:fld id="{363C6B2F-0EB9-4825-8B3F-3C3C5B83126B}" type="datetimeFigureOut">
               <a:rPr lang="de-DE" smtClean="0"/>
               <a:t>01.07.2026</a:t>
             </a:fld>
@@ -1153,7 +1153,7 @@
           <p:cNvPr id="5" name="Fußzeilenplatzhalter 4">
             <a:extLst>
               <a:ext uri="{FF2B5EF4-FFF2-40B4-BE49-F238E27FC236}">
-                <a16:creationId xmlns:a16="http://schemas.microsoft.com/office/drawing/2014/main" id="{38E7230C-D025-C1E3-6541-52936A00C3FB}"/>
+                <a16:creationId xmlns:a16="http://schemas.microsoft.com/office/drawing/2014/main" id="{C0CC2093-0550-CCC7-E299-6CD27201D26C}"/>
               </a:ext>
             </a:extLst>
           </p:cNvPr>
@@ -1178,7 +1178,7 @@
           <p:cNvPr id="6" name="Foliennummernplatzhalter 5">
             <a:extLst>
               <a:ext uri="{FF2B5EF4-FFF2-40B4-BE49-F238E27FC236}">
-                <a16:creationId xmlns:a16="http://schemas.microsoft.com/office/drawing/2014/main" id="{E97D9F20-A33B-2C0A-C240-50DB87550171}"/>
+                <a16:creationId xmlns:a16="http://schemas.microsoft.com/office/drawing/2014/main" id="{F62ABDAF-6AB5-F37C-0F93-CEE3F66F0E54}"/>
               </a:ext>
             </a:extLst>
           </p:cNvPr>
@@ -1194,7 +1194,7 @@
           <a:bodyPr/>
           <a:lstStyle/>
           <a:p>
-            <a:fld id="{886836F0-5FA1-462F-9EA7-66848FCD4852}" type="slidenum">
+            <a:fld id="{D36C3734-E1F4-419B-9C5E-DD98F76C0988}" type="slidenum">
               <a:rPr lang="de-DE" smtClean="0"/>
               <a:t>‹Nr.›</a:t>
             </a:fld>
@@ -1205,7 +1205,7 @@
     </p:spTree>
     <p:extLst>
       <p:ext uri="{BB962C8B-B14F-4D97-AF65-F5344CB8AC3E}">
-        <p14:creationId xmlns:p14="http://schemas.microsoft.com/office/powerpoint/2010/main" val="2227998276"/>
+        <p14:creationId xmlns:p14="http://schemas.microsoft.com/office/powerpoint/2010/main" val="3348322176"/>
       </p:ext>
     </p:extLst>
   </p:cSld>
@@ -1237,7 +1237,7 @@
           <p:cNvPr id="2" name="Titel 1">
             <a:extLst>
               <a:ext uri="{FF2B5EF4-FFF2-40B4-BE49-F238E27FC236}">
-                <a16:creationId xmlns:a16="http://schemas.microsoft.com/office/drawing/2014/main" id="{8AD31CE6-4B4A-0510-0068-50AA7280ED33}"/>
+                <a16:creationId xmlns:a16="http://schemas.microsoft.com/office/drawing/2014/main" id="{AD5AA5DA-9064-B3B0-DB30-81EB2E6B6D66}"/>
               </a:ext>
             </a:extLst>
           </p:cNvPr>
@@ -1265,7 +1265,7 @@
           <p:cNvPr id="3" name="Inhaltsplatzhalter 2">
             <a:extLst>
               <a:ext uri="{FF2B5EF4-FFF2-40B4-BE49-F238E27FC236}">
-                <a16:creationId xmlns:a16="http://schemas.microsoft.com/office/drawing/2014/main" id="{565CD72C-E851-79ED-297C-93225ACE35EF}"/>
+                <a16:creationId xmlns:a16="http://schemas.microsoft.com/office/drawing/2014/main" id="{136A1642-B451-1502-76EE-80BDB8111814}"/>
               </a:ext>
             </a:extLst>
           </p:cNvPr>
@@ -1327,7 +1327,7 @@
           <p:cNvPr id="4" name="Inhaltsplatzhalter 3">
             <a:extLst>
               <a:ext uri="{FF2B5EF4-FFF2-40B4-BE49-F238E27FC236}">
-                <a16:creationId xmlns:a16="http://schemas.microsoft.com/office/drawing/2014/main" id="{E38A3F26-AB32-A641-1A12-C4B678088092}"/>
+                <a16:creationId xmlns:a16="http://schemas.microsoft.com/office/drawing/2014/main" id="{F888A5A7-AC42-D6C9-799E-805B7E3CDC28}"/>
               </a:ext>
             </a:extLst>
           </p:cNvPr>
@@ -1389,7 +1389,7 @@
           <p:cNvPr id="5" name="Datumsplatzhalter 4">
             <a:extLst>
               <a:ext uri="{FF2B5EF4-FFF2-40B4-BE49-F238E27FC236}">
-                <a16:creationId xmlns:a16="http://schemas.microsoft.com/office/drawing/2014/main" id="{FF46C629-4AE8-3F5C-E2F4-02CDEAF75135}"/>
+                <a16:creationId xmlns:a16="http://schemas.microsoft.com/office/drawing/2014/main" id="{992876ED-532C-CB62-80E9-176CBB4F5B0E}"/>
               </a:ext>
             </a:extLst>
           </p:cNvPr>
@@ -1405,7 +1405,7 @@
           <a:bodyPr/>
           <a:lstStyle/>
           <a:p>
-            <a:fld id="{170F6B8D-F804-4D13-B0B9-090A522C82BA}" type="datetimeFigureOut">
+            <a:fld id="{363C6B2F-0EB9-4825-8B3F-3C3C5B83126B}" type="datetimeFigureOut">
               <a:rPr lang="de-DE" smtClean="0"/>
               <a:t>01.07.2026</a:t>
             </a:fld>
@@ -1418,7 +1418,7 @@
           <p:cNvPr id="6" name="Fußzeilenplatzhalter 5">
             <a:extLst>
               <a:ext uri="{FF2B5EF4-FFF2-40B4-BE49-F238E27FC236}">
-                <a16:creationId xmlns:a16="http://schemas.microsoft.com/office/drawing/2014/main" id="{1CE317AE-D8D5-2B7C-5D3A-765D69C5F7D9}"/>
+                <a16:creationId xmlns:a16="http://schemas.microsoft.com/office/drawing/2014/main" id="{FFBE4D4A-04D1-B862-1F78-1BCBCE500576}"/>
               </a:ext>
             </a:extLst>
           </p:cNvPr>
@@ -1443,7 +1443,7 @@
           <p:cNvPr id="7" name="Foliennummernplatzhalter 6">
             <a:extLst>
               <a:ext uri="{FF2B5EF4-FFF2-40B4-BE49-F238E27FC236}">
-                <a16:creationId xmlns:a16="http://schemas.microsoft.com/office/drawing/2014/main" id="{25FD9BB1-162F-59C3-AC1C-350B53D2FABC}"/>
+                <a16:creationId xmlns:a16="http://schemas.microsoft.com/office/drawing/2014/main" id="{DB7FD1F9-28A8-F3BD-6224-AB3EC543E40E}"/>
               </a:ext>
             </a:extLst>
           </p:cNvPr>
@@ -1459,7 +1459,7 @@
           <a:bodyPr/>
           <a:lstStyle/>
           <a:p>
-            <a:fld id="{886836F0-5FA1-462F-9EA7-66848FCD4852}" type="slidenum">
+            <a:fld id="{D36C3734-E1F4-419B-9C5E-DD98F76C0988}" type="slidenum">
               <a:rPr lang="de-DE" smtClean="0"/>
               <a:t>‹Nr.›</a:t>
             </a:fld>
@@ -1470,7 +1470,7 @@
     </p:spTree>
     <p:extLst>
       <p:ext uri="{BB962C8B-B14F-4D97-AF65-F5344CB8AC3E}">
-        <p14:creationId xmlns:p14="http://schemas.microsoft.com/office/powerpoint/2010/main" val="3461499129"/>
+        <p14:creationId xmlns:p14="http://schemas.microsoft.com/office/powerpoint/2010/main" val="3544017998"/>
       </p:ext>
     </p:extLst>
   </p:cSld>
@@ -1502,7 +1502,7 @@
           <p:cNvPr id="2" name="Titel 1">
             <a:extLst>
               <a:ext uri="{FF2B5EF4-FFF2-40B4-BE49-F238E27FC236}">
-                <a16:creationId xmlns:a16="http://schemas.microsoft.com/office/drawing/2014/main" id="{EF5983D6-C147-921B-E52D-21B3BD3D0418}"/>
+                <a16:creationId xmlns:a16="http://schemas.microsoft.com/office/drawing/2014/main" id="{A9855105-5EA7-953C-7251-6715EC292085}"/>
               </a:ext>
             </a:extLst>
           </p:cNvPr>
@@ -1535,7 +1535,7 @@
           <p:cNvPr id="3" name="Textplatzhalter 2">
             <a:extLst>
               <a:ext uri="{FF2B5EF4-FFF2-40B4-BE49-F238E27FC236}">
-                <a16:creationId xmlns:a16="http://schemas.microsoft.com/office/drawing/2014/main" id="{D0C71EBD-33E9-29D3-693F-F7470A386C76}"/>
+                <a16:creationId xmlns:a16="http://schemas.microsoft.com/office/drawing/2014/main" id="{162C979D-B1E2-8BAE-BDE7-5313613DDFA1}"/>
               </a:ext>
             </a:extLst>
           </p:cNvPr>
@@ -1606,7 +1606,7 @@
           <p:cNvPr id="4" name="Inhaltsplatzhalter 3">
             <a:extLst>
               <a:ext uri="{FF2B5EF4-FFF2-40B4-BE49-F238E27FC236}">
-                <a16:creationId xmlns:a16="http://schemas.microsoft.com/office/drawing/2014/main" id="{CD911B75-0722-B972-135C-D7A859EF322B}"/>
+                <a16:creationId xmlns:a16="http://schemas.microsoft.com/office/drawing/2014/main" id="{2715CB04-E8B0-1D61-6CB6-E9AEA360DB06}"/>
               </a:ext>
             </a:extLst>
           </p:cNvPr>
@@ -1668,7 +1668,7 @@
           <p:cNvPr id="5" name="Textplatzhalter 4">
             <a:extLst>
               <a:ext uri="{FF2B5EF4-FFF2-40B4-BE49-F238E27FC236}">
-                <a16:creationId xmlns:a16="http://schemas.microsoft.com/office/drawing/2014/main" id="{8FDD776A-CE95-2663-EC8E-5ACC56AC936F}"/>
+                <a16:creationId xmlns:a16="http://schemas.microsoft.com/office/drawing/2014/main" id="{E3B2E7F2-42CD-63FF-3B07-F6F020DF561F}"/>
               </a:ext>
             </a:extLst>
           </p:cNvPr>
@@ -1739,7 +1739,7 @@
           <p:cNvPr id="6" name="Inhaltsplatzhalter 5">
             <a:extLst>
               <a:ext uri="{FF2B5EF4-FFF2-40B4-BE49-F238E27FC236}">
-                <a16:creationId xmlns:a16="http://schemas.microsoft.com/office/drawing/2014/main" id="{93DC6077-7BEB-A1B5-47FC-6D783B8D01BF}"/>
+                <a16:creationId xmlns:a16="http://schemas.microsoft.com/office/drawing/2014/main" id="{0B25BEE4-EC9B-BB49-2239-0EDEDCAA0433}"/>
               </a:ext>
             </a:extLst>
           </p:cNvPr>
@@ -1801,7 +1801,7 @@
           <p:cNvPr id="7" name="Datumsplatzhalter 6">
             <a:extLst>
               <a:ext uri="{FF2B5EF4-FFF2-40B4-BE49-F238E27FC236}">
-                <a16:creationId xmlns:a16="http://schemas.microsoft.com/office/drawing/2014/main" id="{3AC64858-A01F-E2B4-60C0-C8F8637FE7C3}"/>
+                <a16:creationId xmlns:a16="http://schemas.microsoft.com/office/drawing/2014/main" id="{04D61895-F6E0-465C-0DDD-6C08BB10FEEB}"/>
               </a:ext>
             </a:extLst>
           </p:cNvPr>
@@ -1817,7 +1817,7 @@
           <a:bodyPr/>
           <a:lstStyle/>
           <a:p>
-            <a:fld id="{170F6B8D-F804-4D13-B0B9-090A522C82BA}" type="datetimeFigureOut">
+            <a:fld id="{363C6B2F-0EB9-4825-8B3F-3C3C5B83126B}" type="datetimeFigureOut">
               <a:rPr lang="de-DE" smtClean="0"/>
               <a:t>01.07.2026</a:t>
             </a:fld>
@@ -1830,7 +1830,7 @@
           <p:cNvPr id="8" name="Fußzeilenplatzhalter 7">
             <a:extLst>
               <a:ext uri="{FF2B5EF4-FFF2-40B4-BE49-F238E27FC236}">
-                <a16:creationId xmlns:a16="http://schemas.microsoft.com/office/drawing/2014/main" id="{42C97B97-AEDE-205C-23B8-3F01AA3BF26F}"/>
+                <a16:creationId xmlns:a16="http://schemas.microsoft.com/office/drawing/2014/main" id="{0731B7A4-7652-A99D-9AAA-7FAAE4EA6207}"/>
               </a:ext>
             </a:extLst>
           </p:cNvPr>
@@ -1855,7 +1855,7 @@
           <p:cNvPr id="9" name="Foliennummernplatzhalter 8">
             <a:extLst>
               <a:ext uri="{FF2B5EF4-FFF2-40B4-BE49-F238E27FC236}">
-                <a16:creationId xmlns:a16="http://schemas.microsoft.com/office/drawing/2014/main" id="{20810458-FD1C-B193-2911-1C7F081D79E6}"/>
+                <a16:creationId xmlns:a16="http://schemas.microsoft.com/office/drawing/2014/main" id="{71C9184A-3B74-029E-ED99-8CE69D64452A}"/>
               </a:ext>
             </a:extLst>
           </p:cNvPr>
@@ -1871,7 +1871,7 @@
           <a:bodyPr/>
           <a:lstStyle/>
           <a:p>
-            <a:fld id="{886836F0-5FA1-462F-9EA7-66848FCD4852}" type="slidenum">
+            <a:fld id="{D36C3734-E1F4-419B-9C5E-DD98F76C0988}" type="slidenum">
               <a:rPr lang="de-DE" smtClean="0"/>
               <a:t>‹Nr.›</a:t>
             </a:fld>
@@ -1882,7 +1882,7 @@
     </p:spTree>
     <p:extLst>
       <p:ext uri="{BB962C8B-B14F-4D97-AF65-F5344CB8AC3E}">
-        <p14:creationId xmlns:p14="http://schemas.microsoft.com/office/powerpoint/2010/main" val="3553681040"/>
+        <p14:creationId xmlns:p14="http://schemas.microsoft.com/office/powerpoint/2010/main" val="2182256617"/>
       </p:ext>
     </p:extLst>
   </p:cSld>
@@ -1914,7 +1914,7 @@
           <p:cNvPr id="2" name="Titel 1">
             <a:extLst>
               <a:ext uri="{FF2B5EF4-FFF2-40B4-BE49-F238E27FC236}">
-                <a16:creationId xmlns:a16="http://schemas.microsoft.com/office/drawing/2014/main" id="{D9834A6E-F4DE-313C-2E15-EA0335695BA8}"/>
+                <a16:creationId xmlns:a16="http://schemas.microsoft.com/office/drawing/2014/main" id="{DFCD9475-5C56-110F-84E4-9830FCB742D6}"/>
               </a:ext>
             </a:extLst>
           </p:cNvPr>
@@ -1942,7 +1942,7 @@
           <p:cNvPr id="3" name="Datumsplatzhalter 2">
             <a:extLst>
               <a:ext uri="{FF2B5EF4-FFF2-40B4-BE49-F238E27FC236}">
-                <a16:creationId xmlns:a16="http://schemas.microsoft.com/office/drawing/2014/main" id="{AF56107C-0784-8DEC-D018-06D8F6A9BB5A}"/>
+                <a16:creationId xmlns:a16="http://schemas.microsoft.com/office/drawing/2014/main" id="{1DF42029-CA5F-3F70-7654-1844D09ADC49}"/>
               </a:ext>
             </a:extLst>
           </p:cNvPr>
@@ -1958,7 +1958,7 @@
           <a:bodyPr/>
           <a:lstStyle/>
           <a:p>
-            <a:fld id="{170F6B8D-F804-4D13-B0B9-090A522C82BA}" type="datetimeFigureOut">
+            <a:fld id="{363C6B2F-0EB9-4825-8B3F-3C3C5B83126B}" type="datetimeFigureOut">
               <a:rPr lang="de-DE" smtClean="0"/>
               <a:t>01.07.2026</a:t>
             </a:fld>
@@ -1971,7 +1971,7 @@
           <p:cNvPr id="4" name="Fußzeilenplatzhalter 3">
             <a:extLst>
               <a:ext uri="{FF2B5EF4-FFF2-40B4-BE49-F238E27FC236}">
-                <a16:creationId xmlns:a16="http://schemas.microsoft.com/office/drawing/2014/main" id="{9411E522-059C-C46C-C125-C40B1838D7AD}"/>
+                <a16:creationId xmlns:a16="http://schemas.microsoft.com/office/drawing/2014/main" id="{2FBFFD8B-6E69-408B-D156-FC4C7CB1A2D6}"/>
               </a:ext>
             </a:extLst>
           </p:cNvPr>
@@ -1996,7 +1996,7 @@
           <p:cNvPr id="5" name="Foliennummernplatzhalter 4">
             <a:extLst>
               <a:ext uri="{FF2B5EF4-FFF2-40B4-BE49-F238E27FC236}">
-                <a16:creationId xmlns:a16="http://schemas.microsoft.com/office/drawing/2014/main" id="{7EC95188-43E5-498B-B3E7-27EA57C6968E}"/>
+                <a16:creationId xmlns:a16="http://schemas.microsoft.com/office/drawing/2014/main" id="{C67D3563-5443-DD8D-106D-A0A1CD70C6FD}"/>
               </a:ext>
             </a:extLst>
           </p:cNvPr>
@@ -2012,7 +2012,7 @@
           <a:bodyPr/>
           <a:lstStyle/>
           <a:p>
-            <a:fld id="{886836F0-5FA1-462F-9EA7-66848FCD4852}" type="slidenum">
+            <a:fld id="{D36C3734-E1F4-419B-9C5E-DD98F76C0988}" type="slidenum">
               <a:rPr lang="de-DE" smtClean="0"/>
               <a:t>‹Nr.›</a:t>
             </a:fld>
@@ -2023,7 +2023,7 @@
     </p:spTree>
     <p:extLst>
       <p:ext uri="{BB962C8B-B14F-4D97-AF65-F5344CB8AC3E}">
-        <p14:creationId xmlns:p14="http://schemas.microsoft.com/office/powerpoint/2010/main" val="4172677804"/>
+        <p14:creationId xmlns:p14="http://schemas.microsoft.com/office/powerpoint/2010/main" val="3547950574"/>
       </p:ext>
     </p:extLst>
   </p:cSld>
@@ -2055,7 +2055,7 @@
           <p:cNvPr id="2" name="Datumsplatzhalter 1">
             <a:extLst>
               <a:ext uri="{FF2B5EF4-FFF2-40B4-BE49-F238E27FC236}">
-                <a16:creationId xmlns:a16="http://schemas.microsoft.com/office/drawing/2014/main" id="{E5DFCBC4-AC78-8F0B-20B7-6CADFE79C866}"/>
+                <a16:creationId xmlns:a16="http://schemas.microsoft.com/office/drawing/2014/main" id="{68B0AEA8-57A3-06C1-EDA7-611F054F999D}"/>
               </a:ext>
             </a:extLst>
           </p:cNvPr>
@@ -2071,7 +2071,7 @@
           <a:bodyPr/>
           <a:lstStyle/>
           <a:p>
-            <a:fld id="{170F6B8D-F804-4D13-B0B9-090A522C82BA}" type="datetimeFigureOut">
+            <a:fld id="{363C6B2F-0EB9-4825-8B3F-3C3C5B83126B}" type="datetimeFigureOut">
               <a:rPr lang="de-DE" smtClean="0"/>
               <a:t>01.07.2026</a:t>
             </a:fld>
@@ -2084,7 +2084,7 @@
           <p:cNvPr id="3" name="Fußzeilenplatzhalter 2">
             <a:extLst>
               <a:ext uri="{FF2B5EF4-FFF2-40B4-BE49-F238E27FC236}">
-                <a16:creationId xmlns:a16="http://schemas.microsoft.com/office/drawing/2014/main" id="{B550AE35-76D1-B6D2-5639-4CC789AE0A50}"/>
+                <a16:creationId xmlns:a16="http://schemas.microsoft.com/office/drawing/2014/main" id="{9B0E09A6-C680-4D1E-EE07-7F2C15C5FCF5}"/>
               </a:ext>
             </a:extLst>
           </p:cNvPr>
@@ -2109,7 +2109,7 @@
           <p:cNvPr id="4" name="Foliennummernplatzhalter 3">
             <a:extLst>
               <a:ext uri="{FF2B5EF4-FFF2-40B4-BE49-F238E27FC236}">
-                <a16:creationId xmlns:a16="http://schemas.microsoft.com/office/drawing/2014/main" id="{F4265B6D-C7D7-ECF7-B14A-C3EF9A2BE5A2}"/>
+                <a16:creationId xmlns:a16="http://schemas.microsoft.com/office/drawing/2014/main" id="{790D4971-A59F-2E59-CE17-17A7C05CE913}"/>
               </a:ext>
             </a:extLst>
           </p:cNvPr>
@@ -2125,7 +2125,7 @@
           <a:bodyPr/>
           <a:lstStyle/>
           <a:p>
-            <a:fld id="{886836F0-5FA1-462F-9EA7-66848FCD4852}" type="slidenum">
+            <a:fld id="{D36C3734-E1F4-419B-9C5E-DD98F76C0988}" type="slidenum">
               <a:rPr lang="de-DE" smtClean="0"/>
               <a:t>‹Nr.›</a:t>
             </a:fld>
@@ -2136,7 +2136,7 @@
     </p:spTree>
     <p:extLst>
       <p:ext uri="{BB962C8B-B14F-4D97-AF65-F5344CB8AC3E}">
-        <p14:creationId xmlns:p14="http://schemas.microsoft.com/office/powerpoint/2010/main" val="877399485"/>
+        <p14:creationId xmlns:p14="http://schemas.microsoft.com/office/powerpoint/2010/main" val="3518167750"/>
       </p:ext>
     </p:extLst>
   </p:cSld>
@@ -2168,7 +2168,7 @@
           <p:cNvPr id="2" name="Titel 1">
             <a:extLst>
               <a:ext uri="{FF2B5EF4-FFF2-40B4-BE49-F238E27FC236}">
-                <a16:creationId xmlns:a16="http://schemas.microsoft.com/office/drawing/2014/main" id="{221B7CD4-2576-F5E9-E522-57695538D803}"/>
+                <a16:creationId xmlns:a16="http://schemas.microsoft.com/office/drawing/2014/main" id="{6FD2C4DE-9154-512D-71AF-C696F4966D07}"/>
               </a:ext>
             </a:extLst>
           </p:cNvPr>
@@ -2205,7 +2205,7 @@
           <p:cNvPr id="3" name="Inhaltsplatzhalter 2">
             <a:extLst>
               <a:ext uri="{FF2B5EF4-FFF2-40B4-BE49-F238E27FC236}">
-                <a16:creationId xmlns:a16="http://schemas.microsoft.com/office/drawing/2014/main" id="{E8AB47ED-361F-95F5-5EB8-023174F75F00}"/>
+                <a16:creationId xmlns:a16="http://schemas.microsoft.com/office/drawing/2014/main" id="{BFF64A47-B3A9-45C3-E00B-5B567DAFA3DB}"/>
               </a:ext>
             </a:extLst>
           </p:cNvPr>
@@ -2295,7 +2295,7 @@
           <p:cNvPr id="4" name="Textplatzhalter 3">
             <a:extLst>
               <a:ext uri="{FF2B5EF4-FFF2-40B4-BE49-F238E27FC236}">
-                <a16:creationId xmlns:a16="http://schemas.microsoft.com/office/drawing/2014/main" id="{398A5C94-F831-EE12-5133-B956789743B4}"/>
+                <a16:creationId xmlns:a16="http://schemas.microsoft.com/office/drawing/2014/main" id="{34C0CC7C-6DA0-7998-3F39-D2FFDD378FA5}"/>
               </a:ext>
             </a:extLst>
           </p:cNvPr>
@@ -2366,7 +2366,7 @@
           <p:cNvPr id="5" name="Datumsplatzhalter 4">
             <a:extLst>
               <a:ext uri="{FF2B5EF4-FFF2-40B4-BE49-F238E27FC236}">
-                <a16:creationId xmlns:a16="http://schemas.microsoft.com/office/drawing/2014/main" id="{D43F4260-CC8F-F17C-3574-884D0AF802BE}"/>
+                <a16:creationId xmlns:a16="http://schemas.microsoft.com/office/drawing/2014/main" id="{7C48ED92-EF37-E8D1-B8EF-18EC309A6211}"/>
               </a:ext>
             </a:extLst>
           </p:cNvPr>
@@ -2382,7 +2382,7 @@
           <a:bodyPr/>
           <a:lstStyle/>
           <a:p>
-            <a:fld id="{170F6B8D-F804-4D13-B0B9-090A522C82BA}" type="datetimeFigureOut">
+            <a:fld id="{363C6B2F-0EB9-4825-8B3F-3C3C5B83126B}" type="datetimeFigureOut">
               <a:rPr lang="de-DE" smtClean="0"/>
               <a:t>01.07.2026</a:t>
             </a:fld>
@@ -2395,7 +2395,7 @@
           <p:cNvPr id="6" name="Fußzeilenplatzhalter 5">
             <a:extLst>
               <a:ext uri="{FF2B5EF4-FFF2-40B4-BE49-F238E27FC236}">
-                <a16:creationId xmlns:a16="http://schemas.microsoft.com/office/drawing/2014/main" id="{6A2182E9-BBF9-1569-5AB5-232A4EA6A62F}"/>
+                <a16:creationId xmlns:a16="http://schemas.microsoft.com/office/drawing/2014/main" id="{443B9C5A-209D-A940-070A-00147A1FE2D5}"/>
               </a:ext>
             </a:extLst>
           </p:cNvPr>
@@ -2420,7 +2420,7 @@
           <p:cNvPr id="7" name="Foliennummernplatzhalter 6">
             <a:extLst>
               <a:ext uri="{FF2B5EF4-FFF2-40B4-BE49-F238E27FC236}">
-                <a16:creationId xmlns:a16="http://schemas.microsoft.com/office/drawing/2014/main" id="{EC1E31CD-2620-D748-0568-A1560F44BC9F}"/>
+                <a16:creationId xmlns:a16="http://schemas.microsoft.com/office/drawing/2014/main" id="{F602BFEB-6208-0738-5568-44836E0576A4}"/>
               </a:ext>
             </a:extLst>
           </p:cNvPr>
@@ -2436,7 +2436,7 @@
           <a:bodyPr/>
           <a:lstStyle/>
           <a:p>
-            <a:fld id="{886836F0-5FA1-462F-9EA7-66848FCD4852}" type="slidenum">
+            <a:fld id="{D36C3734-E1F4-419B-9C5E-DD98F76C0988}" type="slidenum">
               <a:rPr lang="de-DE" smtClean="0"/>
               <a:t>‹Nr.›</a:t>
             </a:fld>
@@ -2447,7 +2447,7 @@
     </p:spTree>
     <p:extLst>
       <p:ext uri="{BB962C8B-B14F-4D97-AF65-F5344CB8AC3E}">
-        <p14:creationId xmlns:p14="http://schemas.microsoft.com/office/powerpoint/2010/main" val="854259636"/>
+        <p14:creationId xmlns:p14="http://schemas.microsoft.com/office/powerpoint/2010/main" val="1042502288"/>
       </p:ext>
     </p:extLst>
   </p:cSld>
@@ -2479,7 +2479,7 @@
           <p:cNvPr id="2" name="Titel 1">
             <a:extLst>
               <a:ext uri="{FF2B5EF4-FFF2-40B4-BE49-F238E27FC236}">
-                <a16:creationId xmlns:a16="http://schemas.microsoft.com/office/drawing/2014/main" id="{60D153FB-A920-46C8-3CD8-1E46284FEC6C}"/>
+                <a16:creationId xmlns:a16="http://schemas.microsoft.com/office/drawing/2014/main" id="{10248060-3651-A152-B9F2-9FE3BD894805}"/>
               </a:ext>
             </a:extLst>
           </p:cNvPr>
@@ -2516,7 +2516,7 @@
           <p:cNvPr id="3" name="Bildplatzhalter 2">
             <a:extLst>
               <a:ext uri="{FF2B5EF4-FFF2-40B4-BE49-F238E27FC236}">
-                <a16:creationId xmlns:a16="http://schemas.microsoft.com/office/drawing/2014/main" id="{6A1A977B-4ECC-CD70-389D-1568D3A47EC5}"/>
+                <a16:creationId xmlns:a16="http://schemas.microsoft.com/office/drawing/2014/main" id="{4CD102AE-E404-4EF7-1B63-CCC744F84197}"/>
               </a:ext>
             </a:extLst>
           </p:cNvPr>
@@ -2583,7 +2583,7 @@
           <p:cNvPr id="4" name="Textplatzhalter 3">
             <a:extLst>
               <a:ext uri="{FF2B5EF4-FFF2-40B4-BE49-F238E27FC236}">
-                <a16:creationId xmlns:a16="http://schemas.microsoft.com/office/drawing/2014/main" id="{B57EFD4F-2B51-C57D-CC7C-B2785CA9C665}"/>
+                <a16:creationId xmlns:a16="http://schemas.microsoft.com/office/drawing/2014/main" id="{711E7858-6DE8-8B55-C724-DCEBB05DFCAC}"/>
               </a:ext>
             </a:extLst>
           </p:cNvPr>
@@ -2654,7 +2654,7 @@
           <p:cNvPr id="5" name="Datumsplatzhalter 4">
             <a:extLst>
               <a:ext uri="{FF2B5EF4-FFF2-40B4-BE49-F238E27FC236}">
-                <a16:creationId xmlns:a16="http://schemas.microsoft.com/office/drawing/2014/main" id="{62B15363-079F-AA9A-2519-77ECD973A94F}"/>
+                <a16:creationId xmlns:a16="http://schemas.microsoft.com/office/drawing/2014/main" id="{1B165479-3E81-DE0F-DCAC-03AE81F1C7DC}"/>
               </a:ext>
             </a:extLst>
           </p:cNvPr>
@@ -2670,7 +2670,7 @@
           <a:bodyPr/>
           <a:lstStyle/>
           <a:p>
-            <a:fld id="{170F6B8D-F804-4D13-B0B9-090A522C82BA}" type="datetimeFigureOut">
+            <a:fld id="{363C6B2F-0EB9-4825-8B3F-3C3C5B83126B}" type="datetimeFigureOut">
               <a:rPr lang="de-DE" smtClean="0"/>
               <a:t>01.07.2026</a:t>
             </a:fld>
@@ -2683,7 +2683,7 @@
           <p:cNvPr id="6" name="Fußzeilenplatzhalter 5">
             <a:extLst>
               <a:ext uri="{FF2B5EF4-FFF2-40B4-BE49-F238E27FC236}">
-                <a16:creationId xmlns:a16="http://schemas.microsoft.com/office/drawing/2014/main" id="{B6D7C2EC-DCAC-B375-B999-75B3D0DFA3BC}"/>
+                <a16:creationId xmlns:a16="http://schemas.microsoft.com/office/drawing/2014/main" id="{5804BD99-EB6E-B566-B347-3FDA93801D15}"/>
               </a:ext>
             </a:extLst>
           </p:cNvPr>
@@ -2708,7 +2708,7 @@
           <p:cNvPr id="7" name="Foliennummernplatzhalter 6">
             <a:extLst>
               <a:ext uri="{FF2B5EF4-FFF2-40B4-BE49-F238E27FC236}">
-                <a16:creationId xmlns:a16="http://schemas.microsoft.com/office/drawing/2014/main" id="{31038438-2749-6EDC-C92C-8FAB22ACC1C0}"/>
+                <a16:creationId xmlns:a16="http://schemas.microsoft.com/office/drawing/2014/main" id="{9620A9BE-6200-598D-5CE4-326299BD40B8}"/>
               </a:ext>
             </a:extLst>
           </p:cNvPr>
@@ -2724,7 +2724,7 @@
           <a:bodyPr/>
           <a:lstStyle/>
           <a:p>
-            <a:fld id="{886836F0-5FA1-462F-9EA7-66848FCD4852}" type="slidenum">
+            <a:fld id="{D36C3734-E1F4-419B-9C5E-DD98F76C0988}" type="slidenum">
               <a:rPr lang="de-DE" smtClean="0"/>
               <a:t>‹Nr.›</a:t>
             </a:fld>
@@ -2735,7 +2735,7 @@
     </p:spTree>
     <p:extLst>
       <p:ext uri="{BB962C8B-B14F-4D97-AF65-F5344CB8AC3E}">
-        <p14:creationId xmlns:p14="http://schemas.microsoft.com/office/powerpoint/2010/main" val="2381868834"/>
+        <p14:creationId xmlns:p14="http://schemas.microsoft.com/office/powerpoint/2010/main" val="4151158940"/>
       </p:ext>
     </p:extLst>
   </p:cSld>
@@ -2772,7 +2772,7 @@
           <p:cNvPr id="2" name="Titelplatzhalter 1">
             <a:extLst>
               <a:ext uri="{FF2B5EF4-FFF2-40B4-BE49-F238E27FC236}">
-                <a16:creationId xmlns:a16="http://schemas.microsoft.com/office/drawing/2014/main" id="{D19C2E34-3000-0810-6E0F-6147421AE32A}"/>
+                <a16:creationId xmlns:a16="http://schemas.microsoft.com/office/drawing/2014/main" id="{EE52EA34-8FE9-FEE8-B9E1-B69BDB243FDC}"/>
               </a:ext>
             </a:extLst>
           </p:cNvPr>
@@ -2810,7 +2810,7 @@
           <p:cNvPr id="3" name="Textplatzhalter 2">
             <a:extLst>
               <a:ext uri="{FF2B5EF4-FFF2-40B4-BE49-F238E27FC236}">
-                <a16:creationId xmlns:a16="http://schemas.microsoft.com/office/drawing/2014/main" id="{11D17391-900D-F564-C69F-E9D23A50F1AB}"/>
+                <a16:creationId xmlns:a16="http://schemas.microsoft.com/office/drawing/2014/main" id="{C8C2F82E-D2A3-B652-D7C8-CF45F332A455}"/>
               </a:ext>
             </a:extLst>
           </p:cNvPr>
@@ -2877,7 +2877,7 @@
           <p:cNvPr id="4" name="Datumsplatzhalter 3">
             <a:extLst>
               <a:ext uri="{FF2B5EF4-FFF2-40B4-BE49-F238E27FC236}">
-                <a16:creationId xmlns:a16="http://schemas.microsoft.com/office/drawing/2014/main" id="{71DB58ED-9696-D431-9499-067EF74F9569}"/>
+                <a16:creationId xmlns:a16="http://schemas.microsoft.com/office/drawing/2014/main" id="{016D075C-A3EE-3CA1-74EB-FD8B8E353380}"/>
               </a:ext>
             </a:extLst>
           </p:cNvPr>
@@ -2911,7 +2911,7 @@
             </a:lvl1pPr>
           </a:lstStyle>
           <a:p>
-            <a:fld id="{170F6B8D-F804-4D13-B0B9-090A522C82BA}" type="datetimeFigureOut">
+            <a:fld id="{363C6B2F-0EB9-4825-8B3F-3C3C5B83126B}" type="datetimeFigureOut">
               <a:rPr lang="de-DE" smtClean="0"/>
               <a:t>01.07.2026</a:t>
             </a:fld>
@@ -2924,7 +2924,7 @@
           <p:cNvPr id="5" name="Fußzeilenplatzhalter 4">
             <a:extLst>
               <a:ext uri="{FF2B5EF4-FFF2-40B4-BE49-F238E27FC236}">
-                <a16:creationId xmlns:a16="http://schemas.microsoft.com/office/drawing/2014/main" id="{B803952A-C877-8779-AAE3-6FB79405A0ED}"/>
+                <a16:creationId xmlns:a16="http://schemas.microsoft.com/office/drawing/2014/main" id="{162C107D-BCC6-76AD-980F-A0CC295F99FF}"/>
               </a:ext>
             </a:extLst>
           </p:cNvPr>
@@ -2967,7 +2967,7 @@
           <p:cNvPr id="6" name="Foliennummernplatzhalter 5">
             <a:extLst>
               <a:ext uri="{FF2B5EF4-FFF2-40B4-BE49-F238E27FC236}">
-                <a16:creationId xmlns:a16="http://schemas.microsoft.com/office/drawing/2014/main" id="{BB6B3D13-E8E0-3336-E417-6E74091F9C53}"/>
+                <a16:creationId xmlns:a16="http://schemas.microsoft.com/office/drawing/2014/main" id="{C42A79DE-B768-222D-CBDC-D43113959DAA}"/>
               </a:ext>
             </a:extLst>
           </p:cNvPr>
@@ -3001,7 +3001,7 @@
             </a:lvl1pPr>
           </a:lstStyle>
           <a:p>
-            <a:fld id="{886836F0-5FA1-462F-9EA7-66848FCD4852}" type="slidenum">
+            <a:fld id="{D36C3734-E1F4-419B-9C5E-DD98F76C0988}" type="slidenum">
               <a:rPr lang="de-DE" smtClean="0"/>
               <a:t>‹Nr.›</a:t>
             </a:fld>
@@ -3012,7 +3012,7 @@
     </p:spTree>
     <p:extLst>
       <p:ext uri="{BB962C8B-B14F-4D97-AF65-F5344CB8AC3E}">
-        <p14:creationId xmlns:p14="http://schemas.microsoft.com/office/powerpoint/2010/main" val="3434589213"/>
+        <p14:creationId xmlns:p14="http://schemas.microsoft.com/office/powerpoint/2010/main" val="2560773231"/>
       </p:ext>
     </p:extLst>
   </p:cSld>
@@ -3343,7 +3343,7 @@
           <p:cNvPr id="2" name="Rechteck 1">
             <a:extLst>
               <a:ext uri="{FF2B5EF4-FFF2-40B4-BE49-F238E27FC236}">
-                <a16:creationId xmlns:a16="http://schemas.microsoft.com/office/drawing/2014/main" id="{8BE281B2-16CD-0925-DC3C-18DF9A29B2FA}"/>
+                <a16:creationId xmlns:a16="http://schemas.microsoft.com/office/drawing/2014/main" id="{ADAC6348-1BD6-2F45-4541-7115D8A7B49C}"/>
               </a:ext>
             </a:extLst>
           </p:cNvPr>
@@ -3411,7 +3411,7 @@
           <p:cNvPr id="3" name="Rechteck 2">
             <a:extLst>
               <a:ext uri="{FF2B5EF4-FFF2-40B4-BE49-F238E27FC236}">
-                <a16:creationId xmlns:a16="http://schemas.microsoft.com/office/drawing/2014/main" id="{5D4629E6-E003-B6F8-DB54-A1AF696A1875}"/>
+                <a16:creationId xmlns:a16="http://schemas.microsoft.com/office/drawing/2014/main" id="{D6376FC6-43C6-E56E-70A5-3CB914D80D76}"/>
               </a:ext>
             </a:extLst>
           </p:cNvPr>
@@ -3479,7 +3479,7 @@
           <p:cNvPr id="4" name="Textfeld 3">
             <a:extLst>
               <a:ext uri="{FF2B5EF4-FFF2-40B4-BE49-F238E27FC236}">
-                <a16:creationId xmlns:a16="http://schemas.microsoft.com/office/drawing/2014/main" id="{6FC98339-B336-1004-158E-20D546806F2D}"/>
+                <a16:creationId xmlns:a16="http://schemas.microsoft.com/office/drawing/2014/main" id="{83A9EFC2-761D-87EF-D6D7-8EB51F7BB418}"/>
               </a:ext>
             </a:extLst>
           </p:cNvPr>
@@ -3519,7 +3519,7 @@
           <p:cNvPr id="5" name="Textfeld 4">
             <a:extLst>
               <a:ext uri="{FF2B5EF4-FFF2-40B4-BE49-F238E27FC236}">
-                <a16:creationId xmlns:a16="http://schemas.microsoft.com/office/drawing/2014/main" id="{FA299B2F-14F0-D428-B9B8-2CBC9BDACCD8}"/>
+                <a16:creationId xmlns:a16="http://schemas.microsoft.com/office/drawing/2014/main" id="{A0620D66-AC6C-E0A2-306A-0B2A6A40945D}"/>
               </a:ext>
             </a:extLst>
           </p:cNvPr>
@@ -3597,7 +3597,7 @@
           <p:cNvPr id="6" name="Textfeld 5">
             <a:extLst>
               <a:ext uri="{FF2B5EF4-FFF2-40B4-BE49-F238E27FC236}">
-                <a16:creationId xmlns:a16="http://schemas.microsoft.com/office/drawing/2014/main" id="{BE351FCE-0C68-00FE-332E-5949B02B2DF7}"/>
+                <a16:creationId xmlns:a16="http://schemas.microsoft.com/office/drawing/2014/main" id="{9BB52249-1CFE-1935-5B76-2A05955845B5}"/>
               </a:ext>
             </a:extLst>
           </p:cNvPr>
@@ -3635,7 +3635,7 @@
     </p:spTree>
     <p:extLst>
       <p:ext uri="{BB962C8B-B14F-4D97-AF65-F5344CB8AC3E}">
-        <p14:creationId xmlns:p14="http://schemas.microsoft.com/office/powerpoint/2010/main" val="491951080"/>
+        <p14:creationId xmlns:p14="http://schemas.microsoft.com/office/powerpoint/2010/main" val="1149078300"/>
       </p:ext>
     </p:extLst>
   </p:cSld>
@@ -3675,7 +3675,7 @@
           <p:cNvPr id="2" name="Rechteck 1">
             <a:extLst>
               <a:ext uri="{FF2B5EF4-FFF2-40B4-BE49-F238E27FC236}">
-                <a16:creationId xmlns:a16="http://schemas.microsoft.com/office/drawing/2014/main" id="{E4D850A3-911D-048A-172E-DB2E1FC6B503}"/>
+                <a16:creationId xmlns:a16="http://schemas.microsoft.com/office/drawing/2014/main" id="{EE2AB3B3-6286-6D49-4AEF-853DCFDC8FC3}"/>
               </a:ext>
             </a:extLst>
           </p:cNvPr>
@@ -3743,7 +3743,7 @@
           <p:cNvPr id="3" name="Rechteck 2">
             <a:extLst>
               <a:ext uri="{FF2B5EF4-FFF2-40B4-BE49-F238E27FC236}">
-                <a16:creationId xmlns:a16="http://schemas.microsoft.com/office/drawing/2014/main" id="{7EB99D83-B0B4-6DB1-1DA0-7F1F371B6635}"/>
+                <a16:creationId xmlns:a16="http://schemas.microsoft.com/office/drawing/2014/main" id="{C5301CA2-E5BC-0108-5143-A68D0C675E60}"/>
               </a:ext>
             </a:extLst>
           </p:cNvPr>
@@ -3811,7 +3811,7 @@
           <p:cNvPr id="4" name="Textfeld 3">
             <a:extLst>
               <a:ext uri="{FF2B5EF4-FFF2-40B4-BE49-F238E27FC236}">
-                <a16:creationId xmlns:a16="http://schemas.microsoft.com/office/drawing/2014/main" id="{8F291A61-2875-228A-923F-1301BA39EB05}"/>
+                <a16:creationId xmlns:a16="http://schemas.microsoft.com/office/drawing/2014/main" id="{F31DA76B-3D0D-D7B1-3EF8-EAD92F66EEA6}"/>
               </a:ext>
             </a:extLst>
           </p:cNvPr>
@@ -3851,7 +3851,7 @@
           <p:cNvPr id="5" name="Textfeld 4">
             <a:extLst>
               <a:ext uri="{FF2B5EF4-FFF2-40B4-BE49-F238E27FC236}">
-                <a16:creationId xmlns:a16="http://schemas.microsoft.com/office/drawing/2014/main" id="{DAA260B1-A624-A327-5C7D-86945C7AFA6E}"/>
+                <a16:creationId xmlns:a16="http://schemas.microsoft.com/office/drawing/2014/main" id="{999ECCEB-8642-92A3-6A0D-DA83677CEF4E}"/>
               </a:ext>
             </a:extLst>
           </p:cNvPr>
@@ -3929,7 +3929,7 @@
           <p:cNvPr id="6" name="Textfeld 5">
             <a:extLst>
               <a:ext uri="{FF2B5EF4-FFF2-40B4-BE49-F238E27FC236}">
-                <a16:creationId xmlns:a16="http://schemas.microsoft.com/office/drawing/2014/main" id="{571FF242-E47D-FDDC-D8D0-D83D36C8E3E6}"/>
+                <a16:creationId xmlns:a16="http://schemas.microsoft.com/office/drawing/2014/main" id="{E1C3A2F5-0793-3A2D-94DF-F240D731C292}"/>
               </a:ext>
             </a:extLst>
           </p:cNvPr>
@@ -3967,7 +3967,7 @@
     </p:spTree>
     <p:extLst>
       <p:ext uri="{BB962C8B-B14F-4D97-AF65-F5344CB8AC3E}">
-        <p14:creationId xmlns:p14="http://schemas.microsoft.com/office/powerpoint/2010/main" val="1777489078"/>
+        <p14:creationId xmlns:p14="http://schemas.microsoft.com/office/powerpoint/2010/main" val="486858468"/>
       </p:ext>
     </p:extLst>
   </p:cSld>
@@ -4007,7 +4007,7 @@
           <p:cNvPr id="2" name="Rechteck 1">
             <a:extLst>
               <a:ext uri="{FF2B5EF4-FFF2-40B4-BE49-F238E27FC236}">
-                <a16:creationId xmlns:a16="http://schemas.microsoft.com/office/drawing/2014/main" id="{444B0F33-C0DE-9D01-5CAD-BE7ACCA71D49}"/>
+                <a16:creationId xmlns:a16="http://schemas.microsoft.com/office/drawing/2014/main" id="{981DD845-A4CD-B3E4-2AF4-88FAF41F8591}"/>
               </a:ext>
             </a:extLst>
           </p:cNvPr>
@@ -4075,7 +4075,7 @@
           <p:cNvPr id="3" name="Rechteck 2">
             <a:extLst>
               <a:ext uri="{FF2B5EF4-FFF2-40B4-BE49-F238E27FC236}">
-                <a16:creationId xmlns:a16="http://schemas.microsoft.com/office/drawing/2014/main" id="{C80FB130-9A76-A779-8ABE-FAD34CDDEFFF}"/>
+                <a16:creationId xmlns:a16="http://schemas.microsoft.com/office/drawing/2014/main" id="{883F5071-041E-6BC0-54FF-A2F7AAF11591}"/>
               </a:ext>
             </a:extLst>
           </p:cNvPr>
@@ -4143,7 +4143,7 @@
           <p:cNvPr id="4" name="Textfeld 3">
             <a:extLst>
               <a:ext uri="{FF2B5EF4-FFF2-40B4-BE49-F238E27FC236}">
-                <a16:creationId xmlns:a16="http://schemas.microsoft.com/office/drawing/2014/main" id="{7CB57905-5706-533B-3232-EA8BA4F3EB67}"/>
+                <a16:creationId xmlns:a16="http://schemas.microsoft.com/office/drawing/2014/main" id="{1677E19A-0617-64EB-59C1-54E61C5FD7F7}"/>
               </a:ext>
             </a:extLst>
           </p:cNvPr>
@@ -4183,7 +4183,7 @@
           <p:cNvPr id="5" name="Textfeld 4">
             <a:extLst>
               <a:ext uri="{FF2B5EF4-FFF2-40B4-BE49-F238E27FC236}">
-                <a16:creationId xmlns:a16="http://schemas.microsoft.com/office/drawing/2014/main" id="{BD36D7DB-893D-2728-DAA5-E02EB3F41437}"/>
+                <a16:creationId xmlns:a16="http://schemas.microsoft.com/office/drawing/2014/main" id="{835AEDE3-14E4-AC2A-1ECF-1469F3B8B474}"/>
               </a:ext>
             </a:extLst>
           </p:cNvPr>
@@ -4261,7 +4261,7 @@
           <p:cNvPr id="6" name="Textfeld 5">
             <a:extLst>
               <a:ext uri="{FF2B5EF4-FFF2-40B4-BE49-F238E27FC236}">
-                <a16:creationId xmlns:a16="http://schemas.microsoft.com/office/drawing/2014/main" id="{D358364D-480F-90D8-BF89-0C0B4DC51D1E}"/>
+                <a16:creationId xmlns:a16="http://schemas.microsoft.com/office/drawing/2014/main" id="{F5872300-49A3-1D31-B27F-747E45D4F5F7}"/>
               </a:ext>
             </a:extLst>
           </p:cNvPr>
@@ -4299,7 +4299,7 @@
     </p:spTree>
     <p:extLst>
       <p:ext uri="{BB962C8B-B14F-4D97-AF65-F5344CB8AC3E}">
-        <p14:creationId xmlns:p14="http://schemas.microsoft.com/office/powerpoint/2010/main" val="2904658855"/>
+        <p14:creationId xmlns:p14="http://schemas.microsoft.com/office/powerpoint/2010/main" val="2949731054"/>
       </p:ext>
     </p:extLst>
   </p:cSld>
@@ -4339,7 +4339,7 @@
           <p:cNvPr id="2" name="Rechteck 1">
             <a:extLst>
               <a:ext uri="{FF2B5EF4-FFF2-40B4-BE49-F238E27FC236}">
-                <a16:creationId xmlns:a16="http://schemas.microsoft.com/office/drawing/2014/main" id="{C97509B5-531E-DF1D-FCFB-A5398FA3115B}"/>
+                <a16:creationId xmlns:a16="http://schemas.microsoft.com/office/drawing/2014/main" id="{F53C2B89-60F3-C2CE-BEC3-F3B27763392F}"/>
               </a:ext>
             </a:extLst>
           </p:cNvPr>
@@ -4407,7 +4407,7 @@
           <p:cNvPr id="3" name="Rechteck 2">
             <a:extLst>
               <a:ext uri="{FF2B5EF4-FFF2-40B4-BE49-F238E27FC236}">
-                <a16:creationId xmlns:a16="http://schemas.microsoft.com/office/drawing/2014/main" id="{41223367-FE51-A204-7416-20A81DB82546}"/>
+                <a16:creationId xmlns:a16="http://schemas.microsoft.com/office/drawing/2014/main" id="{12B53D25-BDE4-705D-C1F0-426DE1807504}"/>
               </a:ext>
             </a:extLst>
           </p:cNvPr>
@@ -4475,7 +4475,7 @@
           <p:cNvPr id="4" name="Textfeld 3">
             <a:extLst>
               <a:ext uri="{FF2B5EF4-FFF2-40B4-BE49-F238E27FC236}">
-                <a16:creationId xmlns:a16="http://schemas.microsoft.com/office/drawing/2014/main" id="{45C0B23A-811B-193E-41A6-92A56B842247}"/>
+                <a16:creationId xmlns:a16="http://schemas.microsoft.com/office/drawing/2014/main" id="{CE81CE77-F047-4F98-2DAB-C1FD527654DA}"/>
               </a:ext>
             </a:extLst>
           </p:cNvPr>
@@ -4515,7 +4515,7 @@
           <p:cNvPr id="5" name="Textfeld 4">
             <a:extLst>
               <a:ext uri="{FF2B5EF4-FFF2-40B4-BE49-F238E27FC236}">
-                <a16:creationId xmlns:a16="http://schemas.microsoft.com/office/drawing/2014/main" id="{84ABE8DC-234B-6AA7-3E7E-0D112543A65C}"/>
+                <a16:creationId xmlns:a16="http://schemas.microsoft.com/office/drawing/2014/main" id="{C5D364D5-C2DF-5D43-DBA9-065B46037F18}"/>
               </a:ext>
             </a:extLst>
           </p:cNvPr>
@@ -4593,7 +4593,7 @@
           <p:cNvPr id="6" name="Textfeld 5">
             <a:extLst>
               <a:ext uri="{FF2B5EF4-FFF2-40B4-BE49-F238E27FC236}">
-                <a16:creationId xmlns:a16="http://schemas.microsoft.com/office/drawing/2014/main" id="{7A5B34C3-471B-435F-DBCD-E0AB69387369}"/>
+                <a16:creationId xmlns:a16="http://schemas.microsoft.com/office/drawing/2014/main" id="{F33D5BB1-6589-8252-AF9A-10BF89AA3F8A}"/>
               </a:ext>
             </a:extLst>
           </p:cNvPr>
@@ -4631,7 +4631,7 @@
     </p:spTree>
     <p:extLst>
       <p:ext uri="{BB962C8B-B14F-4D97-AF65-F5344CB8AC3E}">
-        <p14:creationId xmlns:p14="http://schemas.microsoft.com/office/powerpoint/2010/main" val="551802165"/>
+        <p14:creationId xmlns:p14="http://schemas.microsoft.com/office/powerpoint/2010/main" val="683007864"/>
       </p:ext>
     </p:extLst>
   </p:cSld>
@@ -4671,7 +4671,7 @@
           <p:cNvPr id="2" name="Rechteck 1">
             <a:extLst>
               <a:ext uri="{FF2B5EF4-FFF2-40B4-BE49-F238E27FC236}">
-                <a16:creationId xmlns:a16="http://schemas.microsoft.com/office/drawing/2014/main" id="{A439838F-05F4-DD59-4F14-3B5F65FB18B4}"/>
+                <a16:creationId xmlns:a16="http://schemas.microsoft.com/office/drawing/2014/main" id="{DD2D76B6-331F-918F-3F0D-251D75249DBE}"/>
               </a:ext>
             </a:extLst>
           </p:cNvPr>
@@ -4739,7 +4739,7 @@
           <p:cNvPr id="3" name="Rechteck 2">
             <a:extLst>
               <a:ext uri="{FF2B5EF4-FFF2-40B4-BE49-F238E27FC236}">
-                <a16:creationId xmlns:a16="http://schemas.microsoft.com/office/drawing/2014/main" id="{B52EDA5A-5D7B-1CFF-AF69-598CBA43EAAB}"/>
+                <a16:creationId xmlns:a16="http://schemas.microsoft.com/office/drawing/2014/main" id="{AAB5958B-4EC5-9E70-6E04-C8963008B1DA}"/>
               </a:ext>
             </a:extLst>
           </p:cNvPr>
@@ -4807,7 +4807,7 @@
           <p:cNvPr id="4" name="Textfeld 3">
             <a:extLst>
               <a:ext uri="{FF2B5EF4-FFF2-40B4-BE49-F238E27FC236}">
-                <a16:creationId xmlns:a16="http://schemas.microsoft.com/office/drawing/2014/main" id="{653B10B6-64DE-B114-87DE-7BFBC28B4241}"/>
+                <a16:creationId xmlns:a16="http://schemas.microsoft.com/office/drawing/2014/main" id="{42B90585-0889-B3D8-D800-14639FEF5A65}"/>
               </a:ext>
             </a:extLst>
           </p:cNvPr>
@@ -4847,7 +4847,7 @@
           <p:cNvPr id="5" name="Textfeld 4">
             <a:extLst>
               <a:ext uri="{FF2B5EF4-FFF2-40B4-BE49-F238E27FC236}">
-                <a16:creationId xmlns:a16="http://schemas.microsoft.com/office/drawing/2014/main" id="{75C69EA3-55A6-CCC5-EC56-E985E22686BF}"/>
+                <a16:creationId xmlns:a16="http://schemas.microsoft.com/office/drawing/2014/main" id="{3012D649-ED80-CFF0-E053-BA7E07296DCA}"/>
               </a:ext>
             </a:extLst>
           </p:cNvPr>
@@ -4925,7 +4925,7 @@
           <p:cNvPr id="6" name="Textfeld 5">
             <a:extLst>
               <a:ext uri="{FF2B5EF4-FFF2-40B4-BE49-F238E27FC236}">
-                <a16:creationId xmlns:a16="http://schemas.microsoft.com/office/drawing/2014/main" id="{D12EA125-5C73-6993-C50B-34D389F3F391}"/>
+                <a16:creationId xmlns:a16="http://schemas.microsoft.com/office/drawing/2014/main" id="{F322C39D-46C9-DB82-ECBB-D4D5AB38CF42}"/>
               </a:ext>
             </a:extLst>
           </p:cNvPr>
@@ -4963,7 +4963,7 @@
     </p:spTree>
     <p:extLst>
       <p:ext uri="{BB962C8B-B14F-4D97-AF65-F5344CB8AC3E}">
-        <p14:creationId xmlns:p14="http://schemas.microsoft.com/office/powerpoint/2010/main" val="1575716949"/>
+        <p14:creationId xmlns:p14="http://schemas.microsoft.com/office/powerpoint/2010/main" val="694944209"/>
       </p:ext>
     </p:extLst>
   </p:cSld>
@@ -5003,7 +5003,7 @@
           <p:cNvPr id="2" name="Rechteck 1">
             <a:extLst>
               <a:ext uri="{FF2B5EF4-FFF2-40B4-BE49-F238E27FC236}">
-                <a16:creationId xmlns:a16="http://schemas.microsoft.com/office/drawing/2014/main" id="{4049A892-3439-E0FC-B685-D2692546E45E}"/>
+                <a16:creationId xmlns:a16="http://schemas.microsoft.com/office/drawing/2014/main" id="{05B3DD35-16C2-F95A-B99A-71D4ACC2B21F}"/>
               </a:ext>
             </a:extLst>
           </p:cNvPr>
@@ -5071,7 +5071,7 @@
           <p:cNvPr id="3" name="Rechteck 2">
             <a:extLst>
               <a:ext uri="{FF2B5EF4-FFF2-40B4-BE49-F238E27FC236}">
-                <a16:creationId xmlns:a16="http://schemas.microsoft.com/office/drawing/2014/main" id="{28F564A0-C3D2-1E0C-388F-3E81BF2C174D}"/>
+                <a16:creationId xmlns:a16="http://schemas.microsoft.com/office/drawing/2014/main" id="{F5D01DA6-8B63-0B2E-82C4-9B614CEB5E98}"/>
               </a:ext>
             </a:extLst>
           </p:cNvPr>
@@ -5139,7 +5139,7 @@
           <p:cNvPr id="4" name="Textfeld 3">
             <a:extLst>
               <a:ext uri="{FF2B5EF4-FFF2-40B4-BE49-F238E27FC236}">
-                <a16:creationId xmlns:a16="http://schemas.microsoft.com/office/drawing/2014/main" id="{EA8968FA-ADC2-49E3-7D04-1088F6677A82}"/>
+                <a16:creationId xmlns:a16="http://schemas.microsoft.com/office/drawing/2014/main" id="{6F4FEA76-652F-8D51-AB36-8A69ADBF6238}"/>
               </a:ext>
             </a:extLst>
           </p:cNvPr>
@@ -5179,7 +5179,7 @@
           <p:cNvPr id="5" name="Textfeld 4">
             <a:extLst>
               <a:ext uri="{FF2B5EF4-FFF2-40B4-BE49-F238E27FC236}">
-                <a16:creationId xmlns:a16="http://schemas.microsoft.com/office/drawing/2014/main" id="{98AD41E6-77EA-1BB6-5910-66F637EDD34E}"/>
+                <a16:creationId xmlns:a16="http://schemas.microsoft.com/office/drawing/2014/main" id="{8904463D-8088-052C-B547-DEFD6AE96161}"/>
               </a:ext>
             </a:extLst>
           </p:cNvPr>
@@ -5257,7 +5257,7 @@
           <p:cNvPr id="6" name="Textfeld 5">
             <a:extLst>
               <a:ext uri="{FF2B5EF4-FFF2-40B4-BE49-F238E27FC236}">
-                <a16:creationId xmlns:a16="http://schemas.microsoft.com/office/drawing/2014/main" id="{58098164-5E6A-07B9-B1FE-59EE64ED269C}"/>
+                <a16:creationId xmlns:a16="http://schemas.microsoft.com/office/drawing/2014/main" id="{16E0A078-6F28-7C11-0B97-2AABF55D03E8}"/>
               </a:ext>
             </a:extLst>
           </p:cNvPr>
@@ -5295,7 +5295,7 @@
     </p:spTree>
     <p:extLst>
       <p:ext uri="{BB962C8B-B14F-4D97-AF65-F5344CB8AC3E}">
-        <p14:creationId xmlns:p14="http://schemas.microsoft.com/office/powerpoint/2010/main" val="550388971"/>
+        <p14:creationId xmlns:p14="http://schemas.microsoft.com/office/powerpoint/2010/main" val="2189173746"/>
       </p:ext>
     </p:extLst>
   </p:cSld>
@@ -5335,7 +5335,7 @@
           <p:cNvPr id="2" name="Rechteck 1">
             <a:extLst>
               <a:ext uri="{FF2B5EF4-FFF2-40B4-BE49-F238E27FC236}">
-                <a16:creationId xmlns:a16="http://schemas.microsoft.com/office/drawing/2014/main" id="{EC775F30-1544-C07C-B227-A83C23975D30}"/>
+                <a16:creationId xmlns:a16="http://schemas.microsoft.com/office/drawing/2014/main" id="{F83E53C3-BADE-36C7-97EA-4C5969DAD1CA}"/>
               </a:ext>
             </a:extLst>
           </p:cNvPr>
@@ -5403,7 +5403,7 @@
           <p:cNvPr id="3" name="Rechteck 2">
             <a:extLst>
               <a:ext uri="{FF2B5EF4-FFF2-40B4-BE49-F238E27FC236}">
-                <a16:creationId xmlns:a16="http://schemas.microsoft.com/office/drawing/2014/main" id="{F52AEF2D-6696-B606-9F26-1D8880733E63}"/>
+                <a16:creationId xmlns:a16="http://schemas.microsoft.com/office/drawing/2014/main" id="{2A95C023-D3F6-D154-D9D7-5AB362E08420}"/>
               </a:ext>
             </a:extLst>
           </p:cNvPr>
@@ -5471,7 +5471,7 @@
           <p:cNvPr id="4" name="Textfeld 3">
             <a:extLst>
               <a:ext uri="{FF2B5EF4-FFF2-40B4-BE49-F238E27FC236}">
-                <a16:creationId xmlns:a16="http://schemas.microsoft.com/office/drawing/2014/main" id="{01A379CD-EF22-4127-8394-737EA8094781}"/>
+                <a16:creationId xmlns:a16="http://schemas.microsoft.com/office/drawing/2014/main" id="{E5F2C4F1-C526-46A7-CA4A-1021C70649E6}"/>
               </a:ext>
             </a:extLst>
           </p:cNvPr>
@@ -5511,7 +5511,7 @@
           <p:cNvPr id="5" name="Textfeld 4">
             <a:extLst>
               <a:ext uri="{FF2B5EF4-FFF2-40B4-BE49-F238E27FC236}">
-                <a16:creationId xmlns:a16="http://schemas.microsoft.com/office/drawing/2014/main" id="{EBD0609F-5109-D959-3D55-8F5A9B494C06}"/>
+                <a16:creationId xmlns:a16="http://schemas.microsoft.com/office/drawing/2014/main" id="{EC3CF354-B597-58F7-D285-CF5CF98BF3FE}"/>
               </a:ext>
             </a:extLst>
           </p:cNvPr>
@@ -5589,7 +5589,7 @@
           <p:cNvPr id="6" name="Textfeld 5">
             <a:extLst>
               <a:ext uri="{FF2B5EF4-FFF2-40B4-BE49-F238E27FC236}">
-                <a16:creationId xmlns:a16="http://schemas.microsoft.com/office/drawing/2014/main" id="{EA4DABD3-A023-BE42-C409-39F20CDF31F0}"/>
+                <a16:creationId xmlns:a16="http://schemas.microsoft.com/office/drawing/2014/main" id="{96206A15-2D3B-59CB-CBC0-2FCD5927185B}"/>
               </a:ext>
             </a:extLst>
           </p:cNvPr>
@@ -5627,7 +5627,7 @@
     </p:spTree>
     <p:extLst>
       <p:ext uri="{BB962C8B-B14F-4D97-AF65-F5344CB8AC3E}">
-        <p14:creationId xmlns:p14="http://schemas.microsoft.com/office/powerpoint/2010/main" val="1069416365"/>
+        <p14:creationId xmlns:p14="http://schemas.microsoft.com/office/powerpoint/2010/main" val="1254817020"/>
       </p:ext>
     </p:extLst>
   </p:cSld>
@@ -5667,7 +5667,7 @@
           <p:cNvPr id="2" name="Rechteck 1">
             <a:extLst>
               <a:ext uri="{FF2B5EF4-FFF2-40B4-BE49-F238E27FC236}">
-                <a16:creationId xmlns:a16="http://schemas.microsoft.com/office/drawing/2014/main" id="{567E20A9-19EC-F9E5-B7FE-9C26E3A38CCA}"/>
+                <a16:creationId xmlns:a16="http://schemas.microsoft.com/office/drawing/2014/main" id="{1E57D9DA-CF81-A532-B800-4214F4514E31}"/>
               </a:ext>
             </a:extLst>
           </p:cNvPr>
@@ -5735,7 +5735,7 @@
           <p:cNvPr id="3" name="Rechteck 2">
             <a:extLst>
               <a:ext uri="{FF2B5EF4-FFF2-40B4-BE49-F238E27FC236}">
-                <a16:creationId xmlns:a16="http://schemas.microsoft.com/office/drawing/2014/main" id="{AA508303-FFA2-707E-8E48-9623C8612671}"/>
+                <a16:creationId xmlns:a16="http://schemas.microsoft.com/office/drawing/2014/main" id="{F3128DCA-E57F-44F9-9082-72B6F2233AC7}"/>
               </a:ext>
             </a:extLst>
           </p:cNvPr>
@@ -5803,7 +5803,7 @@
           <p:cNvPr id="4" name="Textfeld 3">
             <a:extLst>
               <a:ext uri="{FF2B5EF4-FFF2-40B4-BE49-F238E27FC236}">
-                <a16:creationId xmlns:a16="http://schemas.microsoft.com/office/drawing/2014/main" id="{19E0F061-7260-2987-1DA5-6A033439C1A1}"/>
+                <a16:creationId xmlns:a16="http://schemas.microsoft.com/office/drawing/2014/main" id="{6510C5BF-6BE1-20B3-B545-4BD24E07BAF9}"/>
               </a:ext>
             </a:extLst>
           </p:cNvPr>
@@ -5843,7 +5843,7 @@
           <p:cNvPr id="5" name="Textfeld 4">
             <a:extLst>
               <a:ext uri="{FF2B5EF4-FFF2-40B4-BE49-F238E27FC236}">
-                <a16:creationId xmlns:a16="http://schemas.microsoft.com/office/drawing/2014/main" id="{D163863B-222D-FE64-9A58-7EB003656100}"/>
+                <a16:creationId xmlns:a16="http://schemas.microsoft.com/office/drawing/2014/main" id="{AE44CE41-B31F-F294-27C1-0070E2929236}"/>
               </a:ext>
             </a:extLst>
           </p:cNvPr>
@@ -5921,7 +5921,7 @@
           <p:cNvPr id="6" name="Textfeld 5">
             <a:extLst>
               <a:ext uri="{FF2B5EF4-FFF2-40B4-BE49-F238E27FC236}">
-                <a16:creationId xmlns:a16="http://schemas.microsoft.com/office/drawing/2014/main" id="{4BEF55A3-DA2A-CCBD-E8FA-97DFF5B4CC13}"/>
+                <a16:creationId xmlns:a16="http://schemas.microsoft.com/office/drawing/2014/main" id="{0CDFFA7D-4952-8E07-8379-09A6253954D2}"/>
               </a:ext>
             </a:extLst>
           </p:cNvPr>
@@ -5959,7 +5959,7 @@
     </p:spTree>
     <p:extLst>
       <p:ext uri="{BB962C8B-B14F-4D97-AF65-F5344CB8AC3E}">
-        <p14:creationId xmlns:p14="http://schemas.microsoft.com/office/powerpoint/2010/main" val="2385659242"/>
+        <p14:creationId xmlns:p14="http://schemas.microsoft.com/office/powerpoint/2010/main" val="2973424641"/>
       </p:ext>
     </p:extLst>
   </p:cSld>
@@ -5999,7 +5999,7 @@
           <p:cNvPr id="2" name="Rechteck 1">
             <a:extLst>
               <a:ext uri="{FF2B5EF4-FFF2-40B4-BE49-F238E27FC236}">
-                <a16:creationId xmlns:a16="http://schemas.microsoft.com/office/drawing/2014/main" id="{F666FC5C-E69A-953C-B140-D456FE16F37A}"/>
+                <a16:creationId xmlns:a16="http://schemas.microsoft.com/office/drawing/2014/main" id="{E2EC3A80-8482-5E9D-A87F-B593F22A3D5C}"/>
               </a:ext>
             </a:extLst>
           </p:cNvPr>
@@ -6067,7 +6067,7 @@
           <p:cNvPr id="3" name="Rechteck 2">
             <a:extLst>
               <a:ext uri="{FF2B5EF4-FFF2-40B4-BE49-F238E27FC236}">
-                <a16:creationId xmlns:a16="http://schemas.microsoft.com/office/drawing/2014/main" id="{D6CD6728-5518-3477-77F9-2CB264D9D040}"/>
+                <a16:creationId xmlns:a16="http://schemas.microsoft.com/office/drawing/2014/main" id="{981DDFE2-341D-BF0B-1663-E0D2C1EA93F6}"/>
               </a:ext>
             </a:extLst>
           </p:cNvPr>
@@ -6135,7 +6135,7 @@
           <p:cNvPr id="4" name="Textfeld 3">
             <a:extLst>
               <a:ext uri="{FF2B5EF4-FFF2-40B4-BE49-F238E27FC236}">
-                <a16:creationId xmlns:a16="http://schemas.microsoft.com/office/drawing/2014/main" id="{75CA7682-9B1D-ED20-478E-5B24C0A1D4FF}"/>
+                <a16:creationId xmlns:a16="http://schemas.microsoft.com/office/drawing/2014/main" id="{D7ADE1E3-5355-3473-4A7B-DA5CE059350C}"/>
               </a:ext>
             </a:extLst>
           </p:cNvPr>
@@ -6175,7 +6175,7 @@
           <p:cNvPr id="5" name="Textfeld 4">
             <a:extLst>
               <a:ext uri="{FF2B5EF4-FFF2-40B4-BE49-F238E27FC236}">
-                <a16:creationId xmlns:a16="http://schemas.microsoft.com/office/drawing/2014/main" id="{F08E907E-BD60-FAF0-26CA-A50087D63FCD}"/>
+                <a16:creationId xmlns:a16="http://schemas.microsoft.com/office/drawing/2014/main" id="{4765296D-5B12-97DF-814C-F43B5F5CA66E}"/>
               </a:ext>
             </a:extLst>
           </p:cNvPr>
@@ -6253,7 +6253,7 @@
           <p:cNvPr id="6" name="Textfeld 5">
             <a:extLst>
               <a:ext uri="{FF2B5EF4-FFF2-40B4-BE49-F238E27FC236}">
-                <a16:creationId xmlns:a16="http://schemas.microsoft.com/office/drawing/2014/main" id="{D05103F3-D1CF-1431-F83A-E1FC314AC992}"/>
+                <a16:creationId xmlns:a16="http://schemas.microsoft.com/office/drawing/2014/main" id="{283F6149-3328-79E1-5622-9D66E053EA84}"/>
               </a:ext>
             </a:extLst>
           </p:cNvPr>
@@ -6291,7 +6291,7 @@
     </p:spTree>
     <p:extLst>
       <p:ext uri="{BB962C8B-B14F-4D97-AF65-F5344CB8AC3E}">
-        <p14:creationId xmlns:p14="http://schemas.microsoft.com/office/powerpoint/2010/main" val="3040517359"/>
+        <p14:creationId xmlns:p14="http://schemas.microsoft.com/office/powerpoint/2010/main" val="1020400736"/>
       </p:ext>
     </p:extLst>
   </p:cSld>
@@ -6331,7 +6331,7 @@
           <p:cNvPr id="2" name="Rechteck 1">
             <a:extLst>
               <a:ext uri="{FF2B5EF4-FFF2-40B4-BE49-F238E27FC236}">
-                <a16:creationId xmlns:a16="http://schemas.microsoft.com/office/drawing/2014/main" id="{C61B7628-F986-4EB9-5891-1EDBF4208C8F}"/>
+                <a16:creationId xmlns:a16="http://schemas.microsoft.com/office/drawing/2014/main" id="{E5EA22A7-87E9-4BBF-0E42-65D9945F9E50}"/>
               </a:ext>
             </a:extLst>
           </p:cNvPr>
@@ -6399,7 +6399,7 @@
           <p:cNvPr id="3" name="Rechteck 2">
             <a:extLst>
               <a:ext uri="{FF2B5EF4-FFF2-40B4-BE49-F238E27FC236}">
-                <a16:creationId xmlns:a16="http://schemas.microsoft.com/office/drawing/2014/main" id="{35C7911E-89BB-250E-1780-411E83AE723E}"/>
+                <a16:creationId xmlns:a16="http://schemas.microsoft.com/office/drawing/2014/main" id="{92937CB7-C9B8-D115-2C80-9E6BF5617985}"/>
               </a:ext>
             </a:extLst>
           </p:cNvPr>
@@ -6467,7 +6467,7 @@
           <p:cNvPr id="4" name="Textfeld 3">
             <a:extLst>
               <a:ext uri="{FF2B5EF4-FFF2-40B4-BE49-F238E27FC236}">
-                <a16:creationId xmlns:a16="http://schemas.microsoft.com/office/drawing/2014/main" id="{57401A94-D674-E408-2647-DD067DC1F2E9}"/>
+                <a16:creationId xmlns:a16="http://schemas.microsoft.com/office/drawing/2014/main" id="{5AD2057C-B2A7-10FB-541A-767C4CD83DAE}"/>
               </a:ext>
             </a:extLst>
           </p:cNvPr>
@@ -6507,7 +6507,7 @@
           <p:cNvPr id="5" name="Textfeld 4">
             <a:extLst>
               <a:ext uri="{FF2B5EF4-FFF2-40B4-BE49-F238E27FC236}">
-                <a16:creationId xmlns:a16="http://schemas.microsoft.com/office/drawing/2014/main" id="{DEF07390-219B-F568-A2C9-89414BE739F2}"/>
+                <a16:creationId xmlns:a16="http://schemas.microsoft.com/office/drawing/2014/main" id="{3B7B52ED-8B26-4001-F22B-DAE485711FB0}"/>
               </a:ext>
             </a:extLst>
           </p:cNvPr>
@@ -6517,7 +6517,7 @@
         <p:spPr>
           <a:xfrm>
             <a:off x="889000" y="1854200"/>
-            <a:ext cx="10160000" cy="1667123"/>
+            <a:ext cx="10160000" cy="2544286"/>
           </a:xfrm>
           <a:prstGeom prst="rect">
             <a:avLst/>
@@ -6537,7 +6537,7 @@
                 </a:solidFill>
                 <a:latin typeface="Arial" panose="020B0604020202020204" pitchFamily="34" charset="0"/>
               </a:rPr>
-              <a:t>• Der Projekt-Monitor ist für eine spätere Freigabe vorgesehen und wird nach ausdrücklicher Upload-/Deploy-Freigabe nachgereicht.</a:t>
+              <a:t>• Geplanter Projekt-Monitor:</a:t>
             </a:r>
           </a:p>
           <a:p>
@@ -6556,7 +6556,45 @@
                 </a:solidFill>
                 <a:latin typeface="Arial" panose="020B0604020202020204" pitchFamily="34" charset="0"/>
               </a:rPr>
-              <a:t>• Derzeit ist kein öffentlicher Projektlink aktiv. Es wurde kein Push, kein Upload und kein Deploy freigegeben.</a:t>
+              <a:t>• https://sari-raslan.github.io/universal-arranger-os/jobcenter/</a:t>
+            </a:r>
+          </a:p>
+          <a:p>
+            <a:endParaRPr lang="de-DE" sz="1900">
+              <a:solidFill>
+                <a:srgbClr val="E6E6E6"/>
+              </a:solidFill>
+              <a:latin typeface="Arial" panose="020B0604020202020204" pitchFamily="34" charset="0"/>
+            </a:endParaRPr>
+          </a:p>
+          <a:p>
+            <a:r>
+              <a:rPr lang="de-DE" sz="1900">
+                <a:solidFill>
+                  <a:srgbClr val="E6E6E6"/>
+                </a:solidFill>
+                <a:latin typeface="Arial" panose="020B0604020202020204" pitchFamily="34" charset="0"/>
+              </a:rPr>
+              <a:t>• Status:</a:t>
+            </a:r>
+          </a:p>
+          <a:p>
+            <a:endParaRPr lang="de-DE" sz="1900">
+              <a:solidFill>
+                <a:srgbClr val="E6E6E6"/>
+              </a:solidFill>
+              <a:latin typeface="Arial" panose="020B0604020202020204" pitchFamily="34" charset="0"/>
+            </a:endParaRPr>
+          </a:p>
+          <a:p>
+            <a:r>
+              <a:rPr lang="de-DE" sz="1900">
+                <a:solidFill>
+                  <a:srgbClr val="E6E6E6"/>
+                </a:solidFill>
+                <a:latin typeface="Arial" panose="020B0604020202020204" pitchFamily="34" charset="0"/>
+              </a:rPr>
+              <a:t>• Der Link ist derzeit noch nicht öffentlich aktiv. Er wird erst nach ausdrücklicher Upload-/Deploy-Freigabe aktiviert. Es wurde kein Push, kein Upload und kein Deploy freigegeben.</a:t>
             </a:r>
           </a:p>
         </p:txBody>
@@ -6566,7 +6604,7 @@
           <p:cNvPr id="6" name="Textfeld 5">
             <a:extLst>
               <a:ext uri="{FF2B5EF4-FFF2-40B4-BE49-F238E27FC236}">
-                <a16:creationId xmlns:a16="http://schemas.microsoft.com/office/drawing/2014/main" id="{55C48916-2FA2-84C2-5272-99A68C30F41D}"/>
+                <a16:creationId xmlns:a16="http://schemas.microsoft.com/office/drawing/2014/main" id="{1BE33CD2-6F41-5E23-7E62-8DE390D0B621}"/>
               </a:ext>
             </a:extLst>
           </p:cNvPr>
@@ -6604,7 +6642,7 @@
     </p:spTree>
     <p:extLst>
       <p:ext uri="{BB962C8B-B14F-4D97-AF65-F5344CB8AC3E}">
-        <p14:creationId xmlns:p14="http://schemas.microsoft.com/office/powerpoint/2010/main" val="1665126923"/>
+        <p14:creationId xmlns:p14="http://schemas.microsoft.com/office/powerpoint/2010/main" val="1991514361"/>
       </p:ext>
     </p:extLst>
   </p:cSld>

</xml_diff>

<commit_message>
Remove inactive Jobcenter monitor URL from final send-ready pack
</commit_message>
<xml_diff>
--- a/uaos-ai-factory/jobcenter-send-ready/UAOS_JOBCENTER_PRESENTATION_2026-07-01_DE.pptx
+++ b/uaos-ai-factory/jobcenter-send-ready/UAOS_JOBCENTER_PRESENTATION_2026-07-01_DE.pptx
@@ -138,7 +138,7 @@
           <p:cNvPr id="2" name="Titel 1">
             <a:extLst>
               <a:ext uri="{FF2B5EF4-FFF2-40B4-BE49-F238E27FC236}">
-                <a16:creationId xmlns:a16="http://schemas.microsoft.com/office/drawing/2014/main" id="{B5ACD904-75DC-1D59-61E9-27E5E89814D1}"/>
+                <a16:creationId xmlns:a16="http://schemas.microsoft.com/office/drawing/2014/main" id="{04F839AF-C4C1-32C5-5DC6-AAEF6C7D3C3F}"/>
               </a:ext>
             </a:extLst>
           </p:cNvPr>
@@ -175,7 +175,7 @@
           <p:cNvPr id="3" name="Untertitel 2">
             <a:extLst>
               <a:ext uri="{FF2B5EF4-FFF2-40B4-BE49-F238E27FC236}">
-                <a16:creationId xmlns:a16="http://schemas.microsoft.com/office/drawing/2014/main" id="{7120E6AD-E2E0-E038-930E-11B9EFD547CF}"/>
+                <a16:creationId xmlns:a16="http://schemas.microsoft.com/office/drawing/2014/main" id="{B632D4C4-E2EC-08B1-0A40-70560E17028C}"/>
               </a:ext>
             </a:extLst>
           </p:cNvPr>
@@ -245,7 +245,7 @@
           <p:cNvPr id="4" name="Datumsplatzhalter 3">
             <a:extLst>
               <a:ext uri="{FF2B5EF4-FFF2-40B4-BE49-F238E27FC236}">
-                <a16:creationId xmlns:a16="http://schemas.microsoft.com/office/drawing/2014/main" id="{E81306D2-482A-F278-E08B-09EC3765ED04}"/>
+                <a16:creationId xmlns:a16="http://schemas.microsoft.com/office/drawing/2014/main" id="{91C5D034-176B-84DB-2C55-5DFE6D9ECFFB}"/>
               </a:ext>
             </a:extLst>
           </p:cNvPr>
@@ -261,7 +261,7 @@
           <a:bodyPr/>
           <a:lstStyle/>
           <a:p>
-            <a:fld id="{363C6B2F-0EB9-4825-8B3F-3C3C5B83126B}" type="datetimeFigureOut">
+            <a:fld id="{C34BCCBE-FFF1-4213-A060-BD0744E7F377}" type="datetimeFigureOut">
               <a:rPr lang="de-DE" smtClean="0"/>
               <a:t>01.07.2026</a:t>
             </a:fld>
@@ -274,7 +274,7 @@
           <p:cNvPr id="5" name="Fußzeilenplatzhalter 4">
             <a:extLst>
               <a:ext uri="{FF2B5EF4-FFF2-40B4-BE49-F238E27FC236}">
-                <a16:creationId xmlns:a16="http://schemas.microsoft.com/office/drawing/2014/main" id="{2E2F9342-E160-3AA8-18E3-A0B4307FCBAA}"/>
+                <a16:creationId xmlns:a16="http://schemas.microsoft.com/office/drawing/2014/main" id="{9F3AB7C6-B84E-5F88-096E-91DBF38BEAD7}"/>
               </a:ext>
             </a:extLst>
           </p:cNvPr>
@@ -299,7 +299,7 @@
           <p:cNvPr id="6" name="Foliennummernplatzhalter 5">
             <a:extLst>
               <a:ext uri="{FF2B5EF4-FFF2-40B4-BE49-F238E27FC236}">
-                <a16:creationId xmlns:a16="http://schemas.microsoft.com/office/drawing/2014/main" id="{59FB6AED-DF50-987B-F1DD-A56148D3EC5D}"/>
+                <a16:creationId xmlns:a16="http://schemas.microsoft.com/office/drawing/2014/main" id="{F157A27E-517D-732B-BEFF-A3552D3B4DAD}"/>
               </a:ext>
             </a:extLst>
           </p:cNvPr>
@@ -315,7 +315,7 @@
           <a:bodyPr/>
           <a:lstStyle/>
           <a:p>
-            <a:fld id="{D36C3734-E1F4-419B-9C5E-DD98F76C0988}" type="slidenum">
+            <a:fld id="{6A1B2D6F-A1C6-4069-816D-FEC1538C4AD2}" type="slidenum">
               <a:rPr lang="de-DE" smtClean="0"/>
               <a:t>‹Nr.›</a:t>
             </a:fld>
@@ -326,7 +326,7 @@
     </p:spTree>
     <p:extLst>
       <p:ext uri="{BB962C8B-B14F-4D97-AF65-F5344CB8AC3E}">
-        <p14:creationId xmlns:p14="http://schemas.microsoft.com/office/powerpoint/2010/main" val="3417246299"/>
+        <p14:creationId xmlns:p14="http://schemas.microsoft.com/office/powerpoint/2010/main" val="1704349254"/>
       </p:ext>
     </p:extLst>
   </p:cSld>
@@ -358,7 +358,7 @@
           <p:cNvPr id="2" name="Titel 1">
             <a:extLst>
               <a:ext uri="{FF2B5EF4-FFF2-40B4-BE49-F238E27FC236}">
-                <a16:creationId xmlns:a16="http://schemas.microsoft.com/office/drawing/2014/main" id="{82B0448B-14B6-84B8-BE2E-6151C80442F4}"/>
+                <a16:creationId xmlns:a16="http://schemas.microsoft.com/office/drawing/2014/main" id="{7182612E-EFD9-0B10-6ED3-89A42CAE74BC}"/>
               </a:ext>
             </a:extLst>
           </p:cNvPr>
@@ -386,7 +386,7 @@
           <p:cNvPr id="3" name="Vertikaler Textplatzhalter 2">
             <a:extLst>
               <a:ext uri="{FF2B5EF4-FFF2-40B4-BE49-F238E27FC236}">
-                <a16:creationId xmlns:a16="http://schemas.microsoft.com/office/drawing/2014/main" id="{FD7DBB8B-5DCA-249D-0413-9EC2E8C4582A}"/>
+                <a16:creationId xmlns:a16="http://schemas.microsoft.com/office/drawing/2014/main" id="{DBE20EF3-233B-3979-4EC8-1085852E800B}"/>
               </a:ext>
             </a:extLst>
           </p:cNvPr>
@@ -443,7 +443,7 @@
           <p:cNvPr id="4" name="Datumsplatzhalter 3">
             <a:extLst>
               <a:ext uri="{FF2B5EF4-FFF2-40B4-BE49-F238E27FC236}">
-                <a16:creationId xmlns:a16="http://schemas.microsoft.com/office/drawing/2014/main" id="{6E263608-89CB-B222-9749-002575BDE998}"/>
+                <a16:creationId xmlns:a16="http://schemas.microsoft.com/office/drawing/2014/main" id="{292A5928-6D38-72A4-DECF-CEAEB3789F8D}"/>
               </a:ext>
             </a:extLst>
           </p:cNvPr>
@@ -459,7 +459,7 @@
           <a:bodyPr/>
           <a:lstStyle/>
           <a:p>
-            <a:fld id="{363C6B2F-0EB9-4825-8B3F-3C3C5B83126B}" type="datetimeFigureOut">
+            <a:fld id="{C34BCCBE-FFF1-4213-A060-BD0744E7F377}" type="datetimeFigureOut">
               <a:rPr lang="de-DE" smtClean="0"/>
               <a:t>01.07.2026</a:t>
             </a:fld>
@@ -472,7 +472,7 @@
           <p:cNvPr id="5" name="Fußzeilenplatzhalter 4">
             <a:extLst>
               <a:ext uri="{FF2B5EF4-FFF2-40B4-BE49-F238E27FC236}">
-                <a16:creationId xmlns:a16="http://schemas.microsoft.com/office/drawing/2014/main" id="{462AD8A4-BB25-D935-FE60-F7B13A65D0DA}"/>
+                <a16:creationId xmlns:a16="http://schemas.microsoft.com/office/drawing/2014/main" id="{41C0ADD8-3279-F4C6-5DC2-01095FAAF088}"/>
               </a:ext>
             </a:extLst>
           </p:cNvPr>
@@ -497,7 +497,7 @@
           <p:cNvPr id="6" name="Foliennummernplatzhalter 5">
             <a:extLst>
               <a:ext uri="{FF2B5EF4-FFF2-40B4-BE49-F238E27FC236}">
-                <a16:creationId xmlns:a16="http://schemas.microsoft.com/office/drawing/2014/main" id="{48176FDE-B514-6254-E66F-109AAB6D9D98}"/>
+                <a16:creationId xmlns:a16="http://schemas.microsoft.com/office/drawing/2014/main" id="{1A25037E-04F0-F106-6F7E-323362DA8E61}"/>
               </a:ext>
             </a:extLst>
           </p:cNvPr>
@@ -513,7 +513,7 @@
           <a:bodyPr/>
           <a:lstStyle/>
           <a:p>
-            <a:fld id="{D36C3734-E1F4-419B-9C5E-DD98F76C0988}" type="slidenum">
+            <a:fld id="{6A1B2D6F-A1C6-4069-816D-FEC1538C4AD2}" type="slidenum">
               <a:rPr lang="de-DE" smtClean="0"/>
               <a:t>‹Nr.›</a:t>
             </a:fld>
@@ -524,7 +524,7 @@
     </p:spTree>
     <p:extLst>
       <p:ext uri="{BB962C8B-B14F-4D97-AF65-F5344CB8AC3E}">
-        <p14:creationId xmlns:p14="http://schemas.microsoft.com/office/powerpoint/2010/main" val="1597861993"/>
+        <p14:creationId xmlns:p14="http://schemas.microsoft.com/office/powerpoint/2010/main" val="3906858677"/>
       </p:ext>
     </p:extLst>
   </p:cSld>
@@ -556,7 +556,7 @@
           <p:cNvPr id="2" name="Vertikaler Titel 1">
             <a:extLst>
               <a:ext uri="{FF2B5EF4-FFF2-40B4-BE49-F238E27FC236}">
-                <a16:creationId xmlns:a16="http://schemas.microsoft.com/office/drawing/2014/main" id="{9933CD0C-7557-31F2-9FDA-78C6494DA211}"/>
+                <a16:creationId xmlns:a16="http://schemas.microsoft.com/office/drawing/2014/main" id="{10B2DCC1-A849-647E-6FB1-47B04E489818}"/>
               </a:ext>
             </a:extLst>
           </p:cNvPr>
@@ -589,7 +589,7 @@
           <p:cNvPr id="3" name="Vertikaler Textplatzhalter 2">
             <a:extLst>
               <a:ext uri="{FF2B5EF4-FFF2-40B4-BE49-F238E27FC236}">
-                <a16:creationId xmlns:a16="http://schemas.microsoft.com/office/drawing/2014/main" id="{53BEFD0D-51ED-656B-70D2-73510E2CE465}"/>
+                <a16:creationId xmlns:a16="http://schemas.microsoft.com/office/drawing/2014/main" id="{716C4B5F-7907-9255-5C90-96D88CBB7F8C}"/>
               </a:ext>
             </a:extLst>
           </p:cNvPr>
@@ -651,7 +651,7 @@
           <p:cNvPr id="4" name="Datumsplatzhalter 3">
             <a:extLst>
               <a:ext uri="{FF2B5EF4-FFF2-40B4-BE49-F238E27FC236}">
-                <a16:creationId xmlns:a16="http://schemas.microsoft.com/office/drawing/2014/main" id="{41A937FB-1514-8329-CF50-7C7D27AAFDC0}"/>
+                <a16:creationId xmlns:a16="http://schemas.microsoft.com/office/drawing/2014/main" id="{C99A9AE2-B6A3-8316-AC74-1D42D0E37CE9}"/>
               </a:ext>
             </a:extLst>
           </p:cNvPr>
@@ -667,7 +667,7 @@
           <a:bodyPr/>
           <a:lstStyle/>
           <a:p>
-            <a:fld id="{363C6B2F-0EB9-4825-8B3F-3C3C5B83126B}" type="datetimeFigureOut">
+            <a:fld id="{C34BCCBE-FFF1-4213-A060-BD0744E7F377}" type="datetimeFigureOut">
               <a:rPr lang="de-DE" smtClean="0"/>
               <a:t>01.07.2026</a:t>
             </a:fld>
@@ -680,7 +680,7 @@
           <p:cNvPr id="5" name="Fußzeilenplatzhalter 4">
             <a:extLst>
               <a:ext uri="{FF2B5EF4-FFF2-40B4-BE49-F238E27FC236}">
-                <a16:creationId xmlns:a16="http://schemas.microsoft.com/office/drawing/2014/main" id="{1D3AADC8-D3E0-C29D-F621-C2A924664667}"/>
+                <a16:creationId xmlns:a16="http://schemas.microsoft.com/office/drawing/2014/main" id="{DBA1140C-A506-9926-9004-2D773CF1B451}"/>
               </a:ext>
             </a:extLst>
           </p:cNvPr>
@@ -705,7 +705,7 @@
           <p:cNvPr id="6" name="Foliennummernplatzhalter 5">
             <a:extLst>
               <a:ext uri="{FF2B5EF4-FFF2-40B4-BE49-F238E27FC236}">
-                <a16:creationId xmlns:a16="http://schemas.microsoft.com/office/drawing/2014/main" id="{A7048438-BCA5-C402-C48E-34D9143B4253}"/>
+                <a16:creationId xmlns:a16="http://schemas.microsoft.com/office/drawing/2014/main" id="{C2287C2D-1D15-F63C-E231-E67C2D00A775}"/>
               </a:ext>
             </a:extLst>
           </p:cNvPr>
@@ -721,7 +721,7 @@
           <a:bodyPr/>
           <a:lstStyle/>
           <a:p>
-            <a:fld id="{D36C3734-E1F4-419B-9C5E-DD98F76C0988}" type="slidenum">
+            <a:fld id="{6A1B2D6F-A1C6-4069-816D-FEC1538C4AD2}" type="slidenum">
               <a:rPr lang="de-DE" smtClean="0"/>
               <a:t>‹Nr.›</a:t>
             </a:fld>
@@ -732,7 +732,7 @@
     </p:spTree>
     <p:extLst>
       <p:ext uri="{BB962C8B-B14F-4D97-AF65-F5344CB8AC3E}">
-        <p14:creationId xmlns:p14="http://schemas.microsoft.com/office/powerpoint/2010/main" val="2670658476"/>
+        <p14:creationId xmlns:p14="http://schemas.microsoft.com/office/powerpoint/2010/main" val="1479298349"/>
       </p:ext>
     </p:extLst>
   </p:cSld>
@@ -764,7 +764,7 @@
           <p:cNvPr id="2" name="Titel 1">
             <a:extLst>
               <a:ext uri="{FF2B5EF4-FFF2-40B4-BE49-F238E27FC236}">
-                <a16:creationId xmlns:a16="http://schemas.microsoft.com/office/drawing/2014/main" id="{82FF80C1-1DCC-A8C2-AFF8-E554B02F1E2B}"/>
+                <a16:creationId xmlns:a16="http://schemas.microsoft.com/office/drawing/2014/main" id="{D1A1D1C2-F456-96DA-A0CB-D243366B9450}"/>
               </a:ext>
             </a:extLst>
           </p:cNvPr>
@@ -792,7 +792,7 @@
           <p:cNvPr id="3" name="Inhaltsplatzhalter 2">
             <a:extLst>
               <a:ext uri="{FF2B5EF4-FFF2-40B4-BE49-F238E27FC236}">
-                <a16:creationId xmlns:a16="http://schemas.microsoft.com/office/drawing/2014/main" id="{EA643ACC-27C1-0F30-39C8-75C7D1181D92}"/>
+                <a16:creationId xmlns:a16="http://schemas.microsoft.com/office/drawing/2014/main" id="{BCCAC7D2-1B62-C036-38BD-3A654547A23A}"/>
               </a:ext>
             </a:extLst>
           </p:cNvPr>
@@ -849,7 +849,7 @@
           <p:cNvPr id="4" name="Datumsplatzhalter 3">
             <a:extLst>
               <a:ext uri="{FF2B5EF4-FFF2-40B4-BE49-F238E27FC236}">
-                <a16:creationId xmlns:a16="http://schemas.microsoft.com/office/drawing/2014/main" id="{95793594-B919-2322-576C-AE21F2079A60}"/>
+                <a16:creationId xmlns:a16="http://schemas.microsoft.com/office/drawing/2014/main" id="{87B93466-2242-6F8A-048D-3090AF87605E}"/>
               </a:ext>
             </a:extLst>
           </p:cNvPr>
@@ -865,7 +865,7 @@
           <a:bodyPr/>
           <a:lstStyle/>
           <a:p>
-            <a:fld id="{363C6B2F-0EB9-4825-8B3F-3C3C5B83126B}" type="datetimeFigureOut">
+            <a:fld id="{C34BCCBE-FFF1-4213-A060-BD0744E7F377}" type="datetimeFigureOut">
               <a:rPr lang="de-DE" smtClean="0"/>
               <a:t>01.07.2026</a:t>
             </a:fld>
@@ -878,7 +878,7 @@
           <p:cNvPr id="5" name="Fußzeilenplatzhalter 4">
             <a:extLst>
               <a:ext uri="{FF2B5EF4-FFF2-40B4-BE49-F238E27FC236}">
-                <a16:creationId xmlns:a16="http://schemas.microsoft.com/office/drawing/2014/main" id="{E6B94988-5AFF-1BDE-1945-9CE784F9C9C4}"/>
+                <a16:creationId xmlns:a16="http://schemas.microsoft.com/office/drawing/2014/main" id="{400EE4EF-61E1-6696-5CE6-8654C3AD378E}"/>
               </a:ext>
             </a:extLst>
           </p:cNvPr>
@@ -903,7 +903,7 @@
           <p:cNvPr id="6" name="Foliennummernplatzhalter 5">
             <a:extLst>
               <a:ext uri="{FF2B5EF4-FFF2-40B4-BE49-F238E27FC236}">
-                <a16:creationId xmlns:a16="http://schemas.microsoft.com/office/drawing/2014/main" id="{78199769-8E31-C740-01FF-5EC5B241E2A8}"/>
+                <a16:creationId xmlns:a16="http://schemas.microsoft.com/office/drawing/2014/main" id="{9E3E28F8-CD53-8291-E509-F46212B2BCBC}"/>
               </a:ext>
             </a:extLst>
           </p:cNvPr>
@@ -919,7 +919,7 @@
           <a:bodyPr/>
           <a:lstStyle/>
           <a:p>
-            <a:fld id="{D36C3734-E1F4-419B-9C5E-DD98F76C0988}" type="slidenum">
+            <a:fld id="{6A1B2D6F-A1C6-4069-816D-FEC1538C4AD2}" type="slidenum">
               <a:rPr lang="de-DE" smtClean="0"/>
               <a:t>‹Nr.›</a:t>
             </a:fld>
@@ -930,7 +930,7 @@
     </p:spTree>
     <p:extLst>
       <p:ext uri="{BB962C8B-B14F-4D97-AF65-F5344CB8AC3E}">
-        <p14:creationId xmlns:p14="http://schemas.microsoft.com/office/powerpoint/2010/main" val="1568535701"/>
+        <p14:creationId xmlns:p14="http://schemas.microsoft.com/office/powerpoint/2010/main" val="958933273"/>
       </p:ext>
     </p:extLst>
   </p:cSld>
@@ -962,7 +962,7 @@
           <p:cNvPr id="2" name="Titel 1">
             <a:extLst>
               <a:ext uri="{FF2B5EF4-FFF2-40B4-BE49-F238E27FC236}">
-                <a16:creationId xmlns:a16="http://schemas.microsoft.com/office/drawing/2014/main" id="{46FBCB9E-4161-8899-0698-773001446314}"/>
+                <a16:creationId xmlns:a16="http://schemas.microsoft.com/office/drawing/2014/main" id="{A743550E-C922-1510-6B82-51F3BDA30F61}"/>
               </a:ext>
             </a:extLst>
           </p:cNvPr>
@@ -999,7 +999,7 @@
           <p:cNvPr id="3" name="Textplatzhalter 2">
             <a:extLst>
               <a:ext uri="{FF2B5EF4-FFF2-40B4-BE49-F238E27FC236}">
-                <a16:creationId xmlns:a16="http://schemas.microsoft.com/office/drawing/2014/main" id="{D97C947B-4602-BC6F-9055-FD65C627AA0E}"/>
+                <a16:creationId xmlns:a16="http://schemas.microsoft.com/office/drawing/2014/main" id="{E12D192B-25D5-4E70-6027-E788E7EC0C38}"/>
               </a:ext>
             </a:extLst>
           </p:cNvPr>
@@ -1124,7 +1124,7 @@
           <p:cNvPr id="4" name="Datumsplatzhalter 3">
             <a:extLst>
               <a:ext uri="{FF2B5EF4-FFF2-40B4-BE49-F238E27FC236}">
-                <a16:creationId xmlns:a16="http://schemas.microsoft.com/office/drawing/2014/main" id="{DE59A43F-3126-E0F0-44D6-C8B4620ADB7F}"/>
+                <a16:creationId xmlns:a16="http://schemas.microsoft.com/office/drawing/2014/main" id="{EDD53759-FAA1-A702-CBCD-F7AD10FA169C}"/>
               </a:ext>
             </a:extLst>
           </p:cNvPr>
@@ -1140,7 +1140,7 @@
           <a:bodyPr/>
           <a:lstStyle/>
           <a:p>
-            <a:fld id="{363C6B2F-0EB9-4825-8B3F-3C3C5B83126B}" type="datetimeFigureOut">
+            <a:fld id="{C34BCCBE-FFF1-4213-A060-BD0744E7F377}" type="datetimeFigureOut">
               <a:rPr lang="de-DE" smtClean="0"/>
               <a:t>01.07.2026</a:t>
             </a:fld>
@@ -1153,7 +1153,7 @@
           <p:cNvPr id="5" name="Fußzeilenplatzhalter 4">
             <a:extLst>
               <a:ext uri="{FF2B5EF4-FFF2-40B4-BE49-F238E27FC236}">
-                <a16:creationId xmlns:a16="http://schemas.microsoft.com/office/drawing/2014/main" id="{C0CC2093-0550-CCC7-E299-6CD27201D26C}"/>
+                <a16:creationId xmlns:a16="http://schemas.microsoft.com/office/drawing/2014/main" id="{ACAB352B-180B-DD7F-65D5-5312EC3A63A7}"/>
               </a:ext>
             </a:extLst>
           </p:cNvPr>
@@ -1178,7 +1178,7 @@
           <p:cNvPr id="6" name="Foliennummernplatzhalter 5">
             <a:extLst>
               <a:ext uri="{FF2B5EF4-FFF2-40B4-BE49-F238E27FC236}">
-                <a16:creationId xmlns:a16="http://schemas.microsoft.com/office/drawing/2014/main" id="{F62ABDAF-6AB5-F37C-0F93-CEE3F66F0E54}"/>
+                <a16:creationId xmlns:a16="http://schemas.microsoft.com/office/drawing/2014/main" id="{8402C9F7-8D68-B857-81D2-F630EFA5134A}"/>
               </a:ext>
             </a:extLst>
           </p:cNvPr>
@@ -1194,7 +1194,7 @@
           <a:bodyPr/>
           <a:lstStyle/>
           <a:p>
-            <a:fld id="{D36C3734-E1F4-419B-9C5E-DD98F76C0988}" type="slidenum">
+            <a:fld id="{6A1B2D6F-A1C6-4069-816D-FEC1538C4AD2}" type="slidenum">
               <a:rPr lang="de-DE" smtClean="0"/>
               <a:t>‹Nr.›</a:t>
             </a:fld>
@@ -1205,7 +1205,7 @@
     </p:spTree>
     <p:extLst>
       <p:ext uri="{BB962C8B-B14F-4D97-AF65-F5344CB8AC3E}">
-        <p14:creationId xmlns:p14="http://schemas.microsoft.com/office/powerpoint/2010/main" val="3348322176"/>
+        <p14:creationId xmlns:p14="http://schemas.microsoft.com/office/powerpoint/2010/main" val="489053116"/>
       </p:ext>
     </p:extLst>
   </p:cSld>
@@ -1237,7 +1237,7 @@
           <p:cNvPr id="2" name="Titel 1">
             <a:extLst>
               <a:ext uri="{FF2B5EF4-FFF2-40B4-BE49-F238E27FC236}">
-                <a16:creationId xmlns:a16="http://schemas.microsoft.com/office/drawing/2014/main" id="{AD5AA5DA-9064-B3B0-DB30-81EB2E6B6D66}"/>
+                <a16:creationId xmlns:a16="http://schemas.microsoft.com/office/drawing/2014/main" id="{D74947CE-3865-CBE0-CD3F-564F8B121517}"/>
               </a:ext>
             </a:extLst>
           </p:cNvPr>
@@ -1265,7 +1265,7 @@
           <p:cNvPr id="3" name="Inhaltsplatzhalter 2">
             <a:extLst>
               <a:ext uri="{FF2B5EF4-FFF2-40B4-BE49-F238E27FC236}">
-                <a16:creationId xmlns:a16="http://schemas.microsoft.com/office/drawing/2014/main" id="{136A1642-B451-1502-76EE-80BDB8111814}"/>
+                <a16:creationId xmlns:a16="http://schemas.microsoft.com/office/drawing/2014/main" id="{E48CA721-989A-09B1-DE7E-7B15DE9EF444}"/>
               </a:ext>
             </a:extLst>
           </p:cNvPr>
@@ -1327,7 +1327,7 @@
           <p:cNvPr id="4" name="Inhaltsplatzhalter 3">
             <a:extLst>
               <a:ext uri="{FF2B5EF4-FFF2-40B4-BE49-F238E27FC236}">
-                <a16:creationId xmlns:a16="http://schemas.microsoft.com/office/drawing/2014/main" id="{F888A5A7-AC42-D6C9-799E-805B7E3CDC28}"/>
+                <a16:creationId xmlns:a16="http://schemas.microsoft.com/office/drawing/2014/main" id="{B8465D31-F78A-C2F0-F970-A1F1F72C487C}"/>
               </a:ext>
             </a:extLst>
           </p:cNvPr>
@@ -1389,7 +1389,7 @@
           <p:cNvPr id="5" name="Datumsplatzhalter 4">
             <a:extLst>
               <a:ext uri="{FF2B5EF4-FFF2-40B4-BE49-F238E27FC236}">
-                <a16:creationId xmlns:a16="http://schemas.microsoft.com/office/drawing/2014/main" id="{992876ED-532C-CB62-80E9-176CBB4F5B0E}"/>
+                <a16:creationId xmlns:a16="http://schemas.microsoft.com/office/drawing/2014/main" id="{4AC35863-872A-F094-971D-CFEACD5F5513}"/>
               </a:ext>
             </a:extLst>
           </p:cNvPr>
@@ -1405,7 +1405,7 @@
           <a:bodyPr/>
           <a:lstStyle/>
           <a:p>
-            <a:fld id="{363C6B2F-0EB9-4825-8B3F-3C3C5B83126B}" type="datetimeFigureOut">
+            <a:fld id="{C34BCCBE-FFF1-4213-A060-BD0744E7F377}" type="datetimeFigureOut">
               <a:rPr lang="de-DE" smtClean="0"/>
               <a:t>01.07.2026</a:t>
             </a:fld>
@@ -1418,7 +1418,7 @@
           <p:cNvPr id="6" name="Fußzeilenplatzhalter 5">
             <a:extLst>
               <a:ext uri="{FF2B5EF4-FFF2-40B4-BE49-F238E27FC236}">
-                <a16:creationId xmlns:a16="http://schemas.microsoft.com/office/drawing/2014/main" id="{FFBE4D4A-04D1-B862-1F78-1BCBCE500576}"/>
+                <a16:creationId xmlns:a16="http://schemas.microsoft.com/office/drawing/2014/main" id="{A901A54A-E929-36E2-8927-D513820F823A}"/>
               </a:ext>
             </a:extLst>
           </p:cNvPr>
@@ -1443,7 +1443,7 @@
           <p:cNvPr id="7" name="Foliennummernplatzhalter 6">
             <a:extLst>
               <a:ext uri="{FF2B5EF4-FFF2-40B4-BE49-F238E27FC236}">
-                <a16:creationId xmlns:a16="http://schemas.microsoft.com/office/drawing/2014/main" id="{DB7FD1F9-28A8-F3BD-6224-AB3EC543E40E}"/>
+                <a16:creationId xmlns:a16="http://schemas.microsoft.com/office/drawing/2014/main" id="{188F1D34-CF1D-3B64-0E0C-B5454AAD9A9A}"/>
               </a:ext>
             </a:extLst>
           </p:cNvPr>
@@ -1459,7 +1459,7 @@
           <a:bodyPr/>
           <a:lstStyle/>
           <a:p>
-            <a:fld id="{D36C3734-E1F4-419B-9C5E-DD98F76C0988}" type="slidenum">
+            <a:fld id="{6A1B2D6F-A1C6-4069-816D-FEC1538C4AD2}" type="slidenum">
               <a:rPr lang="de-DE" smtClean="0"/>
               <a:t>‹Nr.›</a:t>
             </a:fld>
@@ -1470,7 +1470,7 @@
     </p:spTree>
     <p:extLst>
       <p:ext uri="{BB962C8B-B14F-4D97-AF65-F5344CB8AC3E}">
-        <p14:creationId xmlns:p14="http://schemas.microsoft.com/office/powerpoint/2010/main" val="3544017998"/>
+        <p14:creationId xmlns:p14="http://schemas.microsoft.com/office/powerpoint/2010/main" val="4230771853"/>
       </p:ext>
     </p:extLst>
   </p:cSld>
@@ -1502,7 +1502,7 @@
           <p:cNvPr id="2" name="Titel 1">
             <a:extLst>
               <a:ext uri="{FF2B5EF4-FFF2-40B4-BE49-F238E27FC236}">
-                <a16:creationId xmlns:a16="http://schemas.microsoft.com/office/drawing/2014/main" id="{A9855105-5EA7-953C-7251-6715EC292085}"/>
+                <a16:creationId xmlns:a16="http://schemas.microsoft.com/office/drawing/2014/main" id="{7812AC80-4FCC-2D0C-390F-B34EE2BA57BD}"/>
               </a:ext>
             </a:extLst>
           </p:cNvPr>
@@ -1535,7 +1535,7 @@
           <p:cNvPr id="3" name="Textplatzhalter 2">
             <a:extLst>
               <a:ext uri="{FF2B5EF4-FFF2-40B4-BE49-F238E27FC236}">
-                <a16:creationId xmlns:a16="http://schemas.microsoft.com/office/drawing/2014/main" id="{162C979D-B1E2-8BAE-BDE7-5313613DDFA1}"/>
+                <a16:creationId xmlns:a16="http://schemas.microsoft.com/office/drawing/2014/main" id="{396C86E1-2098-9E2A-29AA-CAA92EAC29F9}"/>
               </a:ext>
             </a:extLst>
           </p:cNvPr>
@@ -1606,7 +1606,7 @@
           <p:cNvPr id="4" name="Inhaltsplatzhalter 3">
             <a:extLst>
               <a:ext uri="{FF2B5EF4-FFF2-40B4-BE49-F238E27FC236}">
-                <a16:creationId xmlns:a16="http://schemas.microsoft.com/office/drawing/2014/main" id="{2715CB04-E8B0-1D61-6CB6-E9AEA360DB06}"/>
+                <a16:creationId xmlns:a16="http://schemas.microsoft.com/office/drawing/2014/main" id="{E43E4A0D-CFC4-9E46-D328-78261CB69BEF}"/>
               </a:ext>
             </a:extLst>
           </p:cNvPr>
@@ -1668,7 +1668,7 @@
           <p:cNvPr id="5" name="Textplatzhalter 4">
             <a:extLst>
               <a:ext uri="{FF2B5EF4-FFF2-40B4-BE49-F238E27FC236}">
-                <a16:creationId xmlns:a16="http://schemas.microsoft.com/office/drawing/2014/main" id="{E3B2E7F2-42CD-63FF-3B07-F6F020DF561F}"/>
+                <a16:creationId xmlns:a16="http://schemas.microsoft.com/office/drawing/2014/main" id="{5F31D432-B50C-D399-AD06-6972A220EED8}"/>
               </a:ext>
             </a:extLst>
           </p:cNvPr>
@@ -1739,7 +1739,7 @@
           <p:cNvPr id="6" name="Inhaltsplatzhalter 5">
             <a:extLst>
               <a:ext uri="{FF2B5EF4-FFF2-40B4-BE49-F238E27FC236}">
-                <a16:creationId xmlns:a16="http://schemas.microsoft.com/office/drawing/2014/main" id="{0B25BEE4-EC9B-BB49-2239-0EDEDCAA0433}"/>
+                <a16:creationId xmlns:a16="http://schemas.microsoft.com/office/drawing/2014/main" id="{F18F2F4A-7F5D-C3F8-9459-F559B32C222B}"/>
               </a:ext>
             </a:extLst>
           </p:cNvPr>
@@ -1801,7 +1801,7 @@
           <p:cNvPr id="7" name="Datumsplatzhalter 6">
             <a:extLst>
               <a:ext uri="{FF2B5EF4-FFF2-40B4-BE49-F238E27FC236}">
-                <a16:creationId xmlns:a16="http://schemas.microsoft.com/office/drawing/2014/main" id="{04D61895-F6E0-465C-0DDD-6C08BB10FEEB}"/>
+                <a16:creationId xmlns:a16="http://schemas.microsoft.com/office/drawing/2014/main" id="{14B2DC3D-B732-4789-45BC-348E40556415}"/>
               </a:ext>
             </a:extLst>
           </p:cNvPr>
@@ -1817,7 +1817,7 @@
           <a:bodyPr/>
           <a:lstStyle/>
           <a:p>
-            <a:fld id="{363C6B2F-0EB9-4825-8B3F-3C3C5B83126B}" type="datetimeFigureOut">
+            <a:fld id="{C34BCCBE-FFF1-4213-A060-BD0744E7F377}" type="datetimeFigureOut">
               <a:rPr lang="de-DE" smtClean="0"/>
               <a:t>01.07.2026</a:t>
             </a:fld>
@@ -1830,7 +1830,7 @@
           <p:cNvPr id="8" name="Fußzeilenplatzhalter 7">
             <a:extLst>
               <a:ext uri="{FF2B5EF4-FFF2-40B4-BE49-F238E27FC236}">
-                <a16:creationId xmlns:a16="http://schemas.microsoft.com/office/drawing/2014/main" id="{0731B7A4-7652-A99D-9AAA-7FAAE4EA6207}"/>
+                <a16:creationId xmlns:a16="http://schemas.microsoft.com/office/drawing/2014/main" id="{9F38AAB4-7EEE-3A68-89F3-2C31551E6C98}"/>
               </a:ext>
             </a:extLst>
           </p:cNvPr>
@@ -1855,7 +1855,7 @@
           <p:cNvPr id="9" name="Foliennummernplatzhalter 8">
             <a:extLst>
               <a:ext uri="{FF2B5EF4-FFF2-40B4-BE49-F238E27FC236}">
-                <a16:creationId xmlns:a16="http://schemas.microsoft.com/office/drawing/2014/main" id="{71C9184A-3B74-029E-ED99-8CE69D64452A}"/>
+                <a16:creationId xmlns:a16="http://schemas.microsoft.com/office/drawing/2014/main" id="{580EAE39-1056-15FC-4B59-52004A0B0EBB}"/>
               </a:ext>
             </a:extLst>
           </p:cNvPr>
@@ -1871,7 +1871,7 @@
           <a:bodyPr/>
           <a:lstStyle/>
           <a:p>
-            <a:fld id="{D36C3734-E1F4-419B-9C5E-DD98F76C0988}" type="slidenum">
+            <a:fld id="{6A1B2D6F-A1C6-4069-816D-FEC1538C4AD2}" type="slidenum">
               <a:rPr lang="de-DE" smtClean="0"/>
               <a:t>‹Nr.›</a:t>
             </a:fld>
@@ -1882,7 +1882,7 @@
     </p:spTree>
     <p:extLst>
       <p:ext uri="{BB962C8B-B14F-4D97-AF65-F5344CB8AC3E}">
-        <p14:creationId xmlns:p14="http://schemas.microsoft.com/office/powerpoint/2010/main" val="2182256617"/>
+        <p14:creationId xmlns:p14="http://schemas.microsoft.com/office/powerpoint/2010/main" val="495183895"/>
       </p:ext>
     </p:extLst>
   </p:cSld>
@@ -1914,7 +1914,7 @@
           <p:cNvPr id="2" name="Titel 1">
             <a:extLst>
               <a:ext uri="{FF2B5EF4-FFF2-40B4-BE49-F238E27FC236}">
-                <a16:creationId xmlns:a16="http://schemas.microsoft.com/office/drawing/2014/main" id="{DFCD9475-5C56-110F-84E4-9830FCB742D6}"/>
+                <a16:creationId xmlns:a16="http://schemas.microsoft.com/office/drawing/2014/main" id="{5A70589E-C62C-47B4-1D36-2CAEAF9CB9B2}"/>
               </a:ext>
             </a:extLst>
           </p:cNvPr>
@@ -1942,7 +1942,7 @@
           <p:cNvPr id="3" name="Datumsplatzhalter 2">
             <a:extLst>
               <a:ext uri="{FF2B5EF4-FFF2-40B4-BE49-F238E27FC236}">
-                <a16:creationId xmlns:a16="http://schemas.microsoft.com/office/drawing/2014/main" id="{1DF42029-CA5F-3F70-7654-1844D09ADC49}"/>
+                <a16:creationId xmlns:a16="http://schemas.microsoft.com/office/drawing/2014/main" id="{9C4D28B7-7E92-A924-ADF8-179CDB334BC5}"/>
               </a:ext>
             </a:extLst>
           </p:cNvPr>
@@ -1958,7 +1958,7 @@
           <a:bodyPr/>
           <a:lstStyle/>
           <a:p>
-            <a:fld id="{363C6B2F-0EB9-4825-8B3F-3C3C5B83126B}" type="datetimeFigureOut">
+            <a:fld id="{C34BCCBE-FFF1-4213-A060-BD0744E7F377}" type="datetimeFigureOut">
               <a:rPr lang="de-DE" smtClean="0"/>
               <a:t>01.07.2026</a:t>
             </a:fld>
@@ -1971,7 +1971,7 @@
           <p:cNvPr id="4" name="Fußzeilenplatzhalter 3">
             <a:extLst>
               <a:ext uri="{FF2B5EF4-FFF2-40B4-BE49-F238E27FC236}">
-                <a16:creationId xmlns:a16="http://schemas.microsoft.com/office/drawing/2014/main" id="{2FBFFD8B-6E69-408B-D156-FC4C7CB1A2D6}"/>
+                <a16:creationId xmlns:a16="http://schemas.microsoft.com/office/drawing/2014/main" id="{241BC058-E6BB-9A2A-547F-E594BB37EFD9}"/>
               </a:ext>
             </a:extLst>
           </p:cNvPr>
@@ -1996,7 +1996,7 @@
           <p:cNvPr id="5" name="Foliennummernplatzhalter 4">
             <a:extLst>
               <a:ext uri="{FF2B5EF4-FFF2-40B4-BE49-F238E27FC236}">
-                <a16:creationId xmlns:a16="http://schemas.microsoft.com/office/drawing/2014/main" id="{C67D3563-5443-DD8D-106D-A0A1CD70C6FD}"/>
+                <a16:creationId xmlns:a16="http://schemas.microsoft.com/office/drawing/2014/main" id="{275FFCB3-3C79-A285-6E93-2EFC9DFD526E}"/>
               </a:ext>
             </a:extLst>
           </p:cNvPr>
@@ -2012,7 +2012,7 @@
           <a:bodyPr/>
           <a:lstStyle/>
           <a:p>
-            <a:fld id="{D36C3734-E1F4-419B-9C5E-DD98F76C0988}" type="slidenum">
+            <a:fld id="{6A1B2D6F-A1C6-4069-816D-FEC1538C4AD2}" type="slidenum">
               <a:rPr lang="de-DE" smtClean="0"/>
               <a:t>‹Nr.›</a:t>
             </a:fld>
@@ -2023,7 +2023,7 @@
     </p:spTree>
     <p:extLst>
       <p:ext uri="{BB962C8B-B14F-4D97-AF65-F5344CB8AC3E}">
-        <p14:creationId xmlns:p14="http://schemas.microsoft.com/office/powerpoint/2010/main" val="3547950574"/>
+        <p14:creationId xmlns:p14="http://schemas.microsoft.com/office/powerpoint/2010/main" val="3188614860"/>
       </p:ext>
     </p:extLst>
   </p:cSld>
@@ -2055,7 +2055,7 @@
           <p:cNvPr id="2" name="Datumsplatzhalter 1">
             <a:extLst>
               <a:ext uri="{FF2B5EF4-FFF2-40B4-BE49-F238E27FC236}">
-                <a16:creationId xmlns:a16="http://schemas.microsoft.com/office/drawing/2014/main" id="{68B0AEA8-57A3-06C1-EDA7-611F054F999D}"/>
+                <a16:creationId xmlns:a16="http://schemas.microsoft.com/office/drawing/2014/main" id="{71DBA8D4-3C2D-AED4-1FD0-76012E795E7E}"/>
               </a:ext>
             </a:extLst>
           </p:cNvPr>
@@ -2071,7 +2071,7 @@
           <a:bodyPr/>
           <a:lstStyle/>
           <a:p>
-            <a:fld id="{363C6B2F-0EB9-4825-8B3F-3C3C5B83126B}" type="datetimeFigureOut">
+            <a:fld id="{C34BCCBE-FFF1-4213-A060-BD0744E7F377}" type="datetimeFigureOut">
               <a:rPr lang="de-DE" smtClean="0"/>
               <a:t>01.07.2026</a:t>
             </a:fld>
@@ -2084,7 +2084,7 @@
           <p:cNvPr id="3" name="Fußzeilenplatzhalter 2">
             <a:extLst>
               <a:ext uri="{FF2B5EF4-FFF2-40B4-BE49-F238E27FC236}">
-                <a16:creationId xmlns:a16="http://schemas.microsoft.com/office/drawing/2014/main" id="{9B0E09A6-C680-4D1E-EE07-7F2C15C5FCF5}"/>
+                <a16:creationId xmlns:a16="http://schemas.microsoft.com/office/drawing/2014/main" id="{4B952D3A-DF6D-1450-9F88-1D4AD862242A}"/>
               </a:ext>
             </a:extLst>
           </p:cNvPr>
@@ -2109,7 +2109,7 @@
           <p:cNvPr id="4" name="Foliennummernplatzhalter 3">
             <a:extLst>
               <a:ext uri="{FF2B5EF4-FFF2-40B4-BE49-F238E27FC236}">
-                <a16:creationId xmlns:a16="http://schemas.microsoft.com/office/drawing/2014/main" id="{790D4971-A59F-2E59-CE17-17A7C05CE913}"/>
+                <a16:creationId xmlns:a16="http://schemas.microsoft.com/office/drawing/2014/main" id="{67471235-4A97-614E-9E70-FA87C2504EA3}"/>
               </a:ext>
             </a:extLst>
           </p:cNvPr>
@@ -2125,7 +2125,7 @@
           <a:bodyPr/>
           <a:lstStyle/>
           <a:p>
-            <a:fld id="{D36C3734-E1F4-419B-9C5E-DD98F76C0988}" type="slidenum">
+            <a:fld id="{6A1B2D6F-A1C6-4069-816D-FEC1538C4AD2}" type="slidenum">
               <a:rPr lang="de-DE" smtClean="0"/>
               <a:t>‹Nr.›</a:t>
             </a:fld>
@@ -2136,7 +2136,7 @@
     </p:spTree>
     <p:extLst>
       <p:ext uri="{BB962C8B-B14F-4D97-AF65-F5344CB8AC3E}">
-        <p14:creationId xmlns:p14="http://schemas.microsoft.com/office/powerpoint/2010/main" val="3518167750"/>
+        <p14:creationId xmlns:p14="http://schemas.microsoft.com/office/powerpoint/2010/main" val="4029378826"/>
       </p:ext>
     </p:extLst>
   </p:cSld>
@@ -2168,7 +2168,7 @@
           <p:cNvPr id="2" name="Titel 1">
             <a:extLst>
               <a:ext uri="{FF2B5EF4-FFF2-40B4-BE49-F238E27FC236}">
-                <a16:creationId xmlns:a16="http://schemas.microsoft.com/office/drawing/2014/main" id="{6FD2C4DE-9154-512D-71AF-C696F4966D07}"/>
+                <a16:creationId xmlns:a16="http://schemas.microsoft.com/office/drawing/2014/main" id="{E109C930-D02F-C1CD-83BB-FF385ABD057D}"/>
               </a:ext>
             </a:extLst>
           </p:cNvPr>
@@ -2205,7 +2205,7 @@
           <p:cNvPr id="3" name="Inhaltsplatzhalter 2">
             <a:extLst>
               <a:ext uri="{FF2B5EF4-FFF2-40B4-BE49-F238E27FC236}">
-                <a16:creationId xmlns:a16="http://schemas.microsoft.com/office/drawing/2014/main" id="{BFF64A47-B3A9-45C3-E00B-5B567DAFA3DB}"/>
+                <a16:creationId xmlns:a16="http://schemas.microsoft.com/office/drawing/2014/main" id="{A9B47EBE-D40E-9A4E-2963-BB6D6B46BD0E}"/>
               </a:ext>
             </a:extLst>
           </p:cNvPr>
@@ -2295,7 +2295,7 @@
           <p:cNvPr id="4" name="Textplatzhalter 3">
             <a:extLst>
               <a:ext uri="{FF2B5EF4-FFF2-40B4-BE49-F238E27FC236}">
-                <a16:creationId xmlns:a16="http://schemas.microsoft.com/office/drawing/2014/main" id="{34C0CC7C-6DA0-7998-3F39-D2FFDD378FA5}"/>
+                <a16:creationId xmlns:a16="http://schemas.microsoft.com/office/drawing/2014/main" id="{098C3AE8-3814-FAF0-F9CC-AE717BA2D635}"/>
               </a:ext>
             </a:extLst>
           </p:cNvPr>
@@ -2366,7 +2366,7 @@
           <p:cNvPr id="5" name="Datumsplatzhalter 4">
             <a:extLst>
               <a:ext uri="{FF2B5EF4-FFF2-40B4-BE49-F238E27FC236}">
-                <a16:creationId xmlns:a16="http://schemas.microsoft.com/office/drawing/2014/main" id="{7C48ED92-EF37-E8D1-B8EF-18EC309A6211}"/>
+                <a16:creationId xmlns:a16="http://schemas.microsoft.com/office/drawing/2014/main" id="{E6986A6E-E778-A0AB-B01A-4E1F0CA5C3C7}"/>
               </a:ext>
             </a:extLst>
           </p:cNvPr>
@@ -2382,7 +2382,7 @@
           <a:bodyPr/>
           <a:lstStyle/>
           <a:p>
-            <a:fld id="{363C6B2F-0EB9-4825-8B3F-3C3C5B83126B}" type="datetimeFigureOut">
+            <a:fld id="{C34BCCBE-FFF1-4213-A060-BD0744E7F377}" type="datetimeFigureOut">
               <a:rPr lang="de-DE" smtClean="0"/>
               <a:t>01.07.2026</a:t>
             </a:fld>
@@ -2395,7 +2395,7 @@
           <p:cNvPr id="6" name="Fußzeilenplatzhalter 5">
             <a:extLst>
               <a:ext uri="{FF2B5EF4-FFF2-40B4-BE49-F238E27FC236}">
-                <a16:creationId xmlns:a16="http://schemas.microsoft.com/office/drawing/2014/main" id="{443B9C5A-209D-A940-070A-00147A1FE2D5}"/>
+                <a16:creationId xmlns:a16="http://schemas.microsoft.com/office/drawing/2014/main" id="{F2DD5ECF-9673-C89B-E6B6-B6EF3036EA30}"/>
               </a:ext>
             </a:extLst>
           </p:cNvPr>
@@ -2420,7 +2420,7 @@
           <p:cNvPr id="7" name="Foliennummernplatzhalter 6">
             <a:extLst>
               <a:ext uri="{FF2B5EF4-FFF2-40B4-BE49-F238E27FC236}">
-                <a16:creationId xmlns:a16="http://schemas.microsoft.com/office/drawing/2014/main" id="{F602BFEB-6208-0738-5568-44836E0576A4}"/>
+                <a16:creationId xmlns:a16="http://schemas.microsoft.com/office/drawing/2014/main" id="{ACAF7B77-CF48-9C4C-CBD8-D3AFD4C698D0}"/>
               </a:ext>
             </a:extLst>
           </p:cNvPr>
@@ -2436,7 +2436,7 @@
           <a:bodyPr/>
           <a:lstStyle/>
           <a:p>
-            <a:fld id="{D36C3734-E1F4-419B-9C5E-DD98F76C0988}" type="slidenum">
+            <a:fld id="{6A1B2D6F-A1C6-4069-816D-FEC1538C4AD2}" type="slidenum">
               <a:rPr lang="de-DE" smtClean="0"/>
               <a:t>‹Nr.›</a:t>
             </a:fld>
@@ -2447,7 +2447,7 @@
     </p:spTree>
     <p:extLst>
       <p:ext uri="{BB962C8B-B14F-4D97-AF65-F5344CB8AC3E}">
-        <p14:creationId xmlns:p14="http://schemas.microsoft.com/office/powerpoint/2010/main" val="1042502288"/>
+        <p14:creationId xmlns:p14="http://schemas.microsoft.com/office/powerpoint/2010/main" val="2244043745"/>
       </p:ext>
     </p:extLst>
   </p:cSld>
@@ -2479,7 +2479,7 @@
           <p:cNvPr id="2" name="Titel 1">
             <a:extLst>
               <a:ext uri="{FF2B5EF4-FFF2-40B4-BE49-F238E27FC236}">
-                <a16:creationId xmlns:a16="http://schemas.microsoft.com/office/drawing/2014/main" id="{10248060-3651-A152-B9F2-9FE3BD894805}"/>
+                <a16:creationId xmlns:a16="http://schemas.microsoft.com/office/drawing/2014/main" id="{41733C37-925D-D45C-51EE-443C12C9083C}"/>
               </a:ext>
             </a:extLst>
           </p:cNvPr>
@@ -2516,7 +2516,7 @@
           <p:cNvPr id="3" name="Bildplatzhalter 2">
             <a:extLst>
               <a:ext uri="{FF2B5EF4-FFF2-40B4-BE49-F238E27FC236}">
-                <a16:creationId xmlns:a16="http://schemas.microsoft.com/office/drawing/2014/main" id="{4CD102AE-E404-4EF7-1B63-CCC744F84197}"/>
+                <a16:creationId xmlns:a16="http://schemas.microsoft.com/office/drawing/2014/main" id="{C85CF806-8BAD-D34D-A6D2-E1C31B765A54}"/>
               </a:ext>
             </a:extLst>
           </p:cNvPr>
@@ -2583,7 +2583,7 @@
           <p:cNvPr id="4" name="Textplatzhalter 3">
             <a:extLst>
               <a:ext uri="{FF2B5EF4-FFF2-40B4-BE49-F238E27FC236}">
-                <a16:creationId xmlns:a16="http://schemas.microsoft.com/office/drawing/2014/main" id="{711E7858-6DE8-8B55-C724-DCEBB05DFCAC}"/>
+                <a16:creationId xmlns:a16="http://schemas.microsoft.com/office/drawing/2014/main" id="{6859B268-9160-C9AE-0FB9-251A8D964912}"/>
               </a:ext>
             </a:extLst>
           </p:cNvPr>
@@ -2654,7 +2654,7 @@
           <p:cNvPr id="5" name="Datumsplatzhalter 4">
             <a:extLst>
               <a:ext uri="{FF2B5EF4-FFF2-40B4-BE49-F238E27FC236}">
-                <a16:creationId xmlns:a16="http://schemas.microsoft.com/office/drawing/2014/main" id="{1B165479-3E81-DE0F-DCAC-03AE81F1C7DC}"/>
+                <a16:creationId xmlns:a16="http://schemas.microsoft.com/office/drawing/2014/main" id="{B9692C52-4210-A024-DB67-50854B50BCAB}"/>
               </a:ext>
             </a:extLst>
           </p:cNvPr>
@@ -2670,7 +2670,7 @@
           <a:bodyPr/>
           <a:lstStyle/>
           <a:p>
-            <a:fld id="{363C6B2F-0EB9-4825-8B3F-3C3C5B83126B}" type="datetimeFigureOut">
+            <a:fld id="{C34BCCBE-FFF1-4213-A060-BD0744E7F377}" type="datetimeFigureOut">
               <a:rPr lang="de-DE" smtClean="0"/>
               <a:t>01.07.2026</a:t>
             </a:fld>
@@ -2683,7 +2683,7 @@
           <p:cNvPr id="6" name="Fußzeilenplatzhalter 5">
             <a:extLst>
               <a:ext uri="{FF2B5EF4-FFF2-40B4-BE49-F238E27FC236}">
-                <a16:creationId xmlns:a16="http://schemas.microsoft.com/office/drawing/2014/main" id="{5804BD99-EB6E-B566-B347-3FDA93801D15}"/>
+                <a16:creationId xmlns:a16="http://schemas.microsoft.com/office/drawing/2014/main" id="{C325BF8B-A38C-7997-714E-B25F8928D5EC}"/>
               </a:ext>
             </a:extLst>
           </p:cNvPr>
@@ -2708,7 +2708,7 @@
           <p:cNvPr id="7" name="Foliennummernplatzhalter 6">
             <a:extLst>
               <a:ext uri="{FF2B5EF4-FFF2-40B4-BE49-F238E27FC236}">
-                <a16:creationId xmlns:a16="http://schemas.microsoft.com/office/drawing/2014/main" id="{9620A9BE-6200-598D-5CE4-326299BD40B8}"/>
+                <a16:creationId xmlns:a16="http://schemas.microsoft.com/office/drawing/2014/main" id="{DED88116-CBFA-FD1D-C90F-2005CAC16296}"/>
               </a:ext>
             </a:extLst>
           </p:cNvPr>
@@ -2724,7 +2724,7 @@
           <a:bodyPr/>
           <a:lstStyle/>
           <a:p>
-            <a:fld id="{D36C3734-E1F4-419B-9C5E-DD98F76C0988}" type="slidenum">
+            <a:fld id="{6A1B2D6F-A1C6-4069-816D-FEC1538C4AD2}" type="slidenum">
               <a:rPr lang="de-DE" smtClean="0"/>
               <a:t>‹Nr.›</a:t>
             </a:fld>
@@ -2735,7 +2735,7 @@
     </p:spTree>
     <p:extLst>
       <p:ext uri="{BB962C8B-B14F-4D97-AF65-F5344CB8AC3E}">
-        <p14:creationId xmlns:p14="http://schemas.microsoft.com/office/powerpoint/2010/main" val="4151158940"/>
+        <p14:creationId xmlns:p14="http://schemas.microsoft.com/office/powerpoint/2010/main" val="2612861806"/>
       </p:ext>
     </p:extLst>
   </p:cSld>
@@ -2772,7 +2772,7 @@
           <p:cNvPr id="2" name="Titelplatzhalter 1">
             <a:extLst>
               <a:ext uri="{FF2B5EF4-FFF2-40B4-BE49-F238E27FC236}">
-                <a16:creationId xmlns:a16="http://schemas.microsoft.com/office/drawing/2014/main" id="{EE52EA34-8FE9-FEE8-B9E1-B69BDB243FDC}"/>
+                <a16:creationId xmlns:a16="http://schemas.microsoft.com/office/drawing/2014/main" id="{7D499B2E-018E-D617-F076-43C37D758916}"/>
               </a:ext>
             </a:extLst>
           </p:cNvPr>
@@ -2810,7 +2810,7 @@
           <p:cNvPr id="3" name="Textplatzhalter 2">
             <a:extLst>
               <a:ext uri="{FF2B5EF4-FFF2-40B4-BE49-F238E27FC236}">
-                <a16:creationId xmlns:a16="http://schemas.microsoft.com/office/drawing/2014/main" id="{C8C2F82E-D2A3-B652-D7C8-CF45F332A455}"/>
+                <a16:creationId xmlns:a16="http://schemas.microsoft.com/office/drawing/2014/main" id="{141CCBC1-68A6-EB3B-DBB9-F56DCD346C5A}"/>
               </a:ext>
             </a:extLst>
           </p:cNvPr>
@@ -2877,7 +2877,7 @@
           <p:cNvPr id="4" name="Datumsplatzhalter 3">
             <a:extLst>
               <a:ext uri="{FF2B5EF4-FFF2-40B4-BE49-F238E27FC236}">
-                <a16:creationId xmlns:a16="http://schemas.microsoft.com/office/drawing/2014/main" id="{016D075C-A3EE-3CA1-74EB-FD8B8E353380}"/>
+                <a16:creationId xmlns:a16="http://schemas.microsoft.com/office/drawing/2014/main" id="{151BE250-EFA9-6CAE-2D3E-753E2738BE38}"/>
               </a:ext>
             </a:extLst>
           </p:cNvPr>
@@ -2911,7 +2911,7 @@
             </a:lvl1pPr>
           </a:lstStyle>
           <a:p>
-            <a:fld id="{363C6B2F-0EB9-4825-8B3F-3C3C5B83126B}" type="datetimeFigureOut">
+            <a:fld id="{C34BCCBE-FFF1-4213-A060-BD0744E7F377}" type="datetimeFigureOut">
               <a:rPr lang="de-DE" smtClean="0"/>
               <a:t>01.07.2026</a:t>
             </a:fld>
@@ -2924,7 +2924,7 @@
           <p:cNvPr id="5" name="Fußzeilenplatzhalter 4">
             <a:extLst>
               <a:ext uri="{FF2B5EF4-FFF2-40B4-BE49-F238E27FC236}">
-                <a16:creationId xmlns:a16="http://schemas.microsoft.com/office/drawing/2014/main" id="{162C107D-BCC6-76AD-980F-A0CC295F99FF}"/>
+                <a16:creationId xmlns:a16="http://schemas.microsoft.com/office/drawing/2014/main" id="{352F8F37-D300-9F77-B6AA-A6C43E34717E}"/>
               </a:ext>
             </a:extLst>
           </p:cNvPr>
@@ -2967,7 +2967,7 @@
           <p:cNvPr id="6" name="Foliennummernplatzhalter 5">
             <a:extLst>
               <a:ext uri="{FF2B5EF4-FFF2-40B4-BE49-F238E27FC236}">
-                <a16:creationId xmlns:a16="http://schemas.microsoft.com/office/drawing/2014/main" id="{C42A79DE-B768-222D-CBDC-D43113959DAA}"/>
+                <a16:creationId xmlns:a16="http://schemas.microsoft.com/office/drawing/2014/main" id="{DFF7B7AC-34BB-7A26-3ADF-E0F4F02AEE85}"/>
               </a:ext>
             </a:extLst>
           </p:cNvPr>
@@ -3001,7 +3001,7 @@
             </a:lvl1pPr>
           </a:lstStyle>
           <a:p>
-            <a:fld id="{D36C3734-E1F4-419B-9C5E-DD98F76C0988}" type="slidenum">
+            <a:fld id="{6A1B2D6F-A1C6-4069-816D-FEC1538C4AD2}" type="slidenum">
               <a:rPr lang="de-DE" smtClean="0"/>
               <a:t>‹Nr.›</a:t>
             </a:fld>
@@ -3012,7 +3012,7 @@
     </p:spTree>
     <p:extLst>
       <p:ext uri="{BB962C8B-B14F-4D97-AF65-F5344CB8AC3E}">
-        <p14:creationId xmlns:p14="http://schemas.microsoft.com/office/powerpoint/2010/main" val="2560773231"/>
+        <p14:creationId xmlns:p14="http://schemas.microsoft.com/office/powerpoint/2010/main" val="1398285839"/>
       </p:ext>
     </p:extLst>
   </p:cSld>
@@ -3343,7 +3343,7 @@
           <p:cNvPr id="2" name="Rechteck 1">
             <a:extLst>
               <a:ext uri="{FF2B5EF4-FFF2-40B4-BE49-F238E27FC236}">
-                <a16:creationId xmlns:a16="http://schemas.microsoft.com/office/drawing/2014/main" id="{ADAC6348-1BD6-2F45-4541-7115D8A7B49C}"/>
+                <a16:creationId xmlns:a16="http://schemas.microsoft.com/office/drawing/2014/main" id="{87FA4837-2AB5-49DA-E955-094A22087D26}"/>
               </a:ext>
             </a:extLst>
           </p:cNvPr>
@@ -3411,7 +3411,7 @@
           <p:cNvPr id="3" name="Rechteck 2">
             <a:extLst>
               <a:ext uri="{FF2B5EF4-FFF2-40B4-BE49-F238E27FC236}">
-                <a16:creationId xmlns:a16="http://schemas.microsoft.com/office/drawing/2014/main" id="{D6376FC6-43C6-E56E-70A5-3CB914D80D76}"/>
+                <a16:creationId xmlns:a16="http://schemas.microsoft.com/office/drawing/2014/main" id="{487F5709-E693-C8A8-0884-BEE14B770BC0}"/>
               </a:ext>
             </a:extLst>
           </p:cNvPr>
@@ -3479,7 +3479,7 @@
           <p:cNvPr id="4" name="Textfeld 3">
             <a:extLst>
               <a:ext uri="{FF2B5EF4-FFF2-40B4-BE49-F238E27FC236}">
-                <a16:creationId xmlns:a16="http://schemas.microsoft.com/office/drawing/2014/main" id="{83A9EFC2-761D-87EF-D6D7-8EB51F7BB418}"/>
+                <a16:creationId xmlns:a16="http://schemas.microsoft.com/office/drawing/2014/main" id="{A756B358-1BCC-D4B4-F60F-3F0213E53B1E}"/>
               </a:ext>
             </a:extLst>
           </p:cNvPr>
@@ -3519,7 +3519,7 @@
           <p:cNvPr id="5" name="Textfeld 4">
             <a:extLst>
               <a:ext uri="{FF2B5EF4-FFF2-40B4-BE49-F238E27FC236}">
-                <a16:creationId xmlns:a16="http://schemas.microsoft.com/office/drawing/2014/main" id="{A0620D66-AC6C-E0A2-306A-0B2A6A40945D}"/>
+                <a16:creationId xmlns:a16="http://schemas.microsoft.com/office/drawing/2014/main" id="{0B25A530-1453-3EAE-DCE4-44BD91625328}"/>
               </a:ext>
             </a:extLst>
           </p:cNvPr>
@@ -3597,7 +3597,7 @@
           <p:cNvPr id="6" name="Textfeld 5">
             <a:extLst>
               <a:ext uri="{FF2B5EF4-FFF2-40B4-BE49-F238E27FC236}">
-                <a16:creationId xmlns:a16="http://schemas.microsoft.com/office/drawing/2014/main" id="{9BB52249-1CFE-1935-5B76-2A05955845B5}"/>
+                <a16:creationId xmlns:a16="http://schemas.microsoft.com/office/drawing/2014/main" id="{CBB1AE4B-3CAD-DCC2-DE03-DC1BBB19884B}"/>
               </a:ext>
             </a:extLst>
           </p:cNvPr>
@@ -3635,7 +3635,7 @@
     </p:spTree>
     <p:extLst>
       <p:ext uri="{BB962C8B-B14F-4D97-AF65-F5344CB8AC3E}">
-        <p14:creationId xmlns:p14="http://schemas.microsoft.com/office/powerpoint/2010/main" val="1149078300"/>
+        <p14:creationId xmlns:p14="http://schemas.microsoft.com/office/powerpoint/2010/main" val="1607655554"/>
       </p:ext>
     </p:extLst>
   </p:cSld>
@@ -3675,7 +3675,7 @@
           <p:cNvPr id="2" name="Rechteck 1">
             <a:extLst>
               <a:ext uri="{FF2B5EF4-FFF2-40B4-BE49-F238E27FC236}">
-                <a16:creationId xmlns:a16="http://schemas.microsoft.com/office/drawing/2014/main" id="{EE2AB3B3-6286-6D49-4AEF-853DCFDC8FC3}"/>
+                <a16:creationId xmlns:a16="http://schemas.microsoft.com/office/drawing/2014/main" id="{542705FD-FE63-8499-3E93-AF7617FE922C}"/>
               </a:ext>
             </a:extLst>
           </p:cNvPr>
@@ -3743,7 +3743,7 @@
           <p:cNvPr id="3" name="Rechteck 2">
             <a:extLst>
               <a:ext uri="{FF2B5EF4-FFF2-40B4-BE49-F238E27FC236}">
-                <a16:creationId xmlns:a16="http://schemas.microsoft.com/office/drawing/2014/main" id="{C5301CA2-E5BC-0108-5143-A68D0C675E60}"/>
+                <a16:creationId xmlns:a16="http://schemas.microsoft.com/office/drawing/2014/main" id="{524BB1C4-FC55-36E3-2998-3516FFE929E3}"/>
               </a:ext>
             </a:extLst>
           </p:cNvPr>
@@ -3811,7 +3811,7 @@
           <p:cNvPr id="4" name="Textfeld 3">
             <a:extLst>
               <a:ext uri="{FF2B5EF4-FFF2-40B4-BE49-F238E27FC236}">
-                <a16:creationId xmlns:a16="http://schemas.microsoft.com/office/drawing/2014/main" id="{F31DA76B-3D0D-D7B1-3EF8-EAD92F66EEA6}"/>
+                <a16:creationId xmlns:a16="http://schemas.microsoft.com/office/drawing/2014/main" id="{92AE3D84-F9EC-ACC5-46D5-47736078EFDC}"/>
               </a:ext>
             </a:extLst>
           </p:cNvPr>
@@ -3851,7 +3851,7 @@
           <p:cNvPr id="5" name="Textfeld 4">
             <a:extLst>
               <a:ext uri="{FF2B5EF4-FFF2-40B4-BE49-F238E27FC236}">
-                <a16:creationId xmlns:a16="http://schemas.microsoft.com/office/drawing/2014/main" id="{999ECCEB-8642-92A3-6A0D-DA83677CEF4E}"/>
+                <a16:creationId xmlns:a16="http://schemas.microsoft.com/office/drawing/2014/main" id="{21091DAA-0F8B-8046-8FA9-2EEF86684B3A}"/>
               </a:ext>
             </a:extLst>
           </p:cNvPr>
@@ -3929,7 +3929,7 @@
           <p:cNvPr id="6" name="Textfeld 5">
             <a:extLst>
               <a:ext uri="{FF2B5EF4-FFF2-40B4-BE49-F238E27FC236}">
-                <a16:creationId xmlns:a16="http://schemas.microsoft.com/office/drawing/2014/main" id="{E1C3A2F5-0793-3A2D-94DF-F240D731C292}"/>
+                <a16:creationId xmlns:a16="http://schemas.microsoft.com/office/drawing/2014/main" id="{50304F70-E2FE-A310-7E41-FBBFBA99E8DD}"/>
               </a:ext>
             </a:extLst>
           </p:cNvPr>
@@ -3967,7 +3967,7 @@
     </p:spTree>
     <p:extLst>
       <p:ext uri="{BB962C8B-B14F-4D97-AF65-F5344CB8AC3E}">
-        <p14:creationId xmlns:p14="http://schemas.microsoft.com/office/powerpoint/2010/main" val="486858468"/>
+        <p14:creationId xmlns:p14="http://schemas.microsoft.com/office/powerpoint/2010/main" val="1926392439"/>
       </p:ext>
     </p:extLst>
   </p:cSld>
@@ -4007,7 +4007,7 @@
           <p:cNvPr id="2" name="Rechteck 1">
             <a:extLst>
               <a:ext uri="{FF2B5EF4-FFF2-40B4-BE49-F238E27FC236}">
-                <a16:creationId xmlns:a16="http://schemas.microsoft.com/office/drawing/2014/main" id="{981DD845-A4CD-B3E4-2AF4-88FAF41F8591}"/>
+                <a16:creationId xmlns:a16="http://schemas.microsoft.com/office/drawing/2014/main" id="{9D75EB2B-772E-2617-BC84-CAF476FAB873}"/>
               </a:ext>
             </a:extLst>
           </p:cNvPr>
@@ -4075,7 +4075,7 @@
           <p:cNvPr id="3" name="Rechteck 2">
             <a:extLst>
               <a:ext uri="{FF2B5EF4-FFF2-40B4-BE49-F238E27FC236}">
-                <a16:creationId xmlns:a16="http://schemas.microsoft.com/office/drawing/2014/main" id="{883F5071-041E-6BC0-54FF-A2F7AAF11591}"/>
+                <a16:creationId xmlns:a16="http://schemas.microsoft.com/office/drawing/2014/main" id="{AC811356-8EA9-4E0E-955D-0BEF79EFCDD7}"/>
               </a:ext>
             </a:extLst>
           </p:cNvPr>
@@ -4143,7 +4143,7 @@
           <p:cNvPr id="4" name="Textfeld 3">
             <a:extLst>
               <a:ext uri="{FF2B5EF4-FFF2-40B4-BE49-F238E27FC236}">
-                <a16:creationId xmlns:a16="http://schemas.microsoft.com/office/drawing/2014/main" id="{1677E19A-0617-64EB-59C1-54E61C5FD7F7}"/>
+                <a16:creationId xmlns:a16="http://schemas.microsoft.com/office/drawing/2014/main" id="{8B0D2C68-50E2-E251-A497-70EE06BC84B9}"/>
               </a:ext>
             </a:extLst>
           </p:cNvPr>
@@ -4183,7 +4183,7 @@
           <p:cNvPr id="5" name="Textfeld 4">
             <a:extLst>
               <a:ext uri="{FF2B5EF4-FFF2-40B4-BE49-F238E27FC236}">
-                <a16:creationId xmlns:a16="http://schemas.microsoft.com/office/drawing/2014/main" id="{835AEDE3-14E4-AC2A-1ECF-1469F3B8B474}"/>
+                <a16:creationId xmlns:a16="http://schemas.microsoft.com/office/drawing/2014/main" id="{165C4749-754F-6D6E-3DA7-FE1A6E392F33}"/>
               </a:ext>
             </a:extLst>
           </p:cNvPr>
@@ -4261,7 +4261,7 @@
           <p:cNvPr id="6" name="Textfeld 5">
             <a:extLst>
               <a:ext uri="{FF2B5EF4-FFF2-40B4-BE49-F238E27FC236}">
-                <a16:creationId xmlns:a16="http://schemas.microsoft.com/office/drawing/2014/main" id="{F5872300-49A3-1D31-B27F-747E45D4F5F7}"/>
+                <a16:creationId xmlns:a16="http://schemas.microsoft.com/office/drawing/2014/main" id="{8F28F948-6844-C7D9-A065-50AB64020D1F}"/>
               </a:ext>
             </a:extLst>
           </p:cNvPr>
@@ -4299,7 +4299,7 @@
     </p:spTree>
     <p:extLst>
       <p:ext uri="{BB962C8B-B14F-4D97-AF65-F5344CB8AC3E}">
-        <p14:creationId xmlns:p14="http://schemas.microsoft.com/office/powerpoint/2010/main" val="2949731054"/>
+        <p14:creationId xmlns:p14="http://schemas.microsoft.com/office/powerpoint/2010/main" val="3775371590"/>
       </p:ext>
     </p:extLst>
   </p:cSld>
@@ -4339,7 +4339,7 @@
           <p:cNvPr id="2" name="Rechteck 1">
             <a:extLst>
               <a:ext uri="{FF2B5EF4-FFF2-40B4-BE49-F238E27FC236}">
-                <a16:creationId xmlns:a16="http://schemas.microsoft.com/office/drawing/2014/main" id="{F53C2B89-60F3-C2CE-BEC3-F3B27763392F}"/>
+                <a16:creationId xmlns:a16="http://schemas.microsoft.com/office/drawing/2014/main" id="{08DA7DF2-D6E1-E8FC-C466-427A68966EB3}"/>
               </a:ext>
             </a:extLst>
           </p:cNvPr>
@@ -4407,7 +4407,7 @@
           <p:cNvPr id="3" name="Rechteck 2">
             <a:extLst>
               <a:ext uri="{FF2B5EF4-FFF2-40B4-BE49-F238E27FC236}">
-                <a16:creationId xmlns:a16="http://schemas.microsoft.com/office/drawing/2014/main" id="{12B53D25-BDE4-705D-C1F0-426DE1807504}"/>
+                <a16:creationId xmlns:a16="http://schemas.microsoft.com/office/drawing/2014/main" id="{49CFDB78-6C54-4281-ECE5-5DB981C6B20B}"/>
               </a:ext>
             </a:extLst>
           </p:cNvPr>
@@ -4475,7 +4475,7 @@
           <p:cNvPr id="4" name="Textfeld 3">
             <a:extLst>
               <a:ext uri="{FF2B5EF4-FFF2-40B4-BE49-F238E27FC236}">
-                <a16:creationId xmlns:a16="http://schemas.microsoft.com/office/drawing/2014/main" id="{CE81CE77-F047-4F98-2DAB-C1FD527654DA}"/>
+                <a16:creationId xmlns:a16="http://schemas.microsoft.com/office/drawing/2014/main" id="{D8FB7D56-8022-704B-9DEF-82D61B778F66}"/>
               </a:ext>
             </a:extLst>
           </p:cNvPr>
@@ -4515,7 +4515,7 @@
           <p:cNvPr id="5" name="Textfeld 4">
             <a:extLst>
               <a:ext uri="{FF2B5EF4-FFF2-40B4-BE49-F238E27FC236}">
-                <a16:creationId xmlns:a16="http://schemas.microsoft.com/office/drawing/2014/main" id="{C5D364D5-C2DF-5D43-DBA9-065B46037F18}"/>
+                <a16:creationId xmlns:a16="http://schemas.microsoft.com/office/drawing/2014/main" id="{892590CA-D159-6DC0-74B1-B8D123F7A2CD}"/>
               </a:ext>
             </a:extLst>
           </p:cNvPr>
@@ -4593,7 +4593,7 @@
           <p:cNvPr id="6" name="Textfeld 5">
             <a:extLst>
               <a:ext uri="{FF2B5EF4-FFF2-40B4-BE49-F238E27FC236}">
-                <a16:creationId xmlns:a16="http://schemas.microsoft.com/office/drawing/2014/main" id="{F33D5BB1-6589-8252-AF9A-10BF89AA3F8A}"/>
+                <a16:creationId xmlns:a16="http://schemas.microsoft.com/office/drawing/2014/main" id="{0F32024A-64D9-4B23-5061-B15D96ABEAA0}"/>
               </a:ext>
             </a:extLst>
           </p:cNvPr>
@@ -4631,7 +4631,7 @@
     </p:spTree>
     <p:extLst>
       <p:ext uri="{BB962C8B-B14F-4D97-AF65-F5344CB8AC3E}">
-        <p14:creationId xmlns:p14="http://schemas.microsoft.com/office/powerpoint/2010/main" val="683007864"/>
+        <p14:creationId xmlns:p14="http://schemas.microsoft.com/office/powerpoint/2010/main" val="516067920"/>
       </p:ext>
     </p:extLst>
   </p:cSld>
@@ -4671,7 +4671,7 @@
           <p:cNvPr id="2" name="Rechteck 1">
             <a:extLst>
               <a:ext uri="{FF2B5EF4-FFF2-40B4-BE49-F238E27FC236}">
-                <a16:creationId xmlns:a16="http://schemas.microsoft.com/office/drawing/2014/main" id="{DD2D76B6-331F-918F-3F0D-251D75249DBE}"/>
+                <a16:creationId xmlns:a16="http://schemas.microsoft.com/office/drawing/2014/main" id="{AF9EA6ED-5A95-B742-7E2B-6BD017F5A300}"/>
               </a:ext>
             </a:extLst>
           </p:cNvPr>
@@ -4739,7 +4739,7 @@
           <p:cNvPr id="3" name="Rechteck 2">
             <a:extLst>
               <a:ext uri="{FF2B5EF4-FFF2-40B4-BE49-F238E27FC236}">
-                <a16:creationId xmlns:a16="http://schemas.microsoft.com/office/drawing/2014/main" id="{AAB5958B-4EC5-9E70-6E04-C8963008B1DA}"/>
+                <a16:creationId xmlns:a16="http://schemas.microsoft.com/office/drawing/2014/main" id="{6AD1EC79-BC7F-E26D-B2F6-AB16E73B31AF}"/>
               </a:ext>
             </a:extLst>
           </p:cNvPr>
@@ -4807,7 +4807,7 @@
           <p:cNvPr id="4" name="Textfeld 3">
             <a:extLst>
               <a:ext uri="{FF2B5EF4-FFF2-40B4-BE49-F238E27FC236}">
-                <a16:creationId xmlns:a16="http://schemas.microsoft.com/office/drawing/2014/main" id="{42B90585-0889-B3D8-D800-14639FEF5A65}"/>
+                <a16:creationId xmlns:a16="http://schemas.microsoft.com/office/drawing/2014/main" id="{2E7E8609-E43C-4C18-8E42-8DC3DD709473}"/>
               </a:ext>
             </a:extLst>
           </p:cNvPr>
@@ -4847,7 +4847,7 @@
           <p:cNvPr id="5" name="Textfeld 4">
             <a:extLst>
               <a:ext uri="{FF2B5EF4-FFF2-40B4-BE49-F238E27FC236}">
-                <a16:creationId xmlns:a16="http://schemas.microsoft.com/office/drawing/2014/main" id="{3012D649-ED80-CFF0-E053-BA7E07296DCA}"/>
+                <a16:creationId xmlns:a16="http://schemas.microsoft.com/office/drawing/2014/main" id="{B3304478-8CBF-2836-F7F5-4B2D87F3C343}"/>
               </a:ext>
             </a:extLst>
           </p:cNvPr>
@@ -4925,7 +4925,7 @@
           <p:cNvPr id="6" name="Textfeld 5">
             <a:extLst>
               <a:ext uri="{FF2B5EF4-FFF2-40B4-BE49-F238E27FC236}">
-                <a16:creationId xmlns:a16="http://schemas.microsoft.com/office/drawing/2014/main" id="{F322C39D-46C9-DB82-ECBB-D4D5AB38CF42}"/>
+                <a16:creationId xmlns:a16="http://schemas.microsoft.com/office/drawing/2014/main" id="{1214DFBD-437A-73C0-56EB-0D2EF47FAAC6}"/>
               </a:ext>
             </a:extLst>
           </p:cNvPr>
@@ -4963,7 +4963,7 @@
     </p:spTree>
     <p:extLst>
       <p:ext uri="{BB962C8B-B14F-4D97-AF65-F5344CB8AC3E}">
-        <p14:creationId xmlns:p14="http://schemas.microsoft.com/office/powerpoint/2010/main" val="694944209"/>
+        <p14:creationId xmlns:p14="http://schemas.microsoft.com/office/powerpoint/2010/main" val="984526346"/>
       </p:ext>
     </p:extLst>
   </p:cSld>
@@ -5003,7 +5003,7 @@
           <p:cNvPr id="2" name="Rechteck 1">
             <a:extLst>
               <a:ext uri="{FF2B5EF4-FFF2-40B4-BE49-F238E27FC236}">
-                <a16:creationId xmlns:a16="http://schemas.microsoft.com/office/drawing/2014/main" id="{05B3DD35-16C2-F95A-B99A-71D4ACC2B21F}"/>
+                <a16:creationId xmlns:a16="http://schemas.microsoft.com/office/drawing/2014/main" id="{9A2DC1C0-57C5-B925-7AAE-DE09B995908D}"/>
               </a:ext>
             </a:extLst>
           </p:cNvPr>
@@ -5071,7 +5071,7 @@
           <p:cNvPr id="3" name="Rechteck 2">
             <a:extLst>
               <a:ext uri="{FF2B5EF4-FFF2-40B4-BE49-F238E27FC236}">
-                <a16:creationId xmlns:a16="http://schemas.microsoft.com/office/drawing/2014/main" id="{F5D01DA6-8B63-0B2E-82C4-9B614CEB5E98}"/>
+                <a16:creationId xmlns:a16="http://schemas.microsoft.com/office/drawing/2014/main" id="{BBDF9B67-44D6-492F-34F5-02452FA9F5D1}"/>
               </a:ext>
             </a:extLst>
           </p:cNvPr>
@@ -5139,7 +5139,7 @@
           <p:cNvPr id="4" name="Textfeld 3">
             <a:extLst>
               <a:ext uri="{FF2B5EF4-FFF2-40B4-BE49-F238E27FC236}">
-                <a16:creationId xmlns:a16="http://schemas.microsoft.com/office/drawing/2014/main" id="{6F4FEA76-652F-8D51-AB36-8A69ADBF6238}"/>
+                <a16:creationId xmlns:a16="http://schemas.microsoft.com/office/drawing/2014/main" id="{11C4122C-4569-9AAE-FBCB-201C5C727769}"/>
               </a:ext>
             </a:extLst>
           </p:cNvPr>
@@ -5179,7 +5179,7 @@
           <p:cNvPr id="5" name="Textfeld 4">
             <a:extLst>
               <a:ext uri="{FF2B5EF4-FFF2-40B4-BE49-F238E27FC236}">
-                <a16:creationId xmlns:a16="http://schemas.microsoft.com/office/drawing/2014/main" id="{8904463D-8088-052C-B547-DEFD6AE96161}"/>
+                <a16:creationId xmlns:a16="http://schemas.microsoft.com/office/drawing/2014/main" id="{50BEC9D3-CF5E-8A0F-7EB9-51285B7AC3E8}"/>
               </a:ext>
             </a:extLst>
           </p:cNvPr>
@@ -5257,7 +5257,7 @@
           <p:cNvPr id="6" name="Textfeld 5">
             <a:extLst>
               <a:ext uri="{FF2B5EF4-FFF2-40B4-BE49-F238E27FC236}">
-                <a16:creationId xmlns:a16="http://schemas.microsoft.com/office/drawing/2014/main" id="{16E0A078-6F28-7C11-0B97-2AABF55D03E8}"/>
+                <a16:creationId xmlns:a16="http://schemas.microsoft.com/office/drawing/2014/main" id="{16072278-01B5-4597-B02F-C4D414754DEB}"/>
               </a:ext>
             </a:extLst>
           </p:cNvPr>
@@ -5295,7 +5295,7 @@
     </p:spTree>
     <p:extLst>
       <p:ext uri="{BB962C8B-B14F-4D97-AF65-F5344CB8AC3E}">
-        <p14:creationId xmlns:p14="http://schemas.microsoft.com/office/powerpoint/2010/main" val="2189173746"/>
+        <p14:creationId xmlns:p14="http://schemas.microsoft.com/office/powerpoint/2010/main" val="2208360641"/>
       </p:ext>
     </p:extLst>
   </p:cSld>
@@ -5335,7 +5335,7 @@
           <p:cNvPr id="2" name="Rechteck 1">
             <a:extLst>
               <a:ext uri="{FF2B5EF4-FFF2-40B4-BE49-F238E27FC236}">
-                <a16:creationId xmlns:a16="http://schemas.microsoft.com/office/drawing/2014/main" id="{F83E53C3-BADE-36C7-97EA-4C5969DAD1CA}"/>
+                <a16:creationId xmlns:a16="http://schemas.microsoft.com/office/drawing/2014/main" id="{6965727D-D104-C4B6-A39A-74923B196A82}"/>
               </a:ext>
             </a:extLst>
           </p:cNvPr>
@@ -5403,7 +5403,7 @@
           <p:cNvPr id="3" name="Rechteck 2">
             <a:extLst>
               <a:ext uri="{FF2B5EF4-FFF2-40B4-BE49-F238E27FC236}">
-                <a16:creationId xmlns:a16="http://schemas.microsoft.com/office/drawing/2014/main" id="{2A95C023-D3F6-D154-D9D7-5AB362E08420}"/>
+                <a16:creationId xmlns:a16="http://schemas.microsoft.com/office/drawing/2014/main" id="{10DC2ABA-E07E-2155-7A81-2DE69F67F694}"/>
               </a:ext>
             </a:extLst>
           </p:cNvPr>
@@ -5471,7 +5471,7 @@
           <p:cNvPr id="4" name="Textfeld 3">
             <a:extLst>
               <a:ext uri="{FF2B5EF4-FFF2-40B4-BE49-F238E27FC236}">
-                <a16:creationId xmlns:a16="http://schemas.microsoft.com/office/drawing/2014/main" id="{E5F2C4F1-C526-46A7-CA4A-1021C70649E6}"/>
+                <a16:creationId xmlns:a16="http://schemas.microsoft.com/office/drawing/2014/main" id="{40AC59B0-DF5E-3483-1D3D-744B11093D55}"/>
               </a:ext>
             </a:extLst>
           </p:cNvPr>
@@ -5511,7 +5511,7 @@
           <p:cNvPr id="5" name="Textfeld 4">
             <a:extLst>
               <a:ext uri="{FF2B5EF4-FFF2-40B4-BE49-F238E27FC236}">
-                <a16:creationId xmlns:a16="http://schemas.microsoft.com/office/drawing/2014/main" id="{EC3CF354-B597-58F7-D285-CF5CF98BF3FE}"/>
+                <a16:creationId xmlns:a16="http://schemas.microsoft.com/office/drawing/2014/main" id="{A29BCCDE-56B1-C3A8-7360-C04E007EAA6C}"/>
               </a:ext>
             </a:extLst>
           </p:cNvPr>
@@ -5589,7 +5589,7 @@
           <p:cNvPr id="6" name="Textfeld 5">
             <a:extLst>
               <a:ext uri="{FF2B5EF4-FFF2-40B4-BE49-F238E27FC236}">
-                <a16:creationId xmlns:a16="http://schemas.microsoft.com/office/drawing/2014/main" id="{96206A15-2D3B-59CB-CBC0-2FCD5927185B}"/>
+                <a16:creationId xmlns:a16="http://schemas.microsoft.com/office/drawing/2014/main" id="{AD57DB84-FAC7-2509-609A-29DB4A74AA4E}"/>
               </a:ext>
             </a:extLst>
           </p:cNvPr>
@@ -5627,7 +5627,7 @@
     </p:spTree>
     <p:extLst>
       <p:ext uri="{BB962C8B-B14F-4D97-AF65-F5344CB8AC3E}">
-        <p14:creationId xmlns:p14="http://schemas.microsoft.com/office/powerpoint/2010/main" val="1254817020"/>
+        <p14:creationId xmlns:p14="http://schemas.microsoft.com/office/powerpoint/2010/main" val="3181451388"/>
       </p:ext>
     </p:extLst>
   </p:cSld>
@@ -5667,7 +5667,7 @@
           <p:cNvPr id="2" name="Rechteck 1">
             <a:extLst>
               <a:ext uri="{FF2B5EF4-FFF2-40B4-BE49-F238E27FC236}">
-                <a16:creationId xmlns:a16="http://schemas.microsoft.com/office/drawing/2014/main" id="{1E57D9DA-CF81-A532-B800-4214F4514E31}"/>
+                <a16:creationId xmlns:a16="http://schemas.microsoft.com/office/drawing/2014/main" id="{0060B02E-1B84-E3A0-1F51-DDF5038FE643}"/>
               </a:ext>
             </a:extLst>
           </p:cNvPr>
@@ -5735,7 +5735,7 @@
           <p:cNvPr id="3" name="Rechteck 2">
             <a:extLst>
               <a:ext uri="{FF2B5EF4-FFF2-40B4-BE49-F238E27FC236}">
-                <a16:creationId xmlns:a16="http://schemas.microsoft.com/office/drawing/2014/main" id="{F3128DCA-E57F-44F9-9082-72B6F2233AC7}"/>
+                <a16:creationId xmlns:a16="http://schemas.microsoft.com/office/drawing/2014/main" id="{3413D600-715B-34C4-8928-3205F045CFA7}"/>
               </a:ext>
             </a:extLst>
           </p:cNvPr>
@@ -5803,7 +5803,7 @@
           <p:cNvPr id="4" name="Textfeld 3">
             <a:extLst>
               <a:ext uri="{FF2B5EF4-FFF2-40B4-BE49-F238E27FC236}">
-                <a16:creationId xmlns:a16="http://schemas.microsoft.com/office/drawing/2014/main" id="{6510C5BF-6BE1-20B3-B545-4BD24E07BAF9}"/>
+                <a16:creationId xmlns:a16="http://schemas.microsoft.com/office/drawing/2014/main" id="{48BA4040-12F5-EF0F-A893-B749FD29530A}"/>
               </a:ext>
             </a:extLst>
           </p:cNvPr>
@@ -5843,7 +5843,7 @@
           <p:cNvPr id="5" name="Textfeld 4">
             <a:extLst>
               <a:ext uri="{FF2B5EF4-FFF2-40B4-BE49-F238E27FC236}">
-                <a16:creationId xmlns:a16="http://schemas.microsoft.com/office/drawing/2014/main" id="{AE44CE41-B31F-F294-27C1-0070E2929236}"/>
+                <a16:creationId xmlns:a16="http://schemas.microsoft.com/office/drawing/2014/main" id="{05EBF3B6-B368-3403-AECC-6F943558FA7E}"/>
               </a:ext>
             </a:extLst>
           </p:cNvPr>
@@ -5921,7 +5921,7 @@
           <p:cNvPr id="6" name="Textfeld 5">
             <a:extLst>
               <a:ext uri="{FF2B5EF4-FFF2-40B4-BE49-F238E27FC236}">
-                <a16:creationId xmlns:a16="http://schemas.microsoft.com/office/drawing/2014/main" id="{0CDFFA7D-4952-8E07-8379-09A6253954D2}"/>
+                <a16:creationId xmlns:a16="http://schemas.microsoft.com/office/drawing/2014/main" id="{A445B823-F430-1B93-E031-EA4055C38AEF}"/>
               </a:ext>
             </a:extLst>
           </p:cNvPr>
@@ -5959,7 +5959,7 @@
     </p:spTree>
     <p:extLst>
       <p:ext uri="{BB962C8B-B14F-4D97-AF65-F5344CB8AC3E}">
-        <p14:creationId xmlns:p14="http://schemas.microsoft.com/office/powerpoint/2010/main" val="2973424641"/>
+        <p14:creationId xmlns:p14="http://schemas.microsoft.com/office/powerpoint/2010/main" val="702181463"/>
       </p:ext>
     </p:extLst>
   </p:cSld>
@@ -5999,7 +5999,7 @@
           <p:cNvPr id="2" name="Rechteck 1">
             <a:extLst>
               <a:ext uri="{FF2B5EF4-FFF2-40B4-BE49-F238E27FC236}">
-                <a16:creationId xmlns:a16="http://schemas.microsoft.com/office/drawing/2014/main" id="{E2EC3A80-8482-5E9D-A87F-B593F22A3D5C}"/>
+                <a16:creationId xmlns:a16="http://schemas.microsoft.com/office/drawing/2014/main" id="{F38666E8-F0BB-F5D0-E303-083C47DA91DD}"/>
               </a:ext>
             </a:extLst>
           </p:cNvPr>
@@ -6067,7 +6067,7 @@
           <p:cNvPr id="3" name="Rechteck 2">
             <a:extLst>
               <a:ext uri="{FF2B5EF4-FFF2-40B4-BE49-F238E27FC236}">
-                <a16:creationId xmlns:a16="http://schemas.microsoft.com/office/drawing/2014/main" id="{981DDFE2-341D-BF0B-1663-E0D2C1EA93F6}"/>
+                <a16:creationId xmlns:a16="http://schemas.microsoft.com/office/drawing/2014/main" id="{EF94DA55-5E5D-4161-2850-58FC183E496F}"/>
               </a:ext>
             </a:extLst>
           </p:cNvPr>
@@ -6135,7 +6135,7 @@
           <p:cNvPr id="4" name="Textfeld 3">
             <a:extLst>
               <a:ext uri="{FF2B5EF4-FFF2-40B4-BE49-F238E27FC236}">
-                <a16:creationId xmlns:a16="http://schemas.microsoft.com/office/drawing/2014/main" id="{D7ADE1E3-5355-3473-4A7B-DA5CE059350C}"/>
+                <a16:creationId xmlns:a16="http://schemas.microsoft.com/office/drawing/2014/main" id="{0A140A97-383B-5D59-17C4-FE15FD05BBA2}"/>
               </a:ext>
             </a:extLst>
           </p:cNvPr>
@@ -6175,7 +6175,7 @@
           <p:cNvPr id="5" name="Textfeld 4">
             <a:extLst>
               <a:ext uri="{FF2B5EF4-FFF2-40B4-BE49-F238E27FC236}">
-                <a16:creationId xmlns:a16="http://schemas.microsoft.com/office/drawing/2014/main" id="{4765296D-5B12-97DF-814C-F43B5F5CA66E}"/>
+                <a16:creationId xmlns:a16="http://schemas.microsoft.com/office/drawing/2014/main" id="{E3B785B0-681C-9284-F482-74FB936254EF}"/>
               </a:ext>
             </a:extLst>
           </p:cNvPr>
@@ -6253,7 +6253,7 @@
           <p:cNvPr id="6" name="Textfeld 5">
             <a:extLst>
               <a:ext uri="{FF2B5EF4-FFF2-40B4-BE49-F238E27FC236}">
-                <a16:creationId xmlns:a16="http://schemas.microsoft.com/office/drawing/2014/main" id="{283F6149-3328-79E1-5622-9D66E053EA84}"/>
+                <a16:creationId xmlns:a16="http://schemas.microsoft.com/office/drawing/2014/main" id="{A4BD6908-A236-7123-AAC9-7B737EACC258}"/>
               </a:ext>
             </a:extLst>
           </p:cNvPr>
@@ -6291,7 +6291,7 @@
     </p:spTree>
     <p:extLst>
       <p:ext uri="{BB962C8B-B14F-4D97-AF65-F5344CB8AC3E}">
-        <p14:creationId xmlns:p14="http://schemas.microsoft.com/office/powerpoint/2010/main" val="1020400736"/>
+        <p14:creationId xmlns:p14="http://schemas.microsoft.com/office/powerpoint/2010/main" val="2988176369"/>
       </p:ext>
     </p:extLst>
   </p:cSld>
@@ -6331,7 +6331,7 @@
           <p:cNvPr id="2" name="Rechteck 1">
             <a:extLst>
               <a:ext uri="{FF2B5EF4-FFF2-40B4-BE49-F238E27FC236}">
-                <a16:creationId xmlns:a16="http://schemas.microsoft.com/office/drawing/2014/main" id="{E5EA22A7-87E9-4BBF-0E42-65D9945F9E50}"/>
+                <a16:creationId xmlns:a16="http://schemas.microsoft.com/office/drawing/2014/main" id="{950C8F7B-3C40-CE42-6640-AB7C7EB8059A}"/>
               </a:ext>
             </a:extLst>
           </p:cNvPr>
@@ -6399,7 +6399,7 @@
           <p:cNvPr id="3" name="Rechteck 2">
             <a:extLst>
               <a:ext uri="{FF2B5EF4-FFF2-40B4-BE49-F238E27FC236}">
-                <a16:creationId xmlns:a16="http://schemas.microsoft.com/office/drawing/2014/main" id="{92937CB7-C9B8-D115-2C80-9E6BF5617985}"/>
+                <a16:creationId xmlns:a16="http://schemas.microsoft.com/office/drawing/2014/main" id="{A11233E4-6B44-52F7-4F5F-AC035D66EEB4}"/>
               </a:ext>
             </a:extLst>
           </p:cNvPr>
@@ -6467,7 +6467,7 @@
           <p:cNvPr id="4" name="Textfeld 3">
             <a:extLst>
               <a:ext uri="{FF2B5EF4-FFF2-40B4-BE49-F238E27FC236}">
-                <a16:creationId xmlns:a16="http://schemas.microsoft.com/office/drawing/2014/main" id="{5AD2057C-B2A7-10FB-541A-767C4CD83DAE}"/>
+                <a16:creationId xmlns:a16="http://schemas.microsoft.com/office/drawing/2014/main" id="{875966BB-8759-4FE1-5CD3-6A438EC51DBC}"/>
               </a:ext>
             </a:extLst>
           </p:cNvPr>
@@ -6507,7 +6507,7 @@
           <p:cNvPr id="5" name="Textfeld 4">
             <a:extLst>
               <a:ext uri="{FF2B5EF4-FFF2-40B4-BE49-F238E27FC236}">
-                <a16:creationId xmlns:a16="http://schemas.microsoft.com/office/drawing/2014/main" id="{3B7B52ED-8B26-4001-F22B-DAE485711FB0}"/>
+                <a16:creationId xmlns:a16="http://schemas.microsoft.com/office/drawing/2014/main" id="{3645D7BC-B90A-4070-7EA4-40F03BA1AF19}"/>
               </a:ext>
             </a:extLst>
           </p:cNvPr>
@@ -6517,7 +6517,7 @@
         <p:spPr>
           <a:xfrm>
             <a:off x="889000" y="1854200"/>
-            <a:ext cx="10160000" cy="2544286"/>
+            <a:ext cx="10160000" cy="2836674"/>
           </a:xfrm>
           <a:prstGeom prst="rect">
             <a:avLst/>
@@ -6537,7 +6537,7 @@
                 </a:solidFill>
                 <a:latin typeface="Arial" panose="020B0604020202020204" pitchFamily="34" charset="0"/>
               </a:rPr>
-              <a:t>• Geplanter Projekt-Monitor:</a:t>
+              <a:t>• Projekt-Monitor:</a:t>
             </a:r>
           </a:p>
           <a:p>
@@ -6556,7 +6556,7 @@
                 </a:solidFill>
                 <a:latin typeface="Arial" panose="020B0604020202020204" pitchFamily="34" charset="0"/>
               </a:rPr>
-              <a:t>• https://sari-raslan.github.io/universal-arranger-os/jobcenter/</a:t>
+              <a:t>• Der Projekt-Monitor ist vorgesehen und wird nach technischer Freigabe separat nachgereicht.</a:t>
             </a:r>
           </a:p>
           <a:p>
@@ -6594,7 +6594,7 @@
                 </a:solidFill>
                 <a:latin typeface="Arial" panose="020B0604020202020204" pitchFamily="34" charset="0"/>
               </a:rPr>
-              <a:t>• Der Link ist derzeit noch nicht öffentlich aktiv. Er wird erst nach ausdrücklicher Upload-/Deploy-Freigabe aktiviert. Es wurde kein Push, kein Upload und kein Deploy freigegeben.</a:t>
+              <a:t>• Derzeit wird kein öffentlicher Projektlink als aktiver Nachweis verwendet. Es wurde kein Push, kein Upload und kein Deploy freigegeben.</a:t>
             </a:r>
           </a:p>
         </p:txBody>
@@ -6604,7 +6604,7 @@
           <p:cNvPr id="6" name="Textfeld 5">
             <a:extLst>
               <a:ext uri="{FF2B5EF4-FFF2-40B4-BE49-F238E27FC236}">
-                <a16:creationId xmlns:a16="http://schemas.microsoft.com/office/drawing/2014/main" id="{1BE33CD2-6F41-5E23-7E62-8DE390D0B621}"/>
+                <a16:creationId xmlns:a16="http://schemas.microsoft.com/office/drawing/2014/main" id="{82AD4B49-A47A-E7AF-8C84-2132EFE57D98}"/>
               </a:ext>
             </a:extLst>
           </p:cNvPr>
@@ -6642,7 +6642,7 @@
     </p:spTree>
     <p:extLst>
       <p:ext uri="{BB962C8B-B14F-4D97-AF65-F5344CB8AC3E}">
-        <p14:creationId xmlns:p14="http://schemas.microsoft.com/office/powerpoint/2010/main" val="1991514361"/>
+        <p14:creationId xmlns:p14="http://schemas.microsoft.com/office/powerpoint/2010/main" val="971877251"/>
       </p:ext>
     </p:extLst>
   </p:cSld>

</xml_diff>